<commit_message>
docs: add fixed RBAC roles and scoped authorization to MVP design
</commit_message>
<xml_diff>
--- a/docs/presentations/aam-project-overview-mvp.pptx
+++ b/docs/presentations/aam-project-overview-mvp.pptx
@@ -2,17 +2,17 @@
 <file path=ppt/presentation.xml><?xml version="1.0" encoding="utf-8"?>
 <p:presentation xmlns:p="http://schemas.openxmlformats.org/presentationml/2006/main">
   <p:sldMasterIdLst>
-    <p:sldMasterId xmlns:r="http://schemas.openxmlformats.org/officeDocument/2006/relationships" id="2147483648" r:id="Re29e546e70e44288"/>
+    <p:sldMasterId xmlns:r="http://schemas.openxmlformats.org/officeDocument/2006/relationships" id="2147483648" r:id="R9857ea8aca5c4aa6"/>
   </p:sldMasterIdLst>
   <p:notesMasterIdLst>
-    <p:notesMasterId xmlns:r="http://schemas.openxmlformats.org/officeDocument/2006/relationships" r:id="R263e90edf6004def"/>
+    <p:notesMasterId xmlns:r="http://schemas.openxmlformats.org/officeDocument/2006/relationships" r:id="R507de0c321374af1"/>
   </p:notesMasterIdLst>
   <p:sldIdLst>
-    <p:sldId xmlns:r="http://schemas.openxmlformats.org/officeDocument/2006/relationships" id="256" r:id="R44f965a4f50842aa"/>
-    <p:sldId xmlns:r="http://schemas.openxmlformats.org/officeDocument/2006/relationships" id="257" r:id="R62cb6b3946e74344"/>
-    <p:sldId xmlns:r="http://schemas.openxmlformats.org/officeDocument/2006/relationships" id="258" r:id="R30e626d436434f2e"/>
-    <p:sldId xmlns:r="http://schemas.openxmlformats.org/officeDocument/2006/relationships" id="259" r:id="Rbef46324dbf54f6f"/>
-    <p:sldId xmlns:r="http://schemas.openxmlformats.org/officeDocument/2006/relationships" id="260" r:id="R193ae01034374afc"/>
+    <p:sldId xmlns:r="http://schemas.openxmlformats.org/officeDocument/2006/relationships" id="256" r:id="R71f7e099b0884fac"/>
+    <p:sldId xmlns:r="http://schemas.openxmlformats.org/officeDocument/2006/relationships" id="257" r:id="R8a4508d8bccf4540"/>
+    <p:sldId xmlns:r="http://schemas.openxmlformats.org/officeDocument/2006/relationships" id="258" r:id="Rbdfd9f4fcbfa4ecc"/>
+    <p:sldId xmlns:r="http://schemas.openxmlformats.org/officeDocument/2006/relationships" id="259" r:id="Rec95dd2403824d02"/>
+    <p:sldId xmlns:r="http://schemas.openxmlformats.org/officeDocument/2006/relationships" id="260" r:id="R47e1fc36585c48b4"/>
   </p:sldIdLst>
   <p:sldSz cx="15240000" cy="8572500"/>
   <p:notesSz cx="6858000" cy="9144000"/>
@@ -446,7 +446,7 @@
           <a:lstStyle xmlns:a="http://schemas.openxmlformats.org/drawingml/2006/main"/>
           <a:p xmlns:a="http://schemas.openxmlformats.org/drawingml/2006/main">
             <a:r>
-              <a:t>Background and scope: Aaron's project brief in this conversation. AAM organizes email-derived customer work into reviewed Cases and Open Items. Local and Regional AMs retain business decisions and approval before sending. Launch Case templates and detailed acceptance criteria require FSD signoff. No quantified productivity benefit has been assumed.</a:t>
+              <a:t>Background and scope: Aaron's project brief and accepted RBAC decision in this conversation. AAM organizes email-derived customer work into reviewed Cases and Open Items. Fixed MVP roles: Local AM, Regional AM, Group Director and AAM Admin, with business-group/region/customer data scopes. Okta owns role-group memberships. Java enforces action permissions AND applicable resource scopes. AAM Admin is an application role, not an Okta admin role, and does not automatically grant all mailbox access. Director can define authorized Playbooks and view scoped overall Case status. Detailed permissions require FSD signoff. No quantified productivity benefit has been assumed.</a:t>
             </a:r>
           </a:p>
         </p:txBody>
@@ -519,6 +519,16 @@
               <a:t>Sources: https://github.com/realAaronWu/aam/blob/4266cc34b7c7639256ebb993810caeea34608a82/docs/architecture/diagrams/aam-java-services-ha-architecture.drawio and https://github.com/realAaronWu/aam/blob/4266cc34b7c7639256ebb993810caeea34608a82/docs/planning/AAM_Delivery_Plan_FSD_SIT_UAT_to_2027-03-05_EN.xlsx . One backend deployment has identical replicas that handle HTTP and async work. Recovery can repeat AI computation while fenced database commits and business idempotency prevent duplicate effects. Graph send outcomes can be uncertain and require reconciliation, not blind retries. These are design controls, not an implemented production qualification.</a:t>
             </a:r>
           </a:p>
+          <a:p xmlns:a="http://schemas.openxmlformats.org/drawingml/2006/main">
+            <a:r>
+              <a:t/>
+            </a:r>
+          </a:p>
+          <a:p xmlns:a="http://schemas.openxmlformats.org/drawingml/2006/main">
+            <a:r>
+              <a:t>RBAC addition approved by Aaron: MVP has fixed Local AM, Regional AM, Group Director and AAM Admin roles. Okta is authoritative for role-group membership. Java maps these groups to action permissions and enforces them together with applicable business-group, region and customer scopes. PostgreSQL owns business scope bindings and audit, not a second editable role-membership authority. Default deny applies. Local AM access follows assigned customers; Regional AM access follows authorized regions; Directors can define authorized Playbooks and see authorized group-wide Case status. AAM Admin can manage Playbooks/configuration without automatic unrestricted access to raw mail. Dashboard summaries, list/detail/search/export and AI context must respect scope. Java rechecks current authorization for user-initiated jobs and before sensitive effects; ingestion uses explicit mailbox/service grants. AM approval before sending remains required. Entra/Graph mailbox permissions remain an independent limit. Scope control is cross-cutting, not another business step or service. Confirm Okta authorization-server licensing and session/token integration during implementation. Sources for capability boundaries: https://developer.okta.com/docs/guides/customize-tokens-groups-claim/ , https://developer.okta.com/docs/concepts/auth-servers/ , https://docs.spring.io/spring-security/reference/servlet/oauth2/resource-server/jwt.html . The referenced GitHub diagrams are the baseline before this accepted RBAC addition.</a:t>
+            </a:r>
+          </a:p>
         </p:txBody>
       </p:sp>
       <p:sp>
@@ -587,6 +597,16 @@
           <a:p xmlns:a="http://schemas.openxmlformats.org/drawingml/2006/main">
             <a:r>
               <a:t>Source: https://github.com/realAaronWu/aam/blob/4266cc34b7c7639256ebb993810caeea34608a82/docs/architecture/diagrams/aam-logical-component-flow.drawio . Reflowed to a widescreen, editable PowerPoint component diagram. Preserves numbered core path 01-06, reply branch 04.1-04.3 and Playbook management 07-08. Green arrows show the business path, purple supplies Playbook rules, orange starts AI draft generation, blue represents human review and cyan sends through Graph. AI also supports intent, summaries and Playbook authoring. Progress updates change Case/Open Item state. The original draw.io remains the detailed source.</a:t>
+            </a:r>
+          </a:p>
+          <a:p xmlns:a="http://schemas.openxmlformats.org/drawingml/2006/main">
+            <a:r>
+              <a:t/>
+            </a:r>
+          </a:p>
+          <a:p xmlns:a="http://schemas.openxmlformats.org/drawingml/2006/main">
+            <a:r>
+              <a:t>RBAC addition approved by Aaron: MVP has fixed Local AM, Regional AM, Group Director and AAM Admin roles. Okta is authoritative for role-group membership. Java maps these groups to action permissions and enforces them together with applicable business-group, region and customer scopes. PostgreSQL owns business scope bindings and audit, not a second editable role-membership authority. Default deny applies. Local AM access follows assigned customers; Regional AM access follows authorized regions; Directors can define authorized Playbooks and see authorized group-wide Case status. AAM Admin can manage Playbooks/configuration without automatic unrestricted access to raw mail. Dashboard summaries, list/detail/search/export and AI context must respect scope. Java rechecks current authorization for user-initiated jobs and before sensitive effects; ingestion uses explicit mailbox/service grants. AM approval before sending remains required. Entra/Graph mailbox permissions remain an independent limit. Scope control is cross-cutting, not another business step or service. Confirm Okta authorization-server licensing and session/token integration during implementation. Sources for capability boundaries: https://developer.okta.com/docs/guides/customize-tokens-groups-claim/ , https://developer.okta.com/docs/concepts/auth-servers/ , https://docs.spring.io/spring-security/reference/servlet/oauth2/resource-server/jwt.html . The referenced GitHub diagrams are the baseline before this accepted RBAC addition.</a:t>
             </a:r>
           </a:p>
         </p:txBody>
@@ -659,6 +679,16 @@
               <a:t>Source: https://github.com/realAaronWu/aam/blob/4266cc34b7c7639256ebb993810caeea34608a82/docs/architecture/diagrams/aam-java-services-ha-architecture.drawio . Widescreen reflow preserves the current single-Java-backend architecture and its identity, mail, AI, storage and observability integrations. AM is a user role, not a service. Portal/BFF and Java backend are separate deployments. Every Java replica runs HTTP and bounded async execution; logical modules are not separate microservices. PostgreSQL uses a primary/standby and one write endpoint. Durable job claims, lease renewal, fencing, request idempotency and unique business keys protect recovery. Database HA protection depends on the selected replication/failover configuration. Azure Blob remains in the current source diagram for file artifacts. Okta and Entra arrows describe integration dependencies, not the full OAuth redirect sequence. GitHub Actions is delivery tooling described on slide 2, not a runtime request dependency.</a:t>
             </a:r>
           </a:p>
+          <a:p xmlns:a="http://schemas.openxmlformats.org/drawingml/2006/main">
+            <a:r>
+              <a:t/>
+            </a:r>
+          </a:p>
+          <a:p xmlns:a="http://schemas.openxmlformats.org/drawingml/2006/main">
+            <a:r>
+              <a:t>RBAC addition approved by Aaron: MVP has fixed Local AM, Regional AM, Group Director and AAM Admin roles. Okta is authoritative for role-group membership. Java maps these groups to action permissions and enforces them together with applicable business-group, region and customer scopes. PostgreSQL owns business scope bindings and audit, not a second editable role-membership authority. Default deny applies. Local AM access follows assigned customers; Regional AM access follows authorized regions; Directors can define authorized Playbooks and see authorized group-wide Case status. AAM Admin can manage Playbooks/configuration without automatic unrestricted access to raw mail. Dashboard summaries, list/detail/search/export and AI context must respect scope. Java rechecks current authorization for user-initiated jobs and before sensitive effects; ingestion uses explicit mailbox/service grants. AM approval before sending remains required. Entra/Graph mailbox permissions remain an independent limit. Scope control is cross-cutting, not another business step or service. Confirm Okta authorization-server licensing and session/token integration during implementation. Sources for capability boundaries: https://developer.okta.com/docs/guides/customize-tokens-groups-claim/ , https://developer.okta.com/docs/concepts/auth-servers/ , https://docs.spring.io/spring-security/reference/servlet/oauth2/resource-server/jwt.html . The referenced GitHub diagrams are the baseline before this accepted RBAC addition.</a:t>
+            </a:r>
+          </a:p>
         </p:txBody>
       </p:sp>
       <p:sp>
@@ -773,7 +803,7 @@
           <p:cNvPr id="3" name="Title">
             <a:extLst xmlns:a="http://schemas.openxmlformats.org/drawingml/2006/main">
               <a:ext uri="{FF2B5EF4-FFF2-40B4-BE49-F238E27FC236}">
-                <a16:creationId xmlns:a16="http://schemas.microsoft.com/office/drawing/2014/main" id="{37C6E1CC-2A0F-44C6-A84D-822B3BF42266}"/>
+                <a16:creationId xmlns:a16="http://schemas.microsoft.com/office/drawing/2014/main" id="{2EAB71E2-4C69-4827-99D6-042C1459F7CA}"/>
               </a:ext>
             </a:extLst>
           </p:cNvPr>
@@ -930,7 +960,7 @@
           <p:cNvPr id="2" name="Subtitle">
             <a:extLst xmlns:a="http://schemas.openxmlformats.org/drawingml/2006/main">
               <a:ext uri="{FF2B5EF4-FFF2-40B4-BE49-F238E27FC236}">
-                <a16:creationId xmlns:a16="http://schemas.microsoft.com/office/drawing/2014/main" id="{D1ACF15B-030D-4D3F-80F5-A1FBAEFBFBF4}"/>
+                <a16:creationId xmlns:a16="http://schemas.microsoft.com/office/drawing/2014/main" id="{9C4929A0-C555-445F-9AC1-65C9BB53908D}"/>
               </a:ext>
             </a:extLst>
           </p:cNvPr>
@@ -1104,7 +1134,7 @@
           <p:cNvPr id="2" name="Section title">
             <a:extLst xmlns:a="http://schemas.openxmlformats.org/drawingml/2006/main">
               <a:ext uri="{FF2B5EF4-FFF2-40B4-BE49-F238E27FC236}">
-                <a16:creationId xmlns:a16="http://schemas.microsoft.com/office/drawing/2014/main" id="{10A4F447-2DD5-40C6-9767-0C47BB52BAEC}"/>
+                <a16:creationId xmlns:a16="http://schemas.microsoft.com/office/drawing/2014/main" id="{9B29D607-E2E0-4724-A90C-3AD18BAEBF35}"/>
               </a:ext>
             </a:extLst>
           </p:cNvPr>
@@ -1278,7 +1308,7 @@
           <p:cNvPr id="3" name="Title">
             <a:extLst xmlns:a="http://schemas.openxmlformats.org/drawingml/2006/main">
               <a:ext uri="{FF2B5EF4-FFF2-40B4-BE49-F238E27FC236}">
-                <a16:creationId xmlns:a16="http://schemas.microsoft.com/office/drawing/2014/main" id="{05C87610-ABFC-4730-A307-0936D9D3942C}"/>
+                <a16:creationId xmlns:a16="http://schemas.microsoft.com/office/drawing/2014/main" id="{D8BDD192-9C9F-4D2A-B051-3DAA955FD199}"/>
               </a:ext>
             </a:extLst>
           </p:cNvPr>
@@ -1435,7 +1465,7 @@
           <p:cNvPr id="2" name="Body">
             <a:extLst xmlns:a="http://schemas.openxmlformats.org/drawingml/2006/main">
               <a:ext uri="{FF2B5EF4-FFF2-40B4-BE49-F238E27FC236}">
-                <a16:creationId xmlns:a16="http://schemas.microsoft.com/office/drawing/2014/main" id="{7F2568AB-BB4E-4A4D-87F0-D1906BB84CBD}"/>
+                <a16:creationId xmlns:a16="http://schemas.microsoft.com/office/drawing/2014/main" id="{3A4F6BDE-1E9B-4F62-8CB0-1C0029FA07DD}"/>
               </a:ext>
             </a:extLst>
           </p:cNvPr>
@@ -1609,7 +1639,7 @@
           <p:cNvPr id="4" name="Title">
             <a:extLst xmlns:a="http://schemas.openxmlformats.org/drawingml/2006/main">
               <a:ext uri="{FF2B5EF4-FFF2-40B4-BE49-F238E27FC236}">
-                <a16:creationId xmlns:a16="http://schemas.microsoft.com/office/drawing/2014/main" id="{E446033F-5628-4F06-814F-60954B4CA357}"/>
+                <a16:creationId xmlns:a16="http://schemas.microsoft.com/office/drawing/2014/main" id="{9833ABE0-5CBA-4C52-AD71-F9D1C78DCEC8}"/>
               </a:ext>
             </a:extLst>
           </p:cNvPr>
@@ -1766,7 +1796,7 @@
           <p:cNvPr id="2" name="Left column">
             <a:extLst xmlns:a="http://schemas.openxmlformats.org/drawingml/2006/main">
               <a:ext uri="{FF2B5EF4-FFF2-40B4-BE49-F238E27FC236}">
-                <a16:creationId xmlns:a16="http://schemas.microsoft.com/office/drawing/2014/main" id="{7E7A13F9-02E7-4A9F-B4B4-D28B4AAFB244}"/>
+                <a16:creationId xmlns:a16="http://schemas.microsoft.com/office/drawing/2014/main" id="{3FEFD53C-08CD-4EE5-8863-502CF2B4AA84}"/>
               </a:ext>
             </a:extLst>
           </p:cNvPr>
@@ -1923,7 +1953,7 @@
           <p:cNvPr id="3" name="Right column">
             <a:extLst xmlns:a="http://schemas.openxmlformats.org/drawingml/2006/main">
               <a:ext uri="{FF2B5EF4-FFF2-40B4-BE49-F238E27FC236}">
-                <a16:creationId xmlns:a16="http://schemas.microsoft.com/office/drawing/2014/main" id="{880D5558-2152-44BC-B0B5-3DB81AE73E40}"/>
+                <a16:creationId xmlns:a16="http://schemas.microsoft.com/office/drawing/2014/main" id="{025BDB1A-78BB-4073-BB40-B2FD65A595BF}"/>
               </a:ext>
             </a:extLst>
           </p:cNvPr>
@@ -2097,7 +2127,7 @@
           <p:cNvPr id="3" name="Title">
             <a:extLst xmlns:a="http://schemas.openxmlformats.org/drawingml/2006/main">
               <a:ext uri="{FF2B5EF4-FFF2-40B4-BE49-F238E27FC236}">
-                <a16:creationId xmlns:a16="http://schemas.microsoft.com/office/drawing/2014/main" id="{EC37AB00-3D64-440F-8476-3F523C91777C}"/>
+                <a16:creationId xmlns:a16="http://schemas.microsoft.com/office/drawing/2014/main" id="{901E7AF1-EF37-4C17-A5E6-B79D080B6C2E}"/>
               </a:ext>
             </a:extLst>
           </p:cNvPr>
@@ -2254,7 +2284,7 @@
           <p:cNvPr id="2" name="Left column">
             <a:extLst xmlns:a="http://schemas.openxmlformats.org/drawingml/2006/main">
               <a:ext uri="{FF2B5EF4-FFF2-40B4-BE49-F238E27FC236}">
-                <a16:creationId xmlns:a16="http://schemas.microsoft.com/office/drawing/2014/main" id="{19F39D8C-8681-4347-A7D8-6DD5EFBA2E31}"/>
+                <a16:creationId xmlns:a16="http://schemas.microsoft.com/office/drawing/2014/main" id="{177E0118-B374-4793-81DF-E31906C3C9AC}"/>
               </a:ext>
             </a:extLst>
           </p:cNvPr>
@@ -2449,12 +2479,12 @@
   </p:cSld>
   <p:clrMap bg1="lt1" tx1="dk1" bg2="lt2" tx2="dk2" accent1="accent1" accent2="accent2" accent3="accent3" accent4="accent4" accent5="accent5" accent6="accent6" hlink="hlink" folHlink="folHlink"/>
   <p:sldLayoutIdLst>
-    <p:sldLayoutId xmlns:r="http://schemas.openxmlformats.org/officeDocument/2006/relationships" id="2147483649" r:id="R10e6c9a049834eb9"/>
-    <p:sldLayoutId xmlns:r="http://schemas.openxmlformats.org/officeDocument/2006/relationships" id="2147483650" r:id="R39e6e1fa855e46a1"/>
-    <p:sldLayoutId xmlns:r="http://schemas.openxmlformats.org/officeDocument/2006/relationships" id="2147483651" r:id="Rb7d3c851dbf24aa3"/>
-    <p:sldLayoutId xmlns:r="http://schemas.openxmlformats.org/officeDocument/2006/relationships" id="2147483652" r:id="R11f68318bafd4e44"/>
-    <p:sldLayoutId xmlns:r="http://schemas.openxmlformats.org/officeDocument/2006/relationships" id="2147483653" r:id="R0582da184e324e37"/>
-    <p:sldLayoutId xmlns:r="http://schemas.openxmlformats.org/officeDocument/2006/relationships" id="2147483654" r:id="Rbf6ff36897544a91"/>
+    <p:sldLayoutId xmlns:r="http://schemas.openxmlformats.org/officeDocument/2006/relationships" id="2147483649" r:id="Rdd8b7957e3274f08"/>
+    <p:sldLayoutId xmlns:r="http://schemas.openxmlformats.org/officeDocument/2006/relationships" id="2147483650" r:id="R9d99442d94b543d6"/>
+    <p:sldLayoutId xmlns:r="http://schemas.openxmlformats.org/officeDocument/2006/relationships" id="2147483651" r:id="Rd98a3f8f1fac4b83"/>
+    <p:sldLayoutId xmlns:r="http://schemas.openxmlformats.org/officeDocument/2006/relationships" id="2147483652" r:id="Rdf73bb4515b74e2c"/>
+    <p:sldLayoutId xmlns:r="http://schemas.openxmlformats.org/officeDocument/2006/relationships" id="2147483653" r:id="R912fdbb3dd3e4542"/>
+    <p:sldLayoutId xmlns:r="http://schemas.openxmlformats.org/officeDocument/2006/relationships" id="2147483654" r:id="R0a654deb9e554b19"/>
   </p:sldLayoutIdLst>
   <p:txStyles>
     <p:titleStyle>
@@ -3002,10 +3032,10 @@
       </p:grpSpPr>
       <p:sp>
         <p:nvSpPr>
-          <p:cNvPr id="21" name="title">
+          <p:cNvPr id="23" name="title">
             <a:extLst xmlns:a="http://schemas.openxmlformats.org/drawingml/2006/main">
               <a:ext uri="{FF2B5EF4-FFF2-40B4-BE49-F238E27FC236}">
-                <a16:creationId xmlns:a16="http://schemas.microsoft.com/office/drawing/2014/main" id="{FDBD3B1B-80ED-42A9-A123-9C13EE6E677F}"/>
+                <a16:creationId xmlns:a16="http://schemas.microsoft.com/office/drawing/2014/main" id="{3D28BB3D-A09B-499A-8836-5C94615C8825}"/>
               </a:ext>
             </a:extLst>
           </p:cNvPr>
@@ -3073,7 +3103,7 @@
           <p:cNvPr id="2" name="page">
             <a:extLst xmlns:a="http://schemas.openxmlformats.org/drawingml/2006/main">
               <a:ext uri="{FF2B5EF4-FFF2-40B4-BE49-F238E27FC236}">
-                <a16:creationId xmlns:a16="http://schemas.microsoft.com/office/drawing/2014/main" id="{8A3D6B56-909C-44F0-91AF-D46037A55E7E}"/>
+                <a16:creationId xmlns:a16="http://schemas.microsoft.com/office/drawing/2014/main" id="{42507972-CE38-48AB-A7BF-48ED0C9B598F}"/>
               </a:ext>
             </a:extLst>
           </p:cNvPr>
@@ -3141,7 +3171,7 @@
           <p:cNvPr id="3" name="intro">
             <a:extLst xmlns:a="http://schemas.openxmlformats.org/drawingml/2006/main">
               <a:ext uri="{FF2B5EF4-FFF2-40B4-BE49-F238E27FC236}">
-                <a16:creationId xmlns:a16="http://schemas.microsoft.com/office/drawing/2014/main" id="{EE33541A-D832-42CA-83C5-52D7CDDBACFA}"/>
+                <a16:creationId xmlns:a16="http://schemas.microsoft.com/office/drawing/2014/main" id="{44668E74-C113-436D-BFC3-27D6BE8DE3CB}"/>
               </a:ext>
             </a:extLst>
           </p:cNvPr>
@@ -3209,7 +3239,7 @@
           <p:cNvPr id="4" name="today">
             <a:extLst xmlns:a="http://schemas.openxmlformats.org/drawingml/2006/main">
               <a:ext uri="{FF2B5EF4-FFF2-40B4-BE49-F238E27FC236}">
-                <a16:creationId xmlns:a16="http://schemas.microsoft.com/office/drawing/2014/main" id="{B161804A-8215-41E6-88CA-5BE865359B8E}"/>
+                <a16:creationId xmlns:a16="http://schemas.microsoft.com/office/drawing/2014/main" id="{948FA2DE-0570-4895-813C-6D92E6801CA5}"/>
               </a:ext>
             </a:extLst>
           </p:cNvPr>
@@ -3277,7 +3307,7 @@
           <p:cNvPr id="5" name="pain-title-0">
             <a:extLst xmlns:a="http://schemas.openxmlformats.org/drawingml/2006/main">
               <a:ext uri="{FF2B5EF4-FFF2-40B4-BE49-F238E27FC236}">
-                <a16:creationId xmlns:a16="http://schemas.microsoft.com/office/drawing/2014/main" id="{E0EA5C12-01EC-46BD-869D-88204DABA58B}"/>
+                <a16:creationId xmlns:a16="http://schemas.microsoft.com/office/drawing/2014/main" id="{D7D4CCAC-0DE5-4696-813C-49F7D21BE539}"/>
               </a:ext>
             </a:extLst>
           </p:cNvPr>
@@ -3345,7 +3375,7 @@
           <p:cNvPr id="6" name="pain-body-0">
             <a:extLst xmlns:a="http://schemas.openxmlformats.org/drawingml/2006/main">
               <a:ext uri="{FF2B5EF4-FFF2-40B4-BE49-F238E27FC236}">
-                <a16:creationId xmlns:a16="http://schemas.microsoft.com/office/drawing/2014/main" id="{C64154DC-EEFA-484E-A7B8-FF74841D0CE4}"/>
+                <a16:creationId xmlns:a16="http://schemas.microsoft.com/office/drawing/2014/main" id="{8B6010B2-B6D2-4783-908E-5C0D2FD22491}"/>
               </a:ext>
             </a:extLst>
           </p:cNvPr>
@@ -3413,7 +3443,7 @@
           <p:cNvPr id="7" name="pain-title-1">
             <a:extLst xmlns:a="http://schemas.openxmlformats.org/drawingml/2006/main">
               <a:ext uri="{FF2B5EF4-FFF2-40B4-BE49-F238E27FC236}">
-                <a16:creationId xmlns:a16="http://schemas.microsoft.com/office/drawing/2014/main" id="{53E7BAFD-5B46-4FA4-888B-8947518F9EEF}"/>
+                <a16:creationId xmlns:a16="http://schemas.microsoft.com/office/drawing/2014/main" id="{BBF92CDF-ED51-44F3-9DBD-D54F363B8834}"/>
               </a:ext>
             </a:extLst>
           </p:cNvPr>
@@ -3481,7 +3511,7 @@
           <p:cNvPr id="8" name="pain-body-1">
             <a:extLst xmlns:a="http://schemas.openxmlformats.org/drawingml/2006/main">
               <a:ext uri="{FF2B5EF4-FFF2-40B4-BE49-F238E27FC236}">
-                <a16:creationId xmlns:a16="http://schemas.microsoft.com/office/drawing/2014/main" id="{7ED12DC5-5FF0-40FD-B36B-FA9AB06A84A6}"/>
+                <a16:creationId xmlns:a16="http://schemas.microsoft.com/office/drawing/2014/main" id="{7FB8FF10-577C-45D5-9D30-FCAFE3A2FCD7}"/>
               </a:ext>
             </a:extLst>
           </p:cNvPr>
@@ -3549,7 +3579,7 @@
           <p:cNvPr id="9" name="pain-title-2">
             <a:extLst xmlns:a="http://schemas.openxmlformats.org/drawingml/2006/main">
               <a:ext uri="{FF2B5EF4-FFF2-40B4-BE49-F238E27FC236}">
-                <a16:creationId xmlns:a16="http://schemas.microsoft.com/office/drawing/2014/main" id="{9313C797-D049-4636-8AFC-1CD3626A56EE}"/>
+                <a16:creationId xmlns:a16="http://schemas.microsoft.com/office/drawing/2014/main" id="{0D9327EC-7011-43AF-948E-4B24FAC59271}"/>
               </a:ext>
             </a:extLst>
           </p:cNvPr>
@@ -3617,7 +3647,7 @@
           <p:cNvPr id="10" name="pain-body-2">
             <a:extLst xmlns:a="http://schemas.openxmlformats.org/drawingml/2006/main">
               <a:ext uri="{FF2B5EF4-FFF2-40B4-BE49-F238E27FC236}">
-                <a16:creationId xmlns:a16="http://schemas.microsoft.com/office/drawing/2014/main" id="{E19A0A16-1088-499A-89F2-C7EFFF802C32}"/>
+                <a16:creationId xmlns:a16="http://schemas.microsoft.com/office/drawing/2014/main" id="{2C0EC7DE-19E0-467F-8753-52C331AA1DA3}"/>
               </a:ext>
             </a:extLst>
           </p:cNvPr>
@@ -3685,7 +3715,7 @@
           <p:cNvPr id="11" name="mvp">
             <a:extLst xmlns:a="http://schemas.openxmlformats.org/drawingml/2006/main">
               <a:ext uri="{FF2B5EF4-FFF2-40B4-BE49-F238E27FC236}">
-                <a16:creationId xmlns:a16="http://schemas.microsoft.com/office/drawing/2014/main" id="{92487C03-4A6B-41ED-8AC2-ED61302FF177}"/>
+                <a16:creationId xmlns:a16="http://schemas.microsoft.com/office/drawing/2014/main" id="{44A2B8DA-BF24-4D27-8B82-7C73A78034E7}"/>
               </a:ext>
             </a:extLst>
           </p:cNvPr>
@@ -3743,7 +3773,7 @@
                 <a:ea typeface="Arial"/>
                 <a:cs typeface="Arial"/>
               </a:rPr>
-              <a:t>MVP: one portal for Local and Regional AMs</a:t>
+              <a:t>MVP: one portal with role-based access</a:t>
             </a:r>
           </a:p>
         </p:txBody>
@@ -3753,7 +3783,7 @@
           <p:cNvPr id="12" name="scope-title-0">
             <a:extLst xmlns:a="http://schemas.openxmlformats.org/drawingml/2006/main">
               <a:ext uri="{FF2B5EF4-FFF2-40B4-BE49-F238E27FC236}">
-                <a16:creationId xmlns:a16="http://schemas.microsoft.com/office/drawing/2014/main" id="{91EE977D-2747-4DB8-B685-FCEF061C8A45}"/>
+                <a16:creationId xmlns:a16="http://schemas.microsoft.com/office/drawing/2014/main" id="{7997E77F-6021-49CF-9831-92FCD5926A9B}"/>
               </a:ext>
             </a:extLst>
           </p:cNvPr>
@@ -3764,8 +3794,8 @@
         </p:nvSpPr>
         <p:spPr>
           <a:xfrm xmlns:a="http://schemas.openxmlformats.org/drawingml/2006/main">
-            <a:off x="7381875" y="3143250"/>
-            <a:ext cx="7143750" cy="342900"/>
+            <a:off x="7381875" y="3048000"/>
+            <a:ext cx="7143750" cy="323850"/>
           </a:xfrm>
           <a:prstGeom xmlns:a="http://schemas.openxmlformats.org/drawingml/2006/main" prst="rect">
             <a:avLst/>
@@ -3781,7 +3811,7 @@
           </a:bodyPr>
           <a:lstStyle xmlns:a="http://schemas.openxmlformats.org/drawingml/2006/main">
             <a:defPPr algn="l">
-              <a:defRPr sz="2025" b="1">
+              <a:defRPr sz="1950" b="1">
                 <a:solidFill>
                   <a:srgbClr val="132B45"/>
                 </a:solidFill>
@@ -3793,7 +3823,7 @@
           </a:lstStyle>
           <a:p xmlns:a="http://schemas.openxmlformats.org/drawingml/2006/main">
             <a:pPr algn="l">
-              <a:defRPr sz="2025" b="1">
+              <a:defRPr sz="1950" b="1">
                 <a:solidFill>
                   <a:srgbClr val="132B45"/>
                 </a:solidFill>
@@ -3803,7 +3833,7 @@
               </a:defRPr>
             </a:pPr>
             <a:r>
-              <a:rPr sz="2025" b="1">
+              <a:rPr sz="1950" b="1">
                 <a:solidFill>
                   <a:srgbClr val="132B45"/>
                 </a:solidFill>
@@ -3821,7 +3851,7 @@
           <p:cNvPr id="13" name="scope-body-0">
             <a:extLst xmlns:a="http://schemas.openxmlformats.org/drawingml/2006/main">
               <a:ext uri="{FF2B5EF4-FFF2-40B4-BE49-F238E27FC236}">
-                <a16:creationId xmlns:a16="http://schemas.microsoft.com/office/drawing/2014/main" id="{498A79F2-E96B-495A-8590-1566E0FAFA45}"/>
+                <a16:creationId xmlns:a16="http://schemas.microsoft.com/office/drawing/2014/main" id="{B910B43C-6BF3-4E36-821B-A1F146D8D561}"/>
               </a:ext>
             </a:extLst>
           </p:cNvPr>
@@ -3832,8 +3862,8 @@
         </p:nvSpPr>
         <p:spPr>
           <a:xfrm xmlns:a="http://schemas.openxmlformats.org/drawingml/2006/main">
-            <a:off x="7381875" y="3514725"/>
-            <a:ext cx="7143750" cy="619125"/>
+            <a:off x="7381875" y="3381375"/>
+            <a:ext cx="7143750" cy="523875"/>
           </a:xfrm>
           <a:prstGeom xmlns:a="http://schemas.openxmlformats.org/drawingml/2006/main" prst="rect">
             <a:avLst/>
@@ -3849,7 +3879,7 @@
           </a:bodyPr>
           <a:lstStyle xmlns:a="http://schemas.openxmlformats.org/drawingml/2006/main">
             <a:defPPr algn="l">
-              <a:defRPr sz="1875" b="0">
+              <a:defRPr sz="1800" b="0">
                 <a:solidFill>
                   <a:srgbClr val="56677A"/>
                 </a:solidFill>
@@ -3861,7 +3891,7 @@
           </a:lstStyle>
           <a:p xmlns:a="http://schemas.openxmlformats.org/drawingml/2006/main">
             <a:pPr algn="l">
-              <a:defRPr sz="1875" b="0">
+              <a:defRPr sz="1800" b="0">
                 <a:solidFill>
                   <a:srgbClr val="56677A"/>
                 </a:solidFill>
@@ -3871,7 +3901,7 @@
               </a:defRPr>
             </a:pPr>
             <a:r>
-              <a:rPr sz="1875" b="0">
+              <a:rPr sz="1800" b="0">
                 <a:solidFill>
                   <a:srgbClr val="56677A"/>
                 </a:solidFill>
@@ -3889,7 +3919,7 @@
           <p:cNvPr id="14" name="scope-title-1">
             <a:extLst xmlns:a="http://schemas.openxmlformats.org/drawingml/2006/main">
               <a:ext uri="{FF2B5EF4-FFF2-40B4-BE49-F238E27FC236}">
-                <a16:creationId xmlns:a16="http://schemas.microsoft.com/office/drawing/2014/main" id="{60778157-2EE0-41C8-A863-5AC20FD3DCD1}"/>
+                <a16:creationId xmlns:a16="http://schemas.microsoft.com/office/drawing/2014/main" id="{5255682A-E107-4150-8277-DC2D2BCE333E}"/>
               </a:ext>
             </a:extLst>
           </p:cNvPr>
@@ -3900,8 +3930,8 @@
         </p:nvSpPr>
         <p:spPr>
           <a:xfrm xmlns:a="http://schemas.openxmlformats.org/drawingml/2006/main">
-            <a:off x="7381875" y="4171950"/>
-            <a:ext cx="7143750" cy="342900"/>
+            <a:off x="7381875" y="3914775"/>
+            <a:ext cx="7143750" cy="323850"/>
           </a:xfrm>
           <a:prstGeom xmlns:a="http://schemas.openxmlformats.org/drawingml/2006/main" prst="rect">
             <a:avLst/>
@@ -3917,7 +3947,7 @@
           </a:bodyPr>
           <a:lstStyle xmlns:a="http://schemas.openxmlformats.org/drawingml/2006/main">
             <a:defPPr algn="l">
-              <a:defRPr sz="2025" b="1">
+              <a:defRPr sz="1950" b="1">
                 <a:solidFill>
                   <a:srgbClr val="132B45"/>
                 </a:solidFill>
@@ -3929,7 +3959,7 @@
           </a:lstStyle>
           <a:p xmlns:a="http://schemas.openxmlformats.org/drawingml/2006/main">
             <a:pPr algn="l">
-              <a:defRPr sz="2025" b="1">
+              <a:defRPr sz="1950" b="1">
                 <a:solidFill>
                   <a:srgbClr val="132B45"/>
                 </a:solidFill>
@@ -3939,7 +3969,7 @@
               </a:defRPr>
             </a:pPr>
             <a:r>
-              <a:rPr sz="2025" b="1">
+              <a:rPr sz="1950" b="1">
                 <a:solidFill>
                   <a:srgbClr val="132B45"/>
                 </a:solidFill>
@@ -3957,7 +3987,7 @@
           <p:cNvPr id="15" name="scope-body-1">
             <a:extLst xmlns:a="http://schemas.openxmlformats.org/drawingml/2006/main">
               <a:ext uri="{FF2B5EF4-FFF2-40B4-BE49-F238E27FC236}">
-                <a16:creationId xmlns:a16="http://schemas.microsoft.com/office/drawing/2014/main" id="{91592523-6024-4ADD-8C06-D38FEFA88BE6}"/>
+                <a16:creationId xmlns:a16="http://schemas.microsoft.com/office/drawing/2014/main" id="{72AF4866-9AA8-4BE5-BFF6-87EAD9D41591}"/>
               </a:ext>
             </a:extLst>
           </p:cNvPr>
@@ -3968,8 +3998,8 @@
         </p:nvSpPr>
         <p:spPr>
           <a:xfrm xmlns:a="http://schemas.openxmlformats.org/drawingml/2006/main">
-            <a:off x="7381875" y="4543425"/>
-            <a:ext cx="7143750" cy="619125"/>
+            <a:off x="7381875" y="4248150"/>
+            <a:ext cx="7143750" cy="523875"/>
           </a:xfrm>
           <a:prstGeom xmlns:a="http://schemas.openxmlformats.org/drawingml/2006/main" prst="rect">
             <a:avLst/>
@@ -3985,7 +4015,7 @@
           </a:bodyPr>
           <a:lstStyle xmlns:a="http://schemas.openxmlformats.org/drawingml/2006/main">
             <a:defPPr algn="l">
-              <a:defRPr sz="1875" b="0">
+              <a:defRPr sz="1800" b="0">
                 <a:solidFill>
                   <a:srgbClr val="56677A"/>
                 </a:solidFill>
@@ -3997,7 +4027,7 @@
           </a:lstStyle>
           <a:p xmlns:a="http://schemas.openxmlformats.org/drawingml/2006/main">
             <a:pPr algn="l">
-              <a:defRPr sz="1875" b="0">
+              <a:defRPr sz="1800" b="0">
                 <a:solidFill>
                   <a:srgbClr val="56677A"/>
                 </a:solidFill>
@@ -4007,7 +4037,7 @@
               </a:defRPr>
             </a:pPr>
             <a:r>
-              <a:rPr sz="1875" b="0">
+              <a:rPr sz="1800" b="0">
                 <a:solidFill>
                   <a:srgbClr val="56677A"/>
                 </a:solidFill>
@@ -4025,7 +4055,7 @@
           <p:cNvPr id="16" name="scope-title-2">
             <a:extLst xmlns:a="http://schemas.openxmlformats.org/drawingml/2006/main">
               <a:ext uri="{FF2B5EF4-FFF2-40B4-BE49-F238E27FC236}">
-                <a16:creationId xmlns:a16="http://schemas.microsoft.com/office/drawing/2014/main" id="{EE493390-968A-4258-A9CE-C9FE93572335}"/>
+                <a16:creationId xmlns:a16="http://schemas.microsoft.com/office/drawing/2014/main" id="{FF97E5A9-1994-406E-81B2-CD614891B1A4}"/>
               </a:ext>
             </a:extLst>
           </p:cNvPr>
@@ -4036,8 +4066,8 @@
         </p:nvSpPr>
         <p:spPr>
           <a:xfrm xmlns:a="http://schemas.openxmlformats.org/drawingml/2006/main">
-            <a:off x="7381875" y="5200650"/>
-            <a:ext cx="7143750" cy="342900"/>
+            <a:off x="7381875" y="4781550"/>
+            <a:ext cx="7143750" cy="323850"/>
           </a:xfrm>
           <a:prstGeom xmlns:a="http://schemas.openxmlformats.org/drawingml/2006/main" prst="rect">
             <a:avLst/>
@@ -4053,7 +4083,7 @@
           </a:bodyPr>
           <a:lstStyle xmlns:a="http://schemas.openxmlformats.org/drawingml/2006/main">
             <a:defPPr algn="l">
-              <a:defRPr sz="2025" b="1">
+              <a:defRPr sz="1950" b="1">
                 <a:solidFill>
                   <a:srgbClr val="132B45"/>
                 </a:solidFill>
@@ -4065,7 +4095,7 @@
           </a:lstStyle>
           <a:p xmlns:a="http://schemas.openxmlformats.org/drawingml/2006/main">
             <a:pPr algn="l">
-              <a:defRPr sz="2025" b="1">
+              <a:defRPr sz="1950" b="1">
                 <a:solidFill>
                   <a:srgbClr val="132B45"/>
                 </a:solidFill>
@@ -4075,7 +4105,7 @@
               </a:defRPr>
             </a:pPr>
             <a:r>
-              <a:rPr sz="2025" b="1">
+              <a:rPr sz="1950" b="1">
                 <a:solidFill>
                   <a:srgbClr val="132B45"/>
                 </a:solidFill>
@@ -4093,7 +4123,7 @@
           <p:cNvPr id="17" name="scope-body-2">
             <a:extLst xmlns:a="http://schemas.openxmlformats.org/drawingml/2006/main">
               <a:ext uri="{FF2B5EF4-FFF2-40B4-BE49-F238E27FC236}">
-                <a16:creationId xmlns:a16="http://schemas.microsoft.com/office/drawing/2014/main" id="{9B526492-0A44-486E-B191-EC3549B1C067}"/>
+                <a16:creationId xmlns:a16="http://schemas.microsoft.com/office/drawing/2014/main" id="{1F0E3425-647F-46A7-8AB9-EEF7AB1E7175}"/>
               </a:ext>
             </a:extLst>
           </p:cNvPr>
@@ -4104,8 +4134,8 @@
         </p:nvSpPr>
         <p:spPr>
           <a:xfrm xmlns:a="http://schemas.openxmlformats.org/drawingml/2006/main">
-            <a:off x="7381875" y="5572125"/>
-            <a:ext cx="7143750" cy="619125"/>
+            <a:off x="7381875" y="5114925"/>
+            <a:ext cx="7143750" cy="523875"/>
           </a:xfrm>
           <a:prstGeom xmlns:a="http://schemas.openxmlformats.org/drawingml/2006/main" prst="rect">
             <a:avLst/>
@@ -4121,7 +4151,7 @@
           </a:bodyPr>
           <a:lstStyle xmlns:a="http://schemas.openxmlformats.org/drawingml/2006/main">
             <a:defPPr algn="l">
-              <a:defRPr sz="1875" b="0">
+              <a:defRPr sz="1800" b="0">
                 <a:solidFill>
                   <a:srgbClr val="56677A"/>
                 </a:solidFill>
@@ -4133,7 +4163,7 @@
           </a:lstStyle>
           <a:p xmlns:a="http://schemas.openxmlformats.org/drawingml/2006/main">
             <a:pPr algn="l">
-              <a:defRPr sz="1875" b="0">
+              <a:defRPr sz="1800" b="0">
                 <a:solidFill>
                   <a:srgbClr val="56677A"/>
                 </a:solidFill>
@@ -4143,7 +4173,7 @@
               </a:defRPr>
             </a:pPr>
             <a:r>
-              <a:rPr sz="1875" b="0">
+              <a:rPr sz="1800" b="0">
                 <a:solidFill>
                   <a:srgbClr val="56677A"/>
                 </a:solidFill>
@@ -4161,7 +4191,7 @@
           <p:cNvPr id="18" name="scope-title-3">
             <a:extLst xmlns:a="http://schemas.openxmlformats.org/drawingml/2006/main">
               <a:ext uri="{FF2B5EF4-FFF2-40B4-BE49-F238E27FC236}">
-                <a16:creationId xmlns:a16="http://schemas.microsoft.com/office/drawing/2014/main" id="{1360CC28-9AA5-435B-A827-1C2AAF6E53C0}"/>
+                <a16:creationId xmlns:a16="http://schemas.microsoft.com/office/drawing/2014/main" id="{6E4387D4-B2DF-4783-9615-39D91FC1B0F6}"/>
               </a:ext>
             </a:extLst>
           </p:cNvPr>
@@ -4172,8 +4202,8 @@
         </p:nvSpPr>
         <p:spPr>
           <a:xfrm xmlns:a="http://schemas.openxmlformats.org/drawingml/2006/main">
-            <a:off x="7381875" y="6229350"/>
-            <a:ext cx="7143750" cy="342900"/>
+            <a:off x="7381875" y="5648325"/>
+            <a:ext cx="7143750" cy="323850"/>
           </a:xfrm>
           <a:prstGeom xmlns:a="http://schemas.openxmlformats.org/drawingml/2006/main" prst="rect">
             <a:avLst/>
@@ -4189,7 +4219,7 @@
           </a:bodyPr>
           <a:lstStyle xmlns:a="http://schemas.openxmlformats.org/drawingml/2006/main">
             <a:defPPr algn="l">
-              <a:defRPr sz="2025" b="1">
+              <a:defRPr sz="1950" b="1">
                 <a:solidFill>
                   <a:srgbClr val="132B45"/>
                 </a:solidFill>
@@ -4201,7 +4231,7 @@
           </a:lstStyle>
           <a:p xmlns:a="http://schemas.openxmlformats.org/drawingml/2006/main">
             <a:pPr algn="l">
-              <a:defRPr sz="2025" b="1">
+              <a:defRPr sz="1950" b="1">
                 <a:solidFill>
                   <a:srgbClr val="132B45"/>
                 </a:solidFill>
@@ -4211,7 +4241,7 @@
               </a:defRPr>
             </a:pPr>
             <a:r>
-              <a:rPr sz="2025" b="1">
+              <a:rPr sz="1950" b="1">
                 <a:solidFill>
                   <a:srgbClr val="132B45"/>
                 </a:solidFill>
@@ -4229,7 +4259,7 @@
           <p:cNvPr id="19" name="scope-body-3">
             <a:extLst xmlns:a="http://schemas.openxmlformats.org/drawingml/2006/main">
               <a:ext uri="{FF2B5EF4-FFF2-40B4-BE49-F238E27FC236}">
-                <a16:creationId xmlns:a16="http://schemas.microsoft.com/office/drawing/2014/main" id="{C7097972-1358-4D67-8F9B-0B2419A5CD17}"/>
+                <a16:creationId xmlns:a16="http://schemas.microsoft.com/office/drawing/2014/main" id="{2E9690F9-70FA-4785-990B-E4D6699AFDC1}"/>
               </a:ext>
             </a:extLst>
           </p:cNvPr>
@@ -4240,8 +4270,8 @@
         </p:nvSpPr>
         <p:spPr>
           <a:xfrm xmlns:a="http://schemas.openxmlformats.org/drawingml/2006/main">
-            <a:off x="7381875" y="6600825"/>
-            <a:ext cx="7143750" cy="619125"/>
+            <a:off x="7381875" y="5981700"/>
+            <a:ext cx="7143750" cy="523875"/>
           </a:xfrm>
           <a:prstGeom xmlns:a="http://schemas.openxmlformats.org/drawingml/2006/main" prst="rect">
             <a:avLst/>
@@ -4257,7 +4287,7 @@
           </a:bodyPr>
           <a:lstStyle xmlns:a="http://schemas.openxmlformats.org/drawingml/2006/main">
             <a:defPPr algn="l">
-              <a:defRPr sz="1875" b="0">
+              <a:defRPr sz="1800" b="0">
                 <a:solidFill>
                   <a:srgbClr val="56677A"/>
                 </a:solidFill>
@@ -4269,7 +4299,7 @@
           </a:lstStyle>
           <a:p xmlns:a="http://schemas.openxmlformats.org/drawingml/2006/main">
             <a:pPr algn="l">
-              <a:defRPr sz="1875" b="0">
+              <a:defRPr sz="1800" b="0">
                 <a:solidFill>
                   <a:srgbClr val="56677A"/>
                 </a:solidFill>
@@ -4279,7 +4309,7 @@
               </a:defRPr>
             </a:pPr>
             <a:r>
-              <a:rPr sz="1875" b="0">
+              <a:rPr sz="1800" b="0">
                 <a:solidFill>
                   <a:srgbClr val="56677A"/>
                 </a:solidFill>
@@ -4287,17 +4317,153 @@
                 <a:ea typeface="Arial"/>
                 <a:cs typeface="Arial"/>
               </a:rPr>
-              <a:t>Generate rules from a prompt and example emails, then test, review and publish.</a:t>
+              <a:t>Generate rules from prompts and example emails. Test, review and publish.</a:t>
             </a:r>
           </a:p>
         </p:txBody>
       </p:sp>
       <p:sp>
         <p:nvSpPr>
-          <p:cNvPr id="20" name="benefit">
+          <p:cNvPr id="20" name="scope-title-4">
             <a:extLst xmlns:a="http://schemas.openxmlformats.org/drawingml/2006/main">
               <a:ext uri="{FF2B5EF4-FFF2-40B4-BE49-F238E27FC236}">
-                <a16:creationId xmlns:a16="http://schemas.microsoft.com/office/drawing/2014/main" id="{A7424A82-4250-4626-AA76-E8E987BE6BBC}"/>
+                <a16:creationId xmlns:a16="http://schemas.microsoft.com/office/drawing/2014/main" id="{4F14A718-46C6-4D44-B340-A23712236ECD}"/>
+              </a:ext>
+            </a:extLst>
+          </p:cNvPr>
+          <p:cNvSpPr>
+            <a:spLocks xmlns:a="http://schemas.openxmlformats.org/drawingml/2006/main" noGrp="1"/>
+          </p:cNvSpPr>
+          <p:nvPr/>
+        </p:nvSpPr>
+        <p:spPr>
+          <a:xfrm xmlns:a="http://schemas.openxmlformats.org/drawingml/2006/main">
+            <a:off x="7381875" y="6515100"/>
+            <a:ext cx="7143750" cy="323850"/>
+          </a:xfrm>
+          <a:prstGeom xmlns:a="http://schemas.openxmlformats.org/drawingml/2006/main" prst="rect">
+            <a:avLst/>
+          </a:prstGeom>
+          <a:noFill xmlns:a="http://schemas.openxmlformats.org/drawingml/2006/main"/>
+          <a:ln xmlns:a="http://schemas.openxmlformats.org/drawingml/2006/main" w="0">
+            <a:noFill/>
+          </a:ln>
+        </p:spPr>
+        <p:txBody>
+          <a:bodyPr xmlns:a="http://schemas.openxmlformats.org/drawingml/2006/main" wrap="square" lIns="0" tIns="0" rIns="0" bIns="0" anchor="t">
+            <a:noAutofit/>
+          </a:bodyPr>
+          <a:lstStyle xmlns:a="http://schemas.openxmlformats.org/drawingml/2006/main">
+            <a:defPPr algn="l">
+              <a:defRPr sz="1950" b="1">
+                <a:solidFill>
+                  <a:srgbClr val="132B45"/>
+                </a:solidFill>
+                <a:latin typeface="Arial"/>
+                <a:ea typeface="Arial"/>
+                <a:cs typeface="Arial"/>
+              </a:defRPr>
+            </a:defPPr>
+          </a:lstStyle>
+          <a:p xmlns:a="http://schemas.openxmlformats.org/drawingml/2006/main">
+            <a:pPr algn="l">
+              <a:defRPr sz="1950" b="1">
+                <a:solidFill>
+                  <a:srgbClr val="132B45"/>
+                </a:solidFill>
+                <a:latin typeface="Arial"/>
+                <a:ea typeface="Arial"/>
+                <a:cs typeface="Arial"/>
+              </a:defRPr>
+            </a:pPr>
+            <a:r>
+              <a:rPr sz="1950" b="1">
+                <a:solidFill>
+                  <a:srgbClr val="132B45"/>
+                </a:solidFill>
+                <a:latin typeface="Arial"/>
+                <a:ea typeface="Arial"/>
+                <a:cs typeface="Arial"/>
+              </a:rPr>
+              <a:t>Fixed roles and data scopes</a:t>
+            </a:r>
+          </a:p>
+        </p:txBody>
+      </p:sp>
+      <p:sp>
+        <p:nvSpPr>
+          <p:cNvPr id="21" name="scope-body-4">
+            <a:extLst xmlns:a="http://schemas.openxmlformats.org/drawingml/2006/main">
+              <a:ext uri="{FF2B5EF4-FFF2-40B4-BE49-F238E27FC236}">
+                <a16:creationId xmlns:a16="http://schemas.microsoft.com/office/drawing/2014/main" id="{0E8DAB4D-BECB-4A50-90DD-E796E17F1A57}"/>
+              </a:ext>
+            </a:extLst>
+          </p:cNvPr>
+          <p:cNvSpPr>
+            <a:spLocks xmlns:a="http://schemas.openxmlformats.org/drawingml/2006/main" noGrp="1"/>
+          </p:cNvSpPr>
+          <p:nvPr/>
+        </p:nvSpPr>
+        <p:spPr>
+          <a:xfrm xmlns:a="http://schemas.openxmlformats.org/drawingml/2006/main">
+            <a:off x="7381875" y="6848475"/>
+            <a:ext cx="7143750" cy="523875"/>
+          </a:xfrm>
+          <a:prstGeom xmlns:a="http://schemas.openxmlformats.org/drawingml/2006/main" prst="rect">
+            <a:avLst/>
+          </a:prstGeom>
+          <a:noFill xmlns:a="http://schemas.openxmlformats.org/drawingml/2006/main"/>
+          <a:ln xmlns:a="http://schemas.openxmlformats.org/drawingml/2006/main" w="0">
+            <a:noFill/>
+          </a:ln>
+        </p:spPr>
+        <p:txBody>
+          <a:bodyPr xmlns:a="http://schemas.openxmlformats.org/drawingml/2006/main" wrap="square" lIns="0" tIns="0" rIns="0" bIns="0" anchor="t">
+            <a:noAutofit/>
+          </a:bodyPr>
+          <a:lstStyle xmlns:a="http://schemas.openxmlformats.org/drawingml/2006/main">
+            <a:defPPr algn="l">
+              <a:defRPr sz="1800" b="0">
+                <a:solidFill>
+                  <a:srgbClr val="56677A"/>
+                </a:solidFill>
+                <a:latin typeface="Arial"/>
+                <a:ea typeface="Arial"/>
+                <a:cs typeface="Arial"/>
+              </a:defRPr>
+            </a:defPPr>
+          </a:lstStyle>
+          <a:p xmlns:a="http://schemas.openxmlformats.org/drawingml/2006/main">
+            <a:pPr algn="l">
+              <a:defRPr sz="1800" b="0">
+                <a:solidFill>
+                  <a:srgbClr val="56677A"/>
+                </a:solidFill>
+                <a:latin typeface="Arial"/>
+                <a:ea typeface="Arial"/>
+                <a:cs typeface="Arial"/>
+              </a:defRPr>
+            </a:pPr>
+            <a:r>
+              <a:rPr sz="1800" b="0">
+                <a:solidFill>
+                  <a:srgbClr val="56677A"/>
+                </a:solidFill>
+                <a:latin typeface="Arial"/>
+                <a:ea typeface="Arial"/>
+                <a:cs typeface="Arial"/>
+              </a:rPr>
+              <a:t>Local AM, Regional AM, Director and Admin. Limit data by business group, region and customer.</a:t>
+            </a:r>
+          </a:p>
+        </p:txBody>
+      </p:sp>
+      <p:sp>
+        <p:nvSpPr>
+          <p:cNvPr id="22" name="benefit">
+            <a:extLst xmlns:a="http://schemas.openxmlformats.org/drawingml/2006/main">
+              <a:ext uri="{FF2B5EF4-FFF2-40B4-BE49-F238E27FC236}">
+                <a16:creationId xmlns:a16="http://schemas.microsoft.com/office/drawing/2014/main" id="{267EAA46-5065-46DA-B3D8-582D1B3C7D69}"/>
               </a:ext>
             </a:extLst>
           </p:cNvPr>
@@ -4363,7 +4529,7 @@
     </p:spTree>
     <p:extLst>
       <p:ext uri="{BB962C8B-B14F-4D97-AF65-F5344CB8AC3E}">
-        <p14:creationId xmlns:p14="http://schemas.microsoft.com/office/powerpoint/2010/main" val="1639100107"/>
+        <p14:creationId xmlns:p14="http://schemas.microsoft.com/office/powerpoint/2010/main" val="1513220039"/>
       </p:ext>
     </p:extLst>
   </p:cSld>
@@ -4391,10 +4557,10 @@
       </p:grpSpPr>
       <p:sp>
         <p:nvSpPr>
-          <p:cNvPr id="21" name="title">
+          <p:cNvPr id="24" name="title">
             <a:extLst xmlns:a="http://schemas.openxmlformats.org/drawingml/2006/main">
               <a:ext uri="{FF2B5EF4-FFF2-40B4-BE49-F238E27FC236}">
-                <a16:creationId xmlns:a16="http://schemas.microsoft.com/office/drawing/2014/main" id="{FBB46168-8E21-41D3-B72B-8F6C07051E6A}"/>
+                <a16:creationId xmlns:a16="http://schemas.microsoft.com/office/drawing/2014/main" id="{7E89AAAA-8E48-4258-B472-56F3E77628C3}"/>
               </a:ext>
             </a:extLst>
           </p:cNvPr>
@@ -4462,7 +4628,7 @@
           <p:cNvPr id="2" name="page">
             <a:extLst xmlns:a="http://schemas.openxmlformats.org/drawingml/2006/main">
               <a:ext uri="{FF2B5EF4-FFF2-40B4-BE49-F238E27FC236}">
-                <a16:creationId xmlns:a16="http://schemas.microsoft.com/office/drawing/2014/main" id="{810E7D2E-2A6E-4CC2-A135-D4A639CB9202}"/>
+                <a16:creationId xmlns:a16="http://schemas.microsoft.com/office/drawing/2014/main" id="{4CD79712-76E9-4556-B792-D8D03CB33687}"/>
               </a:ext>
             </a:extLst>
           </p:cNvPr>
@@ -4530,7 +4696,7 @@
           <p:cNvPr id="3" name="lead">
             <a:extLst xmlns:a="http://schemas.openxmlformats.org/drawingml/2006/main">
               <a:ext uri="{FF2B5EF4-FFF2-40B4-BE49-F238E27FC236}">
-                <a16:creationId xmlns:a16="http://schemas.microsoft.com/office/drawing/2014/main" id="{7A82ECC3-F78F-4867-B7CA-73D72455FE08}"/>
+                <a16:creationId xmlns:a16="http://schemas.microsoft.com/office/drawing/2014/main" id="{140FF9A0-F365-4F7B-9F4C-F9A0E61ED358}"/>
               </a:ext>
             </a:extLst>
           </p:cNvPr>
@@ -4598,7 +4764,7 @@
           <p:cNvPr id="4" name="lead-body">
             <a:extLst xmlns:a="http://schemas.openxmlformats.org/drawingml/2006/main">
               <a:ext uri="{FF2B5EF4-FFF2-40B4-BE49-F238E27FC236}">
-                <a16:creationId xmlns:a16="http://schemas.microsoft.com/office/drawing/2014/main" id="{277FEADE-783E-4CFB-AB3E-1FC5D24EA0C8}"/>
+                <a16:creationId xmlns:a16="http://schemas.microsoft.com/office/drawing/2014/main" id="{DFFC9C69-7D05-4ACF-BEFA-D6676F57D909}"/>
               </a:ext>
             </a:extLst>
           </p:cNvPr>
@@ -4666,7 +4832,7 @@
           <p:cNvPr id="5" name="n-0">
             <a:extLst xmlns:a="http://schemas.openxmlformats.org/drawingml/2006/main">
               <a:ext uri="{FF2B5EF4-FFF2-40B4-BE49-F238E27FC236}">
-                <a16:creationId xmlns:a16="http://schemas.microsoft.com/office/drawing/2014/main" id="{E537CDC4-E18E-48D1-98BF-EE68B4839975}"/>
+                <a16:creationId xmlns:a16="http://schemas.microsoft.com/office/drawing/2014/main" id="{451D4BBF-1FE4-41D6-99E0-8618E87E6D89}"/>
               </a:ext>
             </a:extLst>
           </p:cNvPr>
@@ -4677,8 +4843,8 @@
         </p:nvSpPr>
         <p:spPr>
           <a:xfrm xmlns:a="http://schemas.openxmlformats.org/drawingml/2006/main">
-            <a:off x="609600" y="3019425"/>
-            <a:ext cx="571500" cy="428625"/>
+            <a:off x="609600" y="2905125"/>
+            <a:ext cx="571500" cy="409575"/>
           </a:xfrm>
           <a:prstGeom xmlns:a="http://schemas.openxmlformats.org/drawingml/2006/main" prst="rect">
             <a:avLst/>
@@ -4734,7 +4900,7 @@
           <p:cNvPr id="6" name="h-0">
             <a:extLst xmlns:a="http://schemas.openxmlformats.org/drawingml/2006/main">
               <a:ext uri="{FF2B5EF4-FFF2-40B4-BE49-F238E27FC236}">
-                <a16:creationId xmlns:a16="http://schemas.microsoft.com/office/drawing/2014/main" id="{69546361-1E6A-447A-AF7B-C9990C5EF92F}"/>
+                <a16:creationId xmlns:a16="http://schemas.microsoft.com/office/drawing/2014/main" id="{DF47C398-8CE0-46C3-90C3-3379A695464E}"/>
               </a:ext>
             </a:extLst>
           </p:cNvPr>
@@ -4745,8 +4911,8 @@
         </p:nvSpPr>
         <p:spPr>
           <a:xfrm xmlns:a="http://schemas.openxmlformats.org/drawingml/2006/main">
-            <a:off x="1409700" y="3019425"/>
-            <a:ext cx="7905750" cy="361950"/>
+            <a:off x="1409700" y="2905125"/>
+            <a:ext cx="7905750" cy="342900"/>
           </a:xfrm>
           <a:prstGeom xmlns:a="http://schemas.openxmlformats.org/drawingml/2006/main" prst="rect">
             <a:avLst/>
@@ -4802,7 +4968,7 @@
           <p:cNvPr id="7" name="b-0">
             <a:extLst xmlns:a="http://schemas.openxmlformats.org/drawingml/2006/main">
               <a:ext uri="{FF2B5EF4-FFF2-40B4-BE49-F238E27FC236}">
-                <a16:creationId xmlns:a16="http://schemas.microsoft.com/office/drawing/2014/main" id="{E47F358C-F2CC-4DF7-A0FF-EB25F9CFD948}"/>
+                <a16:creationId xmlns:a16="http://schemas.microsoft.com/office/drawing/2014/main" id="{19CD6113-8B16-42BD-99C9-2B48C5276B29}"/>
               </a:ext>
             </a:extLst>
           </p:cNvPr>
@@ -4813,8 +4979,8 @@
         </p:nvSpPr>
         <p:spPr>
           <a:xfrm xmlns:a="http://schemas.openxmlformats.org/drawingml/2006/main">
-            <a:off x="1409700" y="3429000"/>
-            <a:ext cx="7858125" cy="619125"/>
+            <a:off x="1409700" y="3286125"/>
+            <a:ext cx="7858125" cy="552450"/>
           </a:xfrm>
           <a:prstGeom xmlns:a="http://schemas.openxmlformats.org/drawingml/2006/main" prst="rect">
             <a:avLst/>
@@ -4860,7 +5026,7 @@
                 <a:ea typeface="Arial"/>
                 <a:cs typeface="Arial"/>
               </a:rPr>
-              <a:t>Spring Boot handles APIs, Cases, Open Items, permissions and approvals. The same application runs bounded async jobs.</a:t>
+              <a:t>Spring Boot serves APIs and runs bounded async jobs for Cases, Open Items, approvals and mail workflows.</a:t>
             </a:r>
           </a:p>
         </p:txBody>
@@ -4870,7 +5036,7 @@
           <p:cNvPr id="8" name="n-1">
             <a:extLst xmlns:a="http://schemas.openxmlformats.org/drawingml/2006/main">
               <a:ext uri="{FF2B5EF4-FFF2-40B4-BE49-F238E27FC236}">
-                <a16:creationId xmlns:a16="http://schemas.microsoft.com/office/drawing/2014/main" id="{E8E22210-D885-4F8A-A2DA-6F5926DE30E7}"/>
+                <a16:creationId xmlns:a16="http://schemas.microsoft.com/office/drawing/2014/main" id="{80C2E769-5951-4620-95E2-61563B797845}"/>
               </a:ext>
             </a:extLst>
           </p:cNvPr>
@@ -4881,8 +5047,8 @@
         </p:nvSpPr>
         <p:spPr>
           <a:xfrm xmlns:a="http://schemas.openxmlformats.org/drawingml/2006/main">
-            <a:off x="609600" y="4095750"/>
-            <a:ext cx="571500" cy="428625"/>
+            <a:off x="609600" y="3848100"/>
+            <a:ext cx="571500" cy="409575"/>
           </a:xfrm>
           <a:prstGeom xmlns:a="http://schemas.openxmlformats.org/drawingml/2006/main" prst="rect">
             <a:avLst/>
@@ -4938,7 +5104,7 @@
           <p:cNvPr id="9" name="h-1">
             <a:extLst xmlns:a="http://schemas.openxmlformats.org/drawingml/2006/main">
               <a:ext uri="{FF2B5EF4-FFF2-40B4-BE49-F238E27FC236}">
-                <a16:creationId xmlns:a16="http://schemas.microsoft.com/office/drawing/2014/main" id="{14107337-45E1-4737-B4A3-1010EA92906A}"/>
+                <a16:creationId xmlns:a16="http://schemas.microsoft.com/office/drawing/2014/main" id="{DF11F892-8723-406F-9215-94118822F299}"/>
               </a:ext>
             </a:extLst>
           </p:cNvPr>
@@ -4949,8 +5115,8 @@
         </p:nvSpPr>
         <p:spPr>
           <a:xfrm xmlns:a="http://schemas.openxmlformats.org/drawingml/2006/main">
-            <a:off x="1409700" y="4095750"/>
-            <a:ext cx="7905750" cy="361950"/>
+            <a:off x="1409700" y="3848100"/>
+            <a:ext cx="7905750" cy="342900"/>
           </a:xfrm>
           <a:prstGeom xmlns:a="http://schemas.openxmlformats.org/drawingml/2006/main" prst="rect">
             <a:avLst/>
@@ -5006,7 +5172,7 @@
           <p:cNvPr id="10" name="b-1">
             <a:extLst xmlns:a="http://schemas.openxmlformats.org/drawingml/2006/main">
               <a:ext uri="{FF2B5EF4-FFF2-40B4-BE49-F238E27FC236}">
-                <a16:creationId xmlns:a16="http://schemas.microsoft.com/office/drawing/2014/main" id="{227F246F-661D-4365-9256-84CCB43AD976}"/>
+                <a16:creationId xmlns:a16="http://schemas.microsoft.com/office/drawing/2014/main" id="{8C173AC2-18D7-45F0-852A-966BC93EAAD6}"/>
               </a:ext>
             </a:extLst>
           </p:cNvPr>
@@ -5017,8 +5183,8 @@
         </p:nvSpPr>
         <p:spPr>
           <a:xfrm xmlns:a="http://schemas.openxmlformats.org/drawingml/2006/main">
-            <a:off x="1409700" y="4505325"/>
-            <a:ext cx="7858125" cy="619125"/>
+            <a:off x="1409700" y="4229100"/>
+            <a:ext cx="7858125" cy="552450"/>
           </a:xfrm>
           <a:prstGeom xmlns:a="http://schemas.openxmlformats.org/drawingml/2006/main" prst="rect">
             <a:avLst/>
@@ -5064,7 +5230,7 @@
                 <a:ea typeface="Arial"/>
                 <a:cs typeface="Arial"/>
               </a:rPr>
-              <a:t>Spring AI calls Azure AI Foundry for intent, summaries, mail drafts and Playbook generation. AMs confirm business actions.</a:t>
+              <a:t>Spring AI calls Azure AI Foundry for intent, summaries, drafts and Playbooks. AMs approve actions.</a:t>
             </a:r>
           </a:p>
         </p:txBody>
@@ -5074,7 +5240,7 @@
           <p:cNvPr id="11" name="n-2">
             <a:extLst xmlns:a="http://schemas.openxmlformats.org/drawingml/2006/main">
               <a:ext uri="{FF2B5EF4-FFF2-40B4-BE49-F238E27FC236}">
-                <a16:creationId xmlns:a16="http://schemas.microsoft.com/office/drawing/2014/main" id="{7F6506AA-7029-46A8-8A5F-0728825126FA}"/>
+                <a16:creationId xmlns:a16="http://schemas.microsoft.com/office/drawing/2014/main" id="{3D56A0CE-55C2-4A6B-895E-AFCBA5A49267}"/>
               </a:ext>
             </a:extLst>
           </p:cNvPr>
@@ -5085,8 +5251,8 @@
         </p:nvSpPr>
         <p:spPr>
           <a:xfrm xmlns:a="http://schemas.openxmlformats.org/drawingml/2006/main">
-            <a:off x="609600" y="5172075"/>
-            <a:ext cx="571500" cy="428625"/>
+            <a:off x="609600" y="4791075"/>
+            <a:ext cx="571500" cy="409575"/>
           </a:xfrm>
           <a:prstGeom xmlns:a="http://schemas.openxmlformats.org/drawingml/2006/main" prst="rect">
             <a:avLst/>
@@ -5142,7 +5308,7 @@
           <p:cNvPr id="12" name="h-2">
             <a:extLst xmlns:a="http://schemas.openxmlformats.org/drawingml/2006/main">
               <a:ext uri="{FF2B5EF4-FFF2-40B4-BE49-F238E27FC236}">
-                <a16:creationId xmlns:a16="http://schemas.microsoft.com/office/drawing/2014/main" id="{D78FB0DC-EC03-4FC1-8987-0C3F361E657B}"/>
+                <a16:creationId xmlns:a16="http://schemas.microsoft.com/office/drawing/2014/main" id="{45E8C0AA-82CD-4897-A785-85E8D7A4388F}"/>
               </a:ext>
             </a:extLst>
           </p:cNvPr>
@@ -5153,8 +5319,8 @@
         </p:nvSpPr>
         <p:spPr>
           <a:xfrm xmlns:a="http://schemas.openxmlformats.org/drawingml/2006/main">
-            <a:off x="1409700" y="5172075"/>
-            <a:ext cx="7905750" cy="361950"/>
+            <a:off x="1409700" y="4791075"/>
+            <a:ext cx="7905750" cy="342900"/>
           </a:xfrm>
           <a:prstGeom xmlns:a="http://schemas.openxmlformats.org/drawingml/2006/main" prst="rect">
             <a:avLst/>
@@ -5210,7 +5376,7 @@
           <p:cNvPr id="13" name="b-2">
             <a:extLst xmlns:a="http://schemas.openxmlformats.org/drawingml/2006/main">
               <a:ext uri="{FF2B5EF4-FFF2-40B4-BE49-F238E27FC236}">
-                <a16:creationId xmlns:a16="http://schemas.microsoft.com/office/drawing/2014/main" id="{69EEFE1B-4815-442C-9932-0C08289B1718}"/>
+                <a16:creationId xmlns:a16="http://schemas.microsoft.com/office/drawing/2014/main" id="{21F64295-D470-4A67-B5C1-A955101E81B8}"/>
               </a:ext>
             </a:extLst>
           </p:cNvPr>
@@ -5221,8 +5387,8 @@
         </p:nvSpPr>
         <p:spPr>
           <a:xfrm xmlns:a="http://schemas.openxmlformats.org/drawingml/2006/main">
-            <a:off x="1409700" y="5581650"/>
-            <a:ext cx="7858125" cy="619125"/>
+            <a:off x="1409700" y="5172075"/>
+            <a:ext cx="7858125" cy="552450"/>
           </a:xfrm>
           <a:prstGeom xmlns:a="http://schemas.openxmlformats.org/drawingml/2006/main" prst="rect">
             <a:avLst/>
@@ -5268,7 +5434,7 @@
                 <a:ea typeface="Arial"/>
                 <a:cs typeface="Arial"/>
               </a:rPr>
-              <a:t>Persist Cases, sessions, jobs and progress. Short transactions, unique keys and request idempotency protect business updates.</a:t>
+              <a:t>Persist Cases, jobs and sessions. Transactions and idempotency protect business updates.</a:t>
             </a:r>
           </a:p>
         </p:txBody>
@@ -5278,7 +5444,7 @@
           <p:cNvPr id="14" name="n-3">
             <a:extLst xmlns:a="http://schemas.openxmlformats.org/drawingml/2006/main">
               <a:ext uri="{FF2B5EF4-FFF2-40B4-BE49-F238E27FC236}">
-                <a16:creationId xmlns:a16="http://schemas.microsoft.com/office/drawing/2014/main" id="{34C2286A-86D3-4226-8767-C857AF57C9C4}"/>
+                <a16:creationId xmlns:a16="http://schemas.microsoft.com/office/drawing/2014/main" id="{27298665-FD9D-4153-BFF3-279B99132D7E}"/>
               </a:ext>
             </a:extLst>
           </p:cNvPr>
@@ -5289,8 +5455,8 @@
         </p:nvSpPr>
         <p:spPr>
           <a:xfrm xmlns:a="http://schemas.openxmlformats.org/drawingml/2006/main">
-            <a:off x="609600" y="6248400"/>
-            <a:ext cx="571500" cy="428625"/>
+            <a:off x="609600" y="5734050"/>
+            <a:ext cx="571500" cy="409575"/>
           </a:xfrm>
           <a:prstGeom xmlns:a="http://schemas.openxmlformats.org/drawingml/2006/main" prst="rect">
             <a:avLst/>
@@ -5346,7 +5512,7 @@
           <p:cNvPr id="15" name="h-3">
             <a:extLst xmlns:a="http://schemas.openxmlformats.org/drawingml/2006/main">
               <a:ext uri="{FF2B5EF4-FFF2-40B4-BE49-F238E27FC236}">
-                <a16:creationId xmlns:a16="http://schemas.microsoft.com/office/drawing/2014/main" id="{1C4F9A8F-7822-49CD-96CE-937D870C3135}"/>
+                <a16:creationId xmlns:a16="http://schemas.microsoft.com/office/drawing/2014/main" id="{91EB7F62-F172-44C1-8E75-8027743C892C}"/>
               </a:ext>
             </a:extLst>
           </p:cNvPr>
@@ -5357,8 +5523,8 @@
         </p:nvSpPr>
         <p:spPr>
           <a:xfrm xmlns:a="http://schemas.openxmlformats.org/drawingml/2006/main">
-            <a:off x="1409700" y="6248400"/>
-            <a:ext cx="7905750" cy="361950"/>
+            <a:off x="1409700" y="5734050"/>
+            <a:ext cx="7905750" cy="342900"/>
           </a:xfrm>
           <a:prstGeom xmlns:a="http://schemas.openxmlformats.org/drawingml/2006/main" prst="rect">
             <a:avLst/>
@@ -5414,7 +5580,7 @@
           <p:cNvPr id="16" name="b-3">
             <a:extLst xmlns:a="http://schemas.openxmlformats.org/drawingml/2006/main">
               <a:ext uri="{FF2B5EF4-FFF2-40B4-BE49-F238E27FC236}">
-                <a16:creationId xmlns:a16="http://schemas.microsoft.com/office/drawing/2014/main" id="{8837218F-6978-4FAB-867F-FA281AE147A1}"/>
+                <a16:creationId xmlns:a16="http://schemas.microsoft.com/office/drawing/2014/main" id="{2084CE53-BFC2-4796-A886-6128A2DCCBAD}"/>
               </a:ext>
             </a:extLst>
           </p:cNvPr>
@@ -5425,8 +5591,8 @@
         </p:nvSpPr>
         <p:spPr>
           <a:xfrm xmlns:a="http://schemas.openxmlformats.org/drawingml/2006/main">
-            <a:off x="1409700" y="6657975"/>
-            <a:ext cx="7858125" cy="619125"/>
+            <a:off x="1409700" y="6115050"/>
+            <a:ext cx="7858125" cy="552450"/>
           </a:xfrm>
           <a:prstGeom xmlns:a="http://schemas.openxmlformats.org/drawingml/2006/main" prst="rect">
             <a:avLst/>
@@ -5472,17 +5638,221 @@
                 <a:ea typeface="Arial"/>
                 <a:cs typeface="Arial"/>
               </a:rPr>
-              <a:t>Job leases and fencing reject stale results. The platform routes to healthy replicas and replaces failed instances.</a:t>
+              <a:t>Replicas reclaim unfinished jobs using leases and fencing. The platform replaces failed instances.</a:t>
             </a:r>
           </a:p>
         </p:txBody>
       </p:sp>
       <p:sp>
         <p:nvSpPr>
-          <p:cNvPr id="17" name="platform">
+          <p:cNvPr id="17" name="n-4">
             <a:extLst xmlns:a="http://schemas.openxmlformats.org/drawingml/2006/main">
               <a:ext uri="{FF2B5EF4-FFF2-40B4-BE49-F238E27FC236}">
-                <a16:creationId xmlns:a16="http://schemas.microsoft.com/office/drawing/2014/main" id="{9D1770A6-AF2A-43DC-A8D3-2C0021AAEF2F}"/>
+                <a16:creationId xmlns:a16="http://schemas.microsoft.com/office/drawing/2014/main" id="{1A1571AF-A8DD-4111-84BC-15825B4AC7F3}"/>
+              </a:ext>
+            </a:extLst>
+          </p:cNvPr>
+          <p:cNvSpPr>
+            <a:spLocks xmlns:a="http://schemas.openxmlformats.org/drawingml/2006/main" noGrp="1"/>
+          </p:cNvSpPr>
+          <p:nvPr/>
+        </p:nvSpPr>
+        <p:spPr>
+          <a:xfrm xmlns:a="http://schemas.openxmlformats.org/drawingml/2006/main">
+            <a:off x="609600" y="6677025"/>
+            <a:ext cx="571500" cy="409575"/>
+          </a:xfrm>
+          <a:prstGeom xmlns:a="http://schemas.openxmlformats.org/drawingml/2006/main" prst="rect">
+            <a:avLst/>
+          </a:prstGeom>
+          <a:noFill xmlns:a="http://schemas.openxmlformats.org/drawingml/2006/main"/>
+          <a:ln xmlns:a="http://schemas.openxmlformats.org/drawingml/2006/main" w="0">
+            <a:noFill/>
+          </a:ln>
+        </p:spPr>
+        <p:txBody>
+          <a:bodyPr xmlns:a="http://schemas.openxmlformats.org/drawingml/2006/main" wrap="square" lIns="0" tIns="0" rIns="0" bIns="0" anchor="t">
+            <a:noAutofit/>
+          </a:bodyPr>
+          <a:lstStyle xmlns:a="http://schemas.openxmlformats.org/drawingml/2006/main">
+            <a:defPPr algn="l">
+              <a:defRPr sz="2400" b="1">
+                <a:solidFill>
+                  <a:srgbClr val="2563EB"/>
+                </a:solidFill>
+                <a:latin typeface="Arial"/>
+                <a:ea typeface="Arial"/>
+                <a:cs typeface="Arial"/>
+              </a:defRPr>
+            </a:defPPr>
+          </a:lstStyle>
+          <a:p xmlns:a="http://schemas.openxmlformats.org/drawingml/2006/main">
+            <a:pPr algn="l">
+              <a:defRPr sz="2400" b="1">
+                <a:solidFill>
+                  <a:srgbClr val="2563EB"/>
+                </a:solidFill>
+                <a:latin typeface="Arial"/>
+                <a:ea typeface="Arial"/>
+                <a:cs typeface="Arial"/>
+              </a:defRPr>
+            </a:pPr>
+            <a:r>
+              <a:rPr sz="2400" b="1">
+                <a:solidFill>
+                  <a:srgbClr val="2563EB"/>
+                </a:solidFill>
+                <a:latin typeface="Arial"/>
+                <a:ea typeface="Arial"/>
+                <a:cs typeface="Arial"/>
+              </a:rPr>
+              <a:t>05</a:t>
+            </a:r>
+          </a:p>
+        </p:txBody>
+      </p:sp>
+      <p:sp>
+        <p:nvSpPr>
+          <p:cNvPr id="18" name="h-4">
+            <a:extLst xmlns:a="http://schemas.openxmlformats.org/drawingml/2006/main">
+              <a:ext uri="{FF2B5EF4-FFF2-40B4-BE49-F238E27FC236}">
+                <a16:creationId xmlns:a16="http://schemas.microsoft.com/office/drawing/2014/main" id="{863D4E4B-E0D0-4D98-8A31-95D1A716E287}"/>
+              </a:ext>
+            </a:extLst>
+          </p:cNvPr>
+          <p:cNvSpPr>
+            <a:spLocks xmlns:a="http://schemas.openxmlformats.org/drawingml/2006/main" noGrp="1"/>
+          </p:cNvSpPr>
+          <p:nvPr/>
+        </p:nvSpPr>
+        <p:spPr>
+          <a:xfrm xmlns:a="http://schemas.openxmlformats.org/drawingml/2006/main">
+            <a:off x="1409700" y="6677025"/>
+            <a:ext cx="7905750" cy="342900"/>
+          </a:xfrm>
+          <a:prstGeom xmlns:a="http://schemas.openxmlformats.org/drawingml/2006/main" prst="rect">
+            <a:avLst/>
+          </a:prstGeom>
+          <a:noFill xmlns:a="http://schemas.openxmlformats.org/drawingml/2006/main"/>
+          <a:ln xmlns:a="http://schemas.openxmlformats.org/drawingml/2006/main" w="0">
+            <a:noFill/>
+          </a:ln>
+        </p:spPr>
+        <p:txBody>
+          <a:bodyPr xmlns:a="http://schemas.openxmlformats.org/drawingml/2006/main" wrap="square" lIns="0" tIns="0" rIns="0" bIns="0" anchor="t">
+            <a:noAutofit/>
+          </a:bodyPr>
+          <a:lstStyle xmlns:a="http://schemas.openxmlformats.org/drawingml/2006/main">
+            <a:defPPr algn="l">
+              <a:defRPr sz="2175" b="1">
+                <a:solidFill>
+                  <a:srgbClr val="132B45"/>
+                </a:solidFill>
+                <a:latin typeface="Arial"/>
+                <a:ea typeface="Arial"/>
+                <a:cs typeface="Arial"/>
+              </a:defRPr>
+            </a:defPPr>
+          </a:lstStyle>
+          <a:p xmlns:a="http://schemas.openxmlformats.org/drawingml/2006/main">
+            <a:pPr algn="l">
+              <a:defRPr sz="2175" b="1">
+                <a:solidFill>
+                  <a:srgbClr val="132B45"/>
+                </a:solidFill>
+                <a:latin typeface="Arial"/>
+                <a:ea typeface="Arial"/>
+                <a:cs typeface="Arial"/>
+              </a:defRPr>
+            </a:pPr>
+            <a:r>
+              <a:rPr sz="2175" b="1">
+                <a:solidFill>
+                  <a:srgbClr val="132B45"/>
+                </a:solidFill>
+                <a:latin typeface="Arial"/>
+                <a:ea typeface="Arial"/>
+                <a:cs typeface="Arial"/>
+              </a:rPr>
+              <a:t>Okta roles, Java authorization</a:t>
+            </a:r>
+          </a:p>
+        </p:txBody>
+      </p:sp>
+      <p:sp>
+        <p:nvSpPr>
+          <p:cNvPr id="19" name="b-4">
+            <a:extLst xmlns:a="http://schemas.openxmlformats.org/drawingml/2006/main">
+              <a:ext uri="{FF2B5EF4-FFF2-40B4-BE49-F238E27FC236}">
+                <a16:creationId xmlns:a16="http://schemas.microsoft.com/office/drawing/2014/main" id="{85DDC0BB-9FE7-4742-84A9-C004F6DF60CF}"/>
+              </a:ext>
+            </a:extLst>
+          </p:cNvPr>
+          <p:cNvSpPr>
+            <a:spLocks xmlns:a="http://schemas.openxmlformats.org/drawingml/2006/main" noGrp="1"/>
+          </p:cNvSpPr>
+          <p:nvPr/>
+        </p:nvSpPr>
+        <p:spPr>
+          <a:xfrm xmlns:a="http://schemas.openxmlformats.org/drawingml/2006/main">
+            <a:off x="1409700" y="7058025"/>
+            <a:ext cx="7858125" cy="552450"/>
+          </a:xfrm>
+          <a:prstGeom xmlns:a="http://schemas.openxmlformats.org/drawingml/2006/main" prst="rect">
+            <a:avLst/>
+          </a:prstGeom>
+          <a:noFill xmlns:a="http://schemas.openxmlformats.org/drawingml/2006/main"/>
+          <a:ln xmlns:a="http://schemas.openxmlformats.org/drawingml/2006/main" w="0">
+            <a:noFill/>
+          </a:ln>
+        </p:spPr>
+        <p:txBody>
+          <a:bodyPr xmlns:a="http://schemas.openxmlformats.org/drawingml/2006/main" wrap="square" lIns="0" tIns="0" rIns="0" bIns="0" anchor="t">
+            <a:noAutofit/>
+          </a:bodyPr>
+          <a:lstStyle xmlns:a="http://schemas.openxmlformats.org/drawingml/2006/main">
+            <a:defPPr algn="l">
+              <a:defRPr sz="1875" b="0">
+                <a:solidFill>
+                  <a:srgbClr val="56677A"/>
+                </a:solidFill>
+                <a:latin typeface="Arial"/>
+                <a:ea typeface="Arial"/>
+                <a:cs typeface="Arial"/>
+              </a:defRPr>
+            </a:defPPr>
+          </a:lstStyle>
+          <a:p xmlns:a="http://schemas.openxmlformats.org/drawingml/2006/main">
+            <a:pPr algn="l">
+              <a:defRPr sz="1875" b="0">
+                <a:solidFill>
+                  <a:srgbClr val="56677A"/>
+                </a:solidFill>
+                <a:latin typeface="Arial"/>
+                <a:ea typeface="Arial"/>
+                <a:cs typeface="Arial"/>
+              </a:defRPr>
+            </a:pPr>
+            <a:r>
+              <a:rPr sz="1875" b="0">
+                <a:solidFill>
+                  <a:srgbClr val="56677A"/>
+                </a:solidFill>
+                <a:latin typeface="Arial"/>
+                <a:ea typeface="Arial"/>
+                <a:cs typeface="Arial"/>
+              </a:rPr>
+              <a:t>Okta owns role groups. Java enforces permissions and business group, region and customer data scopes.</a:t>
+            </a:r>
+          </a:p>
+        </p:txBody>
+      </p:sp>
+      <p:sp>
+        <p:nvSpPr>
+          <p:cNvPr id="20" name="platform">
+            <a:extLst xmlns:a="http://schemas.openxmlformats.org/drawingml/2006/main">
+              <a:ext uri="{FF2B5EF4-FFF2-40B4-BE49-F238E27FC236}">
+                <a16:creationId xmlns:a16="http://schemas.microsoft.com/office/drawing/2014/main" id="{2AB2E0E6-A6B0-4479-B4B1-6EFB992A5A05}"/>
               </a:ext>
             </a:extLst>
           </p:cNvPr>
@@ -5547,10 +5917,10 @@
       </p:sp>
       <p:sp>
         <p:nvSpPr>
-          <p:cNvPr id="18" name="platform-list">
+          <p:cNvPr id="21" name="platform-list">
             <a:extLst xmlns:a="http://schemas.openxmlformats.org/drawingml/2006/main">
               <a:ext uri="{FF2B5EF4-FFF2-40B4-BE49-F238E27FC236}">
-                <a16:creationId xmlns:a16="http://schemas.microsoft.com/office/drawing/2014/main" id="{73BB17A1-B74B-4F21-A211-0A3CBA4B9838}"/>
+                <a16:creationId xmlns:a16="http://schemas.microsoft.com/office/drawing/2014/main" id="{2505D828-8A29-46E3-ADC7-18D95A022B2F}"/>
               </a:ext>
             </a:extLst>
           </p:cNvPr>
@@ -5608,7 +5978,7 @@
                 <a:ea typeface="Arial"/>
                 <a:cs typeface="Arial"/>
               </a:rPr>
-              <a:t>Okta SSO and MFA</a:t>
+              <a:t>Okta SSO, MFA and role groups</a:t>
             </a:r>
           </a:p>
           <a:p xmlns:a="http://schemas.openxmlformats.org/drawingml/2006/main">
@@ -5707,10 +6077,10 @@
       </p:sp>
       <p:sp>
         <p:nvSpPr>
-          <p:cNvPr id="19" name="delivery">
+          <p:cNvPr id="22" name="delivery">
             <a:extLst xmlns:a="http://schemas.openxmlformats.org/drawingml/2006/main">
               <a:ext uri="{FF2B5EF4-FFF2-40B4-BE49-F238E27FC236}">
-                <a16:creationId xmlns:a16="http://schemas.microsoft.com/office/drawing/2014/main" id="{FEFD2FE2-6643-4CA2-A1A4-2548E44E5196}"/>
+                <a16:creationId xmlns:a16="http://schemas.microsoft.com/office/drawing/2014/main" id="{08586E99-EC42-46F7-B8D9-E645BAE16697}"/>
               </a:ext>
             </a:extLst>
           </p:cNvPr>
@@ -5775,10 +6145,10 @@
       </p:sp>
       <p:sp>
         <p:nvSpPr>
-          <p:cNvPr id="20" name="delivery-body">
+          <p:cNvPr id="23" name="delivery-body">
             <a:extLst xmlns:a="http://schemas.openxmlformats.org/drawingml/2006/main">
               <a:ext uri="{FF2B5EF4-FFF2-40B4-BE49-F238E27FC236}">
-                <a16:creationId xmlns:a16="http://schemas.microsoft.com/office/drawing/2014/main" id="{E97667C6-56E4-48EE-A249-EC9617190E1E}"/>
+                <a16:creationId xmlns:a16="http://schemas.microsoft.com/office/drawing/2014/main" id="{F3660663-FF02-4003-B962-F37D23201866}"/>
               </a:ext>
             </a:extLst>
           </p:cNvPr>
@@ -5890,7 +6260,7 @@
     </p:spTree>
     <p:extLst>
       <p:ext uri="{BB962C8B-B14F-4D97-AF65-F5344CB8AC3E}">
-        <p14:creationId xmlns:p14="http://schemas.microsoft.com/office/powerpoint/2010/main" val="1986316776"/>
+        <p14:creationId xmlns:p14="http://schemas.microsoft.com/office/powerpoint/2010/main" val="925423096"/>
       </p:ext>
     </p:extLst>
   </p:cSld>
@@ -5921,7 +6291,7 @@
           <p:cNvPr id="27" name="">
             <a:extLst xmlns:a="http://schemas.openxmlformats.org/drawingml/2006/main">
               <a:ext uri="{FF2B5EF4-FFF2-40B4-BE49-F238E27FC236}">
-                <a16:creationId xmlns:a16="http://schemas.microsoft.com/office/drawing/2014/main" id="{54940F45-03A6-46EB-A4C8-D188C43CF174}"/>
+                <a16:creationId xmlns:a16="http://schemas.microsoft.com/office/drawing/2014/main" id="{82C929B2-D1FE-44DF-8E81-51582E900175}"/>
               </a:ext>
             </a:extLst>
           </p:cNvPr>
@@ -5953,7 +6323,7 @@
           <p:cNvPr id="26" name="">
             <a:extLst xmlns:a="http://schemas.openxmlformats.org/drawingml/2006/main">
               <a:ext uri="{FF2B5EF4-FFF2-40B4-BE49-F238E27FC236}">
-                <a16:creationId xmlns:a16="http://schemas.microsoft.com/office/drawing/2014/main" id="{DBA46C0A-7502-4022-BBAE-8CFBE8506FE1}"/>
+                <a16:creationId xmlns:a16="http://schemas.microsoft.com/office/drawing/2014/main" id="{21361021-02A2-440D-A7AE-B2E9CBEC313F}"/>
               </a:ext>
             </a:extLst>
           </p:cNvPr>
@@ -5985,7 +6355,7 @@
           <p:cNvPr id="25" name="">
             <a:extLst xmlns:a="http://schemas.openxmlformats.org/drawingml/2006/main">
               <a:ext uri="{FF2B5EF4-FFF2-40B4-BE49-F238E27FC236}">
-                <a16:creationId xmlns:a16="http://schemas.microsoft.com/office/drawing/2014/main" id="{59EEF0C0-1314-4562-8CC8-2D689A40FEA4}"/>
+                <a16:creationId xmlns:a16="http://schemas.microsoft.com/office/drawing/2014/main" id="{E7B71F08-10C2-4359-9ED6-F46409573EE9}"/>
               </a:ext>
             </a:extLst>
           </p:cNvPr>
@@ -6020,7 +6390,7 @@
           <p:cNvPr id="20" name="">
             <a:extLst xmlns:a="http://schemas.openxmlformats.org/drawingml/2006/main">
               <a:ext uri="{FF2B5EF4-FFF2-40B4-BE49-F238E27FC236}">
-                <a16:creationId xmlns:a16="http://schemas.microsoft.com/office/drawing/2014/main" id="{588E524A-0A47-4D02-B789-FE67136B842F}"/>
+                <a16:creationId xmlns:a16="http://schemas.microsoft.com/office/drawing/2014/main" id="{998F8435-C60C-438A-AE31-84F9141F0BFC}"/>
               </a:ext>
             </a:extLst>
           </p:cNvPr>
@@ -6055,7 +6425,7 @@
           <p:cNvPr id="19" name="">
             <a:extLst xmlns:a="http://schemas.openxmlformats.org/drawingml/2006/main">
               <a:ext uri="{FF2B5EF4-FFF2-40B4-BE49-F238E27FC236}">
-                <a16:creationId xmlns:a16="http://schemas.microsoft.com/office/drawing/2014/main" id="{91A5BEE4-D781-400D-A94D-9EE23E0F3F4A}"/>
+                <a16:creationId xmlns:a16="http://schemas.microsoft.com/office/drawing/2014/main" id="{746ECCAA-E093-4002-9B6F-18857C1F7FD1}"/>
               </a:ext>
             </a:extLst>
           </p:cNvPr>
@@ -6087,7 +6457,7 @@
           <p:cNvPr id="14" name="">
             <a:extLst xmlns:a="http://schemas.openxmlformats.org/drawingml/2006/main">
               <a:ext uri="{FF2B5EF4-FFF2-40B4-BE49-F238E27FC236}">
-                <a16:creationId xmlns:a16="http://schemas.microsoft.com/office/drawing/2014/main" id="{7AB54EEA-CA0D-40DF-BBBB-732650BC32C4}"/>
+                <a16:creationId xmlns:a16="http://schemas.microsoft.com/office/drawing/2014/main" id="{9CDF2364-8485-49F7-91DE-D0259AE30D5E}"/>
               </a:ext>
             </a:extLst>
           </p:cNvPr>
@@ -6119,7 +6489,7 @@
           <p:cNvPr id="13" name="">
             <a:extLst xmlns:a="http://schemas.openxmlformats.org/drawingml/2006/main">
               <a:ext uri="{FF2B5EF4-FFF2-40B4-BE49-F238E27FC236}">
-                <a16:creationId xmlns:a16="http://schemas.microsoft.com/office/drawing/2014/main" id="{2213C5B0-BF86-47FF-99A0-81D1FE29C6C2}"/>
+                <a16:creationId xmlns:a16="http://schemas.microsoft.com/office/drawing/2014/main" id="{C6ADF8CE-106B-485B-B0E5-2BE21322F2A3}"/>
               </a:ext>
             </a:extLst>
           </p:cNvPr>
@@ -6151,7 +6521,7 @@
           <p:cNvPr id="12" name="">
             <a:extLst xmlns:a="http://schemas.openxmlformats.org/drawingml/2006/main">
               <a:ext uri="{FF2B5EF4-FFF2-40B4-BE49-F238E27FC236}">
-                <a16:creationId xmlns:a16="http://schemas.microsoft.com/office/drawing/2014/main" id="{230E57BE-E77A-4394-A25C-D847C65A800A}"/>
+                <a16:creationId xmlns:a16="http://schemas.microsoft.com/office/drawing/2014/main" id="{F81219B4-436A-450D-9DF7-EE0D7AB32775}"/>
               </a:ext>
             </a:extLst>
           </p:cNvPr>
@@ -6183,7 +6553,7 @@
           <p:cNvPr id="11" name="">
             <a:extLst xmlns:a="http://schemas.openxmlformats.org/drawingml/2006/main">
               <a:ext uri="{FF2B5EF4-FFF2-40B4-BE49-F238E27FC236}">
-                <a16:creationId xmlns:a16="http://schemas.microsoft.com/office/drawing/2014/main" id="{D6E19A16-CA73-41DF-9565-4D3D142FE770}"/>
+                <a16:creationId xmlns:a16="http://schemas.microsoft.com/office/drawing/2014/main" id="{58B06EAD-96D4-480B-AEA8-CDB5CBCEB4C9}"/>
               </a:ext>
             </a:extLst>
           </p:cNvPr>
@@ -6215,7 +6585,7 @@
           <p:cNvPr id="10" name="">
             <a:extLst xmlns:a="http://schemas.openxmlformats.org/drawingml/2006/main">
               <a:ext uri="{FF2B5EF4-FFF2-40B4-BE49-F238E27FC236}">
-                <a16:creationId xmlns:a16="http://schemas.microsoft.com/office/drawing/2014/main" id="{9C0BFCEC-DB0F-4AA7-97CC-32177423ED60}"/>
+                <a16:creationId xmlns:a16="http://schemas.microsoft.com/office/drawing/2014/main" id="{AD2516A6-1DF1-4426-A794-600F87BA2C62}"/>
               </a:ext>
             </a:extLst>
           </p:cNvPr>
@@ -6247,7 +6617,7 @@
           <p:cNvPr id="30" name="title">
             <a:extLst xmlns:a="http://schemas.openxmlformats.org/drawingml/2006/main">
               <a:ext uri="{FF2B5EF4-FFF2-40B4-BE49-F238E27FC236}">
-                <a16:creationId xmlns:a16="http://schemas.microsoft.com/office/drawing/2014/main" id="{35D71FC5-37C6-4264-A53F-7D652A7354ED}"/>
+                <a16:creationId xmlns:a16="http://schemas.microsoft.com/office/drawing/2014/main" id="{21DE2603-A5C5-4D97-946C-CE9C1F7E805A}"/>
               </a:ext>
             </a:extLst>
           </p:cNvPr>
@@ -6315,7 +6685,7 @@
           <p:cNvPr id="2" name="page">
             <a:extLst xmlns:a="http://schemas.openxmlformats.org/drawingml/2006/main">
               <a:ext uri="{FF2B5EF4-FFF2-40B4-BE49-F238E27FC236}">
-                <a16:creationId xmlns:a16="http://schemas.microsoft.com/office/drawing/2014/main" id="{5124C28E-CA74-45AE-84DA-1826D91BD8F5}"/>
+                <a16:creationId xmlns:a16="http://schemas.microsoft.com/office/drawing/2014/main" id="{579A8990-A282-456F-9919-D4BFA4549661}"/>
               </a:ext>
             </a:extLst>
           </p:cNvPr>
@@ -6383,7 +6753,7 @@
           <p:cNvPr id="3" name="caption">
             <a:extLst xmlns:a="http://schemas.openxmlformats.org/drawingml/2006/main">
               <a:ext uri="{FF2B5EF4-FFF2-40B4-BE49-F238E27FC236}">
-                <a16:creationId xmlns:a16="http://schemas.microsoft.com/office/drawing/2014/main" id="{6D3B3AFF-E522-4B26-9B49-D04D7DE6BE64}"/>
+                <a16:creationId xmlns:a16="http://schemas.microsoft.com/office/drawing/2014/main" id="{D173EC6E-2AE5-4E83-B233-BE1650204E00}"/>
               </a:ext>
             </a:extLst>
           </p:cNvPr>
@@ -6451,7 +6821,7 @@
           <p:cNvPr id="4" name="sync">
             <a:extLst xmlns:a="http://schemas.openxmlformats.org/drawingml/2006/main">
               <a:ext uri="{FF2B5EF4-FFF2-40B4-BE49-F238E27FC236}">
-                <a16:creationId xmlns:a16="http://schemas.microsoft.com/office/drawing/2014/main" id="{15FFA44D-CEF4-407E-A487-A9CD3F6ECA72}"/>
+                <a16:creationId xmlns:a16="http://schemas.microsoft.com/office/drawing/2014/main" id="{F494DDA8-FBAE-4632-9F92-74C8ADB8B1D2}"/>
               </a:ext>
             </a:extLst>
           </p:cNvPr>
@@ -6572,7 +6942,7 @@
           <p:cNvPr id="5" name="intent">
             <a:extLst xmlns:a="http://schemas.openxmlformats.org/drawingml/2006/main">
               <a:ext uri="{FF2B5EF4-FFF2-40B4-BE49-F238E27FC236}">
-                <a16:creationId xmlns:a16="http://schemas.microsoft.com/office/drawing/2014/main" id="{FB280746-BDB3-40EA-997B-79C71305DA1D}"/>
+                <a16:creationId xmlns:a16="http://schemas.microsoft.com/office/drawing/2014/main" id="{E5CA06D3-B2DA-42CA-8BB8-CA7EB6261D45}"/>
               </a:ext>
             </a:extLst>
           </p:cNvPr>
@@ -6693,7 +7063,7 @@
           <p:cNvPr id="6" name="triage">
             <a:extLst xmlns:a="http://schemas.openxmlformats.org/drawingml/2006/main">
               <a:ext uri="{FF2B5EF4-FFF2-40B4-BE49-F238E27FC236}">
-                <a16:creationId xmlns:a16="http://schemas.microsoft.com/office/drawing/2014/main" id="{DFA98F80-9F4F-4F81-8AEF-1F32C197391A}"/>
+                <a16:creationId xmlns:a16="http://schemas.microsoft.com/office/drawing/2014/main" id="{697F1A60-B08E-4D27-BF93-FE0BB905D563}"/>
               </a:ext>
             </a:extLst>
           </p:cNvPr>
@@ -6814,7 +7184,7 @@
           <p:cNvPr id="7" name="case">
             <a:extLst xmlns:a="http://schemas.openxmlformats.org/drawingml/2006/main">
               <a:ext uri="{FF2B5EF4-FFF2-40B4-BE49-F238E27FC236}">
-                <a16:creationId xmlns:a16="http://schemas.microsoft.com/office/drawing/2014/main" id="{F545EAAE-C784-4C08-AA06-AC86AB54AA0E}"/>
+                <a16:creationId xmlns:a16="http://schemas.microsoft.com/office/drawing/2014/main" id="{B7D233FD-FAC8-4C74-865C-F8319C3A336A}"/>
               </a:ext>
             </a:extLst>
           </p:cNvPr>
@@ -6935,7 +7305,7 @@
           <p:cNvPr id="8" name="overview">
             <a:extLst xmlns:a="http://schemas.openxmlformats.org/drawingml/2006/main">
               <a:ext uri="{FF2B5EF4-FFF2-40B4-BE49-F238E27FC236}">
-                <a16:creationId xmlns:a16="http://schemas.microsoft.com/office/drawing/2014/main" id="{8BFC5762-6032-4512-9EC4-644C49B8EE7A}"/>
+                <a16:creationId xmlns:a16="http://schemas.microsoft.com/office/drawing/2014/main" id="{3EC45513-F6FB-4AE9-929D-6B424A87EBE4}"/>
               </a:ext>
             </a:extLst>
           </p:cNvPr>
@@ -7056,7 +7426,7 @@
           <p:cNvPr id="9" name="progress">
             <a:extLst xmlns:a="http://schemas.openxmlformats.org/drawingml/2006/main">
               <a:ext uri="{FF2B5EF4-FFF2-40B4-BE49-F238E27FC236}">
-                <a16:creationId xmlns:a16="http://schemas.microsoft.com/office/drawing/2014/main" id="{584D3CC9-F9D8-4DB8-AA43-20FDF0C23A59}"/>
+                <a16:creationId xmlns:a16="http://schemas.microsoft.com/office/drawing/2014/main" id="{9D51B2B9-3EE8-4FCF-9A58-A55A47535D18}"/>
               </a:ext>
             </a:extLst>
           </p:cNvPr>
@@ -7177,7 +7547,7 @@
           <p:cNvPr id="15" name="mail-input">
             <a:extLst xmlns:a="http://schemas.openxmlformats.org/drawingml/2006/main">
               <a:ext uri="{FF2B5EF4-FFF2-40B4-BE49-F238E27FC236}">
-                <a16:creationId xmlns:a16="http://schemas.microsoft.com/office/drawing/2014/main" id="{EFF2FD8D-8BAB-409C-AF11-D4F94621D02B}"/>
+                <a16:creationId xmlns:a16="http://schemas.microsoft.com/office/drawing/2014/main" id="{898B1138-931A-47D0-80FE-9524B4C79F35}"/>
               </a:ext>
             </a:extLst>
           </p:cNvPr>
@@ -7245,7 +7615,7 @@
           <p:cNvPr id="16" name="playbook-label">
             <a:extLst xmlns:a="http://schemas.openxmlformats.org/drawingml/2006/main">
               <a:ext uri="{FF2B5EF4-FFF2-40B4-BE49-F238E27FC236}">
-                <a16:creationId xmlns:a16="http://schemas.microsoft.com/office/drawing/2014/main" id="{B7A31FF5-713C-42EF-862A-68278A8FE095}"/>
+                <a16:creationId xmlns:a16="http://schemas.microsoft.com/office/drawing/2014/main" id="{0533B342-AA5F-42D6-ABE6-0EFAC993F6B4}"/>
               </a:ext>
             </a:extLst>
           </p:cNvPr>
@@ -7313,7 +7683,7 @@
           <p:cNvPr id="17" name="author">
             <a:extLst xmlns:a="http://schemas.openxmlformats.org/drawingml/2006/main">
               <a:ext uri="{FF2B5EF4-FFF2-40B4-BE49-F238E27FC236}">
-                <a16:creationId xmlns:a16="http://schemas.microsoft.com/office/drawing/2014/main" id="{0B46026A-DA7C-4D14-98B2-762295D5CFC6}"/>
+                <a16:creationId xmlns:a16="http://schemas.microsoft.com/office/drawing/2014/main" id="{0837309D-D50F-40E8-B7C0-EDE28117D6C9}"/>
               </a:ext>
             </a:extLst>
           </p:cNvPr>
@@ -7434,7 +7804,7 @@
           <p:cNvPr id="18" name="rules">
             <a:extLst xmlns:a="http://schemas.openxmlformats.org/drawingml/2006/main">
               <a:ext uri="{FF2B5EF4-FFF2-40B4-BE49-F238E27FC236}">
-                <a16:creationId xmlns:a16="http://schemas.microsoft.com/office/drawing/2014/main" id="{87235340-E592-4DFC-A6B6-7E89F5B2C657}"/>
+                <a16:creationId xmlns:a16="http://schemas.microsoft.com/office/drawing/2014/main" id="{3D8D6C8D-11CD-4030-817B-4DC2A6FBFEC0}"/>
               </a:ext>
             </a:extLst>
           </p:cNvPr>
@@ -7555,7 +7925,7 @@
           <p:cNvPr id="21" name="reply-label">
             <a:extLst xmlns:a="http://schemas.openxmlformats.org/drawingml/2006/main">
               <a:ext uri="{FF2B5EF4-FFF2-40B4-BE49-F238E27FC236}">
-                <a16:creationId xmlns:a16="http://schemas.microsoft.com/office/drawing/2014/main" id="{6236A327-98D4-4517-8396-300D725D1272}"/>
+                <a16:creationId xmlns:a16="http://schemas.microsoft.com/office/drawing/2014/main" id="{CA473A08-88A7-449D-9588-ECC13F0F63BD}"/>
               </a:ext>
             </a:extLst>
           </p:cNvPr>
@@ -7623,7 +7993,7 @@
           <p:cNvPr id="22" name="generate">
             <a:extLst xmlns:a="http://schemas.openxmlformats.org/drawingml/2006/main">
               <a:ext uri="{FF2B5EF4-FFF2-40B4-BE49-F238E27FC236}">
-                <a16:creationId xmlns:a16="http://schemas.microsoft.com/office/drawing/2014/main" id="{9B2E530A-7FD6-4525-B60A-FF67943E2BDD}"/>
+                <a16:creationId xmlns:a16="http://schemas.microsoft.com/office/drawing/2014/main" id="{1947AC8A-5258-498D-9E2D-C01FBE9DF112}"/>
               </a:ext>
             </a:extLst>
           </p:cNvPr>
@@ -7744,7 +8114,7 @@
           <p:cNvPr id="23" name="review">
             <a:extLst xmlns:a="http://schemas.openxmlformats.org/drawingml/2006/main">
               <a:ext uri="{FF2B5EF4-FFF2-40B4-BE49-F238E27FC236}">
-                <a16:creationId xmlns:a16="http://schemas.microsoft.com/office/drawing/2014/main" id="{15593FD0-8D3D-428C-8567-AC646CCE6405}"/>
+                <a16:creationId xmlns:a16="http://schemas.microsoft.com/office/drawing/2014/main" id="{B7C30FEC-29C3-4C58-A4BD-FD3AF6E56E84}"/>
               </a:ext>
             </a:extLst>
           </p:cNvPr>
@@ -7865,7 +8235,7 @@
           <p:cNvPr id="24" name="send">
             <a:extLst xmlns:a="http://schemas.openxmlformats.org/drawingml/2006/main">
               <a:ext uri="{FF2B5EF4-FFF2-40B4-BE49-F238E27FC236}">
-                <a16:creationId xmlns:a16="http://schemas.microsoft.com/office/drawing/2014/main" id="{6C194048-517E-4A60-98E8-B1B550832734}"/>
+                <a16:creationId xmlns:a16="http://schemas.microsoft.com/office/drawing/2014/main" id="{D04FAEF2-C86E-4EA5-A6C1-48E911AF7866}"/>
               </a:ext>
             </a:extLst>
           </p:cNvPr>
@@ -7986,7 +8356,7 @@
           <p:cNvPr id="28" name="legend">
             <a:extLst xmlns:a="http://schemas.openxmlformats.org/drawingml/2006/main">
               <a:ext uri="{FF2B5EF4-FFF2-40B4-BE49-F238E27FC236}">
-                <a16:creationId xmlns:a16="http://schemas.microsoft.com/office/drawing/2014/main" id="{B1AD9598-C1EF-4188-ABAA-CD9F934C2EB3}"/>
+                <a16:creationId xmlns:a16="http://schemas.microsoft.com/office/drawing/2014/main" id="{FFE18842-1224-46A9-8974-1AC4AECBA2F8}"/>
               </a:ext>
             </a:extLst>
           </p:cNvPr>
@@ -8054,7 +8424,7 @@
           <p:cNvPr id="29" name="boundary">
             <a:extLst xmlns:a="http://schemas.openxmlformats.org/drawingml/2006/main">
               <a:ext uri="{FF2B5EF4-FFF2-40B4-BE49-F238E27FC236}">
-                <a16:creationId xmlns:a16="http://schemas.microsoft.com/office/drawing/2014/main" id="{DDE9888C-EEB2-431D-9EC2-DC2FA656C5D7}"/>
+                <a16:creationId xmlns:a16="http://schemas.microsoft.com/office/drawing/2014/main" id="{176B82A5-C5D9-42DA-AE65-A41B2F185744}"/>
               </a:ext>
             </a:extLst>
           </p:cNvPr>
@@ -8065,8 +8435,8 @@
         </p:nvSpPr>
         <p:spPr>
           <a:xfrm xmlns:a="http://schemas.openxmlformats.org/drawingml/2006/main">
-            <a:off x="609600" y="7734300"/>
-            <a:ext cx="13906500" cy="428625"/>
+            <a:off x="609600" y="7639050"/>
+            <a:ext cx="13144500" cy="666750"/>
           </a:xfrm>
           <a:prstGeom xmlns:a="http://schemas.openxmlformats.org/drawingml/2006/main" prst="rect">
             <a:avLst/>
@@ -8112,7 +8482,30 @@
                 <a:ea typeface="Arial"/>
                 <a:cs typeface="Arial"/>
               </a:rPr>
-              <a:t>All processing modules run in one Java backend. AMs approve replies. Sending and Open Item completion remain separate.</a:t>
+              <a:t>All modules share one Java backend. Java checks role permissions and business group / region / customer scope.</a:t>
+            </a:r>
+          </a:p>
+          <a:p xmlns:a="http://schemas.openxmlformats.org/drawingml/2006/main">
+            <a:pPr algn="l">
+              <a:defRPr sz="1725" b="0">
+                <a:solidFill>
+                  <a:srgbClr val="132B45"/>
+                </a:solidFill>
+                <a:latin typeface="Arial"/>
+                <a:ea typeface="Arial"/>
+                <a:cs typeface="Arial"/>
+              </a:defRPr>
+            </a:pPr>
+            <a:r>
+              <a:rPr sz="1725" b="0">
+                <a:solidFill>
+                  <a:srgbClr val="132B45"/>
+                </a:solidFill>
+                <a:latin typeface="Arial"/>
+                <a:ea typeface="Arial"/>
+                <a:cs typeface="Arial"/>
+              </a:rPr>
+              <a:t>AM approval precedes sending. Sending and Open Item completion remain separate.</a:t>
             </a:r>
           </a:p>
         </p:txBody>
@@ -8120,7 +8513,7 @@
     </p:spTree>
     <p:extLst>
       <p:ext uri="{BB962C8B-B14F-4D97-AF65-F5344CB8AC3E}">
-        <p14:creationId xmlns:p14="http://schemas.microsoft.com/office/powerpoint/2010/main" val="429788700"/>
+        <p14:creationId xmlns:p14="http://schemas.microsoft.com/office/powerpoint/2010/main" val="1609199717"/>
       </p:ext>
     </p:extLst>
   </p:cSld>
@@ -8151,7 +8544,7 @@
           <p:cNvPr id="30" name="">
             <a:extLst xmlns:a="http://schemas.openxmlformats.org/drawingml/2006/main">
               <a:ext uri="{FF2B5EF4-FFF2-40B4-BE49-F238E27FC236}">
-                <a16:creationId xmlns:a16="http://schemas.microsoft.com/office/drawing/2014/main" id="{15A69874-5D04-4267-9F59-A970E2100C21}"/>
+                <a16:creationId xmlns:a16="http://schemas.microsoft.com/office/drawing/2014/main" id="{D594FB77-2A1A-4275-BC1D-F36859F5FF3B}"/>
               </a:ext>
             </a:extLst>
           </p:cNvPr>
@@ -8183,7 +8576,7 @@
           <p:cNvPr id="20" name="">
             <a:extLst xmlns:a="http://schemas.openxmlformats.org/drawingml/2006/main">
               <a:ext uri="{FF2B5EF4-FFF2-40B4-BE49-F238E27FC236}">
-                <a16:creationId xmlns:a16="http://schemas.microsoft.com/office/drawing/2014/main" id="{200047FA-1641-4D75-BB48-BF7555217990}"/>
+                <a16:creationId xmlns:a16="http://schemas.microsoft.com/office/drawing/2014/main" id="{82054B62-C5B8-4E44-A1C2-EFFA42DE95E0}"/>
               </a:ext>
             </a:extLst>
           </p:cNvPr>
@@ -8217,7 +8610,7 @@
           <p:cNvPr id="18" name="">
             <a:extLst xmlns:a="http://schemas.openxmlformats.org/drawingml/2006/main">
               <a:ext uri="{FF2B5EF4-FFF2-40B4-BE49-F238E27FC236}">
-                <a16:creationId xmlns:a16="http://schemas.microsoft.com/office/drawing/2014/main" id="{F1D3015F-E3F3-4610-96A1-53B2CEB1950B}"/>
+                <a16:creationId xmlns:a16="http://schemas.microsoft.com/office/drawing/2014/main" id="{390A424C-6C72-4B66-8ACE-0B28A2FCEFFA}"/>
               </a:ext>
             </a:extLst>
           </p:cNvPr>
@@ -8229,8 +8622,8 @@
         </p:nvCxnSpPr>
         <p:spPr>
           <a:xfrm xmlns:a="http://schemas.openxmlformats.org/drawingml/2006/main" flipH="1" flipV="1">
-            <a:off x="3467100" y="4419600"/>
-            <a:ext cx="2028825" cy="666750"/>
+            <a:off x="3467100" y="4514850"/>
+            <a:ext cx="2028825" cy="571500"/>
           </a:xfrm>
           <a:prstGeom xmlns:a="http://schemas.openxmlformats.org/drawingml/2006/main" prst="bentConnector3">
             <a:avLst>
@@ -8251,7 +8644,7 @@
           <p:cNvPr id="16" name="">
             <a:extLst xmlns:a="http://schemas.openxmlformats.org/drawingml/2006/main">
               <a:ext uri="{FF2B5EF4-FFF2-40B4-BE49-F238E27FC236}">
-                <a16:creationId xmlns:a16="http://schemas.microsoft.com/office/drawing/2014/main" id="{F1914095-39D8-4835-AD92-7E9F3F67A1D9}"/>
+                <a16:creationId xmlns:a16="http://schemas.microsoft.com/office/drawing/2014/main" id="{BF21341A-3FDE-49F7-9254-A0DA3ACA0313}"/>
               </a:ext>
             </a:extLst>
           </p:cNvPr>
@@ -8283,7 +8676,7 @@
           <p:cNvPr id="14" name="">
             <a:extLst xmlns:a="http://schemas.openxmlformats.org/drawingml/2006/main">
               <a:ext uri="{FF2B5EF4-FFF2-40B4-BE49-F238E27FC236}">
-                <a16:creationId xmlns:a16="http://schemas.microsoft.com/office/drawing/2014/main" id="{5C50CF8A-E554-49D6-9BFA-A7C5FA0B2372}"/>
+                <a16:creationId xmlns:a16="http://schemas.microsoft.com/office/drawing/2014/main" id="{12514041-DAF5-4F35-A746-8A04F7A8EBA4}"/>
               </a:ext>
             </a:extLst>
           </p:cNvPr>
@@ -8315,7 +8708,7 @@
           <p:cNvPr id="36" name="title">
             <a:extLst xmlns:a="http://schemas.openxmlformats.org/drawingml/2006/main">
               <a:ext uri="{FF2B5EF4-FFF2-40B4-BE49-F238E27FC236}">
-                <a16:creationId xmlns:a16="http://schemas.microsoft.com/office/drawing/2014/main" id="{A2448855-CDCD-4DD9-B567-080731CDF45F}"/>
+                <a16:creationId xmlns:a16="http://schemas.microsoft.com/office/drawing/2014/main" id="{A2A63750-A305-4ACF-8D90-28424FFBA51A}"/>
               </a:ext>
             </a:extLst>
           </p:cNvPr>
@@ -8383,7 +8776,7 @@
           <p:cNvPr id="2" name="page">
             <a:extLst xmlns:a="http://schemas.openxmlformats.org/drawingml/2006/main">
               <a:ext uri="{FF2B5EF4-FFF2-40B4-BE49-F238E27FC236}">
-                <a16:creationId xmlns:a16="http://schemas.microsoft.com/office/drawing/2014/main" id="{61977266-98CD-4B04-9BBC-DD0A6A60933C}"/>
+                <a16:creationId xmlns:a16="http://schemas.microsoft.com/office/drawing/2014/main" id="{36AA7C6D-62E1-4579-8836-99A62000DD45}"/>
               </a:ext>
             </a:extLst>
           </p:cNvPr>
@@ -8451,7 +8844,7 @@
           <p:cNvPr id="3" name="caption">
             <a:extLst xmlns:a="http://schemas.openxmlformats.org/drawingml/2006/main">
               <a:ext uri="{FF2B5EF4-FFF2-40B4-BE49-F238E27FC236}">
-                <a16:creationId xmlns:a16="http://schemas.microsoft.com/office/drawing/2014/main" id="{24F62221-EB02-44F4-98CF-5BAEC33B4B41}"/>
+                <a16:creationId xmlns:a16="http://schemas.microsoft.com/office/drawing/2014/main" id="{7DE27461-4E1C-4EBD-9663-B97630E38248}"/>
               </a:ext>
             </a:extLst>
           </p:cNvPr>
@@ -8519,7 +8912,7 @@
           <p:cNvPr id="4" name="am">
             <a:extLst xmlns:a="http://schemas.openxmlformats.org/drawingml/2006/main">
               <a:ext uri="{FF2B5EF4-FFF2-40B4-BE49-F238E27FC236}">
-                <a16:creationId xmlns:a16="http://schemas.microsoft.com/office/drawing/2014/main" id="{2B32F500-20CA-4468-831C-A460B10FBDAB}"/>
+                <a16:creationId xmlns:a16="http://schemas.microsoft.com/office/drawing/2014/main" id="{5FBDBADA-E048-414F-A9B4-7982ABA84105}"/>
               </a:ext>
             </a:extLst>
           </p:cNvPr>
@@ -8586,7 +8979,7 @@
                 <a:ea typeface="Arial"/>
                 <a:cs typeface="Arial"/>
               </a:rPr>
-              <a:t>Local / Regional AM</a:t>
+              <a:t>AM / Director / Admin</a:t>
             </a:r>
           </a:p>
           <a:p xmlns:a="http://schemas.openxmlformats.org/drawingml/2006/main">
@@ -8619,7 +9012,7 @@
           <p:cNvPr id="5" name="portal">
             <a:extLst xmlns:a="http://schemas.openxmlformats.org/drawingml/2006/main">
               <a:ext uri="{FF2B5EF4-FFF2-40B4-BE49-F238E27FC236}">
-                <a16:creationId xmlns:a16="http://schemas.microsoft.com/office/drawing/2014/main" id="{BD8EB1F9-B988-4897-9133-628D8FD0FBCE}"/>
+                <a16:creationId xmlns:a16="http://schemas.microsoft.com/office/drawing/2014/main" id="{76BDBA33-5473-4C74-82B0-B20B355F64C7}"/>
               </a:ext>
             </a:extLst>
           </p:cNvPr>
@@ -8719,7 +9112,7 @@
           <p:cNvPr id="6" name="java">
             <a:extLst xmlns:a="http://schemas.openxmlformats.org/drawingml/2006/main">
               <a:ext uri="{FF2B5EF4-FFF2-40B4-BE49-F238E27FC236}">
-                <a16:creationId xmlns:a16="http://schemas.microsoft.com/office/drawing/2014/main" id="{78165782-3F5C-4476-945F-DED891EE7645}"/>
+                <a16:creationId xmlns:a16="http://schemas.microsoft.com/office/drawing/2014/main" id="{75F9C9A1-E413-4593-89E0-6F8504154C92}"/>
               </a:ext>
             </a:extLst>
           </p:cNvPr>
@@ -8830,7 +9223,7 @@
                 <a:ea typeface="Arial"/>
                 <a:cs typeface="Arial"/>
               </a:rPr>
-              <a:t>HTTP: APIs, Cases and approvals</a:t>
+              <a:t>APIs, async jobs and approved sends</a:t>
             </a:r>
             <a:br>
               <a:rPr sz="1800">
@@ -8851,7 +9244,7 @@
                 <a:ea typeface="Arial"/>
                 <a:cs typeface="Arial"/>
               </a:rPr>
-              <a:t>Async: mail sync and AI generation</a:t>
+              <a:t>RBAC and data-scope enforcement</a:t>
             </a:r>
             <a:br>
               <a:rPr sz="1800">
@@ -8872,7 +9265,7 @@
                 <a:ea typeface="Arial"/>
                 <a:cs typeface="Arial"/>
               </a:rPr>
-              <a:t>Dispatch: approved sends and reconciliation</a:t>
+              <a:t>Every API request and async job</a:t>
             </a:r>
           </a:p>
         </p:txBody>
@@ -8882,7 +9275,7 @@
           <p:cNvPr id="7" name="okta">
             <a:extLst xmlns:a="http://schemas.openxmlformats.org/drawingml/2006/main">
               <a:ext uri="{FF2B5EF4-FFF2-40B4-BE49-F238E27FC236}">
-                <a16:creationId xmlns:a16="http://schemas.microsoft.com/office/drawing/2014/main" id="{A7F359CF-F944-4571-A308-ECC3EE10C2B2}"/>
+                <a16:creationId xmlns:a16="http://schemas.microsoft.com/office/drawing/2014/main" id="{85FD9B7E-7AFE-4AE5-9210-51F3579FF210}"/>
               </a:ext>
             </a:extLst>
           </p:cNvPr>
@@ -8894,11 +9287,11 @@
         <p:spPr>
           <a:xfrm xmlns:a="http://schemas.openxmlformats.org/drawingml/2006/main">
             <a:off x="609600" y="3943350"/>
-            <a:ext cx="2857500" cy="952500"/>
+            <a:ext cx="2857500" cy="1143000"/>
           </a:xfrm>
           <a:prstGeom xmlns:a="http://schemas.openxmlformats.org/drawingml/2006/main" prst="roundRect">
             <a:avLst>
-              <a:gd name="adj" fmla="val 10000"/>
+              <a:gd name="adj" fmla="val 8333"/>
             </a:avLst>
           </a:prstGeom>
           <a:solidFill xmlns:a="http://schemas.openxmlformats.org/drawingml/2006/main">
@@ -8972,7 +9365,28 @@
                 <a:ea typeface="Arial"/>
                 <a:cs typeface="Arial"/>
               </a:rPr>
-              <a:t>Authentication and MFA</a:t>
+              <a:t>SSO / MFA</a:t>
+            </a:r>
+            <a:br>
+              <a:rPr sz="1800">
+                <a:solidFill>
+                  <a:srgbClr val="132B45"/>
+                </a:solidFill>
+                <a:latin typeface="Arial"/>
+                <a:ea typeface="Arial"/>
+                <a:cs typeface="Arial"/>
+              </a:rPr>
+            </a:br>
+            <a:r>
+              <a:rPr sz="1800">
+                <a:solidFill>
+                  <a:srgbClr val="132B45"/>
+                </a:solidFill>
+                <a:latin typeface="Arial"/>
+                <a:ea typeface="Arial"/>
+                <a:cs typeface="Arial"/>
+              </a:rPr>
+              <a:t>AAM role groups</a:t>
             </a:r>
           </a:p>
         </p:txBody>
@@ -8982,7 +9396,7 @@
           <p:cNvPr id="8" name="entra">
             <a:extLst xmlns:a="http://schemas.openxmlformats.org/drawingml/2006/main">
               <a:ext uri="{FF2B5EF4-FFF2-40B4-BE49-F238E27FC236}">
-                <a16:creationId xmlns:a16="http://schemas.microsoft.com/office/drawing/2014/main" id="{00343856-E355-4828-92F6-D5560C058F59}"/>
+                <a16:creationId xmlns:a16="http://schemas.microsoft.com/office/drawing/2014/main" id="{4AABA699-1D61-43A7-95B8-DB8D7C171811}"/>
               </a:ext>
             </a:extLst>
           </p:cNvPr>
@@ -9103,7 +9517,7 @@
           <p:cNvPr id="9" name="graph">
             <a:extLst xmlns:a="http://schemas.openxmlformats.org/drawingml/2006/main">
               <a:ext uri="{FF2B5EF4-FFF2-40B4-BE49-F238E27FC236}">
-                <a16:creationId xmlns:a16="http://schemas.microsoft.com/office/drawing/2014/main" id="{126DD8BC-5797-4B0E-A259-A01F5D5542DA}"/>
+                <a16:creationId xmlns:a16="http://schemas.microsoft.com/office/drawing/2014/main" id="{C2A7EF92-2088-4E03-BDFE-2F8E6B4D465A}"/>
               </a:ext>
             </a:extLst>
           </p:cNvPr>
@@ -9203,7 +9617,7 @@
           <p:cNvPr id="10" name="foundry">
             <a:extLst xmlns:a="http://schemas.openxmlformats.org/drawingml/2006/main">
               <a:ext uri="{FF2B5EF4-FFF2-40B4-BE49-F238E27FC236}">
-                <a16:creationId xmlns:a16="http://schemas.microsoft.com/office/drawing/2014/main" id="{6360F876-89C5-4FA6-9F31-05F8186FCAB7}"/>
+                <a16:creationId xmlns:a16="http://schemas.microsoft.com/office/drawing/2014/main" id="{8384C5C3-09FC-4EC3-9E63-8FC85C7996AF}"/>
               </a:ext>
             </a:extLst>
           </p:cNvPr>
@@ -9324,7 +9738,7 @@
           <p:cNvPr id="11" name="blob">
             <a:extLst xmlns:a="http://schemas.openxmlformats.org/drawingml/2006/main">
               <a:ext uri="{FF2B5EF4-FFF2-40B4-BE49-F238E27FC236}">
-                <a16:creationId xmlns:a16="http://schemas.microsoft.com/office/drawing/2014/main" id="{B9BF3A8A-C00C-4FFF-81A2-98CCE792B703}"/>
+                <a16:creationId xmlns:a16="http://schemas.microsoft.com/office/drawing/2014/main" id="{E006D3C6-510C-4928-8C81-EB354D9EF974}"/>
               </a:ext>
             </a:extLst>
           </p:cNvPr>
@@ -9445,7 +9859,7 @@
           <p:cNvPr id="12" name="postgres">
             <a:extLst xmlns:a="http://schemas.openxmlformats.org/drawingml/2006/main">
               <a:ext uri="{FF2B5EF4-FFF2-40B4-BE49-F238E27FC236}">
-                <a16:creationId xmlns:a16="http://schemas.microsoft.com/office/drawing/2014/main" id="{C35D0CD9-3726-4013-B16C-156958BA8792}"/>
+                <a16:creationId xmlns:a16="http://schemas.microsoft.com/office/drawing/2014/main" id="{2DFFAC62-EDB1-4C8B-B2B9-EC90073BEB99}"/>
               </a:ext>
             </a:extLst>
           </p:cNvPr>
@@ -9535,7 +9949,7 @@
                 <a:ea typeface="Arial"/>
                 <a:cs typeface="Arial"/>
               </a:rPr>
-              <a:t>Cases, shared sessions, durable jobs,</a:t>
+              <a:t>Cases, jobs, sessions and audit</a:t>
             </a:r>
             <a:br>
               <a:rPr sz="1800">
@@ -9556,7 +9970,7 @@
                 <a:ea typeface="Arial"/>
                 <a:cs typeface="Arial"/>
               </a:rPr>
-              <a:t>sync cursors, audit and idempotency</a:t>
+              <a:t>Business data-scope bindings</a:t>
             </a:r>
           </a:p>
         </p:txBody>
@@ -9566,7 +9980,7 @@
           <p:cNvPr id="13" name="monitor">
             <a:extLst xmlns:a="http://schemas.openxmlformats.org/drawingml/2006/main">
               <a:ext uri="{FF2B5EF4-FFF2-40B4-BE49-F238E27FC236}">
-                <a16:creationId xmlns:a16="http://schemas.microsoft.com/office/drawing/2014/main" id="{96A3BA5A-2168-4A0D-AC05-7746037D9848}"/>
+                <a16:creationId xmlns:a16="http://schemas.microsoft.com/office/drawing/2014/main" id="{8EAE3103-25A3-461E-8D35-8110757C556D}"/>
               </a:ext>
             </a:extLst>
           </p:cNvPr>
@@ -9687,7 +10101,7 @@
           <p:cNvPr id="15" name="https">
             <a:extLst xmlns:a="http://schemas.openxmlformats.org/drawingml/2006/main">
               <a:ext uri="{FF2B5EF4-FFF2-40B4-BE49-F238E27FC236}">
-                <a16:creationId xmlns:a16="http://schemas.microsoft.com/office/drawing/2014/main" id="{1BC1826D-C26A-4725-A7A9-93D94F36C44F}"/>
+                <a16:creationId xmlns:a16="http://schemas.microsoft.com/office/drawing/2014/main" id="{EBB8B441-40DA-49F2-BCE1-C0C55EC1385F}"/>
               </a:ext>
             </a:extLst>
           </p:cNvPr>
@@ -9755,7 +10169,7 @@
           <p:cNvPr id="17" name="http">
             <a:extLst xmlns:a="http://schemas.openxmlformats.org/drawingml/2006/main">
               <a:ext uri="{FF2B5EF4-FFF2-40B4-BE49-F238E27FC236}">
-                <a16:creationId xmlns:a16="http://schemas.microsoft.com/office/drawing/2014/main" id="{EC3A7673-96B2-4D17-8D8D-22B0A80C3DB7}"/>
+                <a16:creationId xmlns:a16="http://schemas.microsoft.com/office/drawing/2014/main" id="{476A17B0-7A7E-402A-9FC9-F7333914CED9}"/>
               </a:ext>
             </a:extLst>
           </p:cNvPr>
@@ -9823,7 +10237,7 @@
           <p:cNvPr id="19" name="sso">
             <a:extLst xmlns:a="http://schemas.openxmlformats.org/drawingml/2006/main">
               <a:ext uri="{FF2B5EF4-FFF2-40B4-BE49-F238E27FC236}">
-                <a16:creationId xmlns:a16="http://schemas.microsoft.com/office/drawing/2014/main" id="{CE63AC84-A442-4696-8A57-299BAEA2DE50}"/>
+                <a16:creationId xmlns:a16="http://schemas.microsoft.com/office/drawing/2014/main" id="{7F6EDADB-B0FB-40FD-90D2-4E60DB017EEF}"/>
               </a:ext>
             </a:extLst>
           </p:cNvPr>
@@ -9881,7 +10295,7 @@
                 <a:ea typeface="Arial"/>
                 <a:cs typeface="Arial"/>
               </a:rPr>
-              <a:t>OIDC / SSO</a:t>
+              <a:t>SSO / groups</a:t>
             </a:r>
           </a:p>
         </p:txBody>
@@ -9891,7 +10305,7 @@
           <p:cNvPr id="21" name="graph-call-1">
             <a:extLst xmlns:a="http://schemas.openxmlformats.org/drawingml/2006/main">
               <a:ext uri="{FF2B5EF4-FFF2-40B4-BE49-F238E27FC236}">
-                <a16:creationId xmlns:a16="http://schemas.microsoft.com/office/drawing/2014/main" id="{9DE5CE6A-AB37-4863-AC0D-5393B6C4E98A}"/>
+                <a16:creationId xmlns:a16="http://schemas.microsoft.com/office/drawing/2014/main" id="{C3F9AF3B-DAC4-49A3-9CA1-2262CE961D72}"/>
               </a:ext>
             </a:extLst>
           </p:cNvPr>
@@ -9919,7 +10333,7 @@
           <p:cNvPr id="22" name="graph-call-2">
             <a:extLst xmlns:a="http://schemas.openxmlformats.org/drawingml/2006/main">
               <a:ext uri="{FF2B5EF4-FFF2-40B4-BE49-F238E27FC236}">
-                <a16:creationId xmlns:a16="http://schemas.microsoft.com/office/drawing/2014/main" id="{D74B1FCA-2E31-42C1-AA40-2B5FD0E3CF2B}"/>
+                <a16:creationId xmlns:a16="http://schemas.microsoft.com/office/drawing/2014/main" id="{4B2D5952-016D-49F2-9935-6E8F5ED1A8F3}"/>
               </a:ext>
             </a:extLst>
           </p:cNvPr>
@@ -9947,7 +10361,7 @@
           <p:cNvPr id="23" name="graph-call-3">
             <a:extLst xmlns:a="http://schemas.openxmlformats.org/drawingml/2006/main">
               <a:ext uri="{FF2B5EF4-FFF2-40B4-BE49-F238E27FC236}">
-                <a16:creationId xmlns:a16="http://schemas.microsoft.com/office/drawing/2014/main" id="{A124C442-871E-4A66-A97B-F88745B8ADBF}"/>
+                <a16:creationId xmlns:a16="http://schemas.microsoft.com/office/drawing/2014/main" id="{BD9E9D83-0C60-44D6-A03B-FE8B9E440916}"/>
               </a:ext>
             </a:extLst>
           </p:cNvPr>
@@ -9976,7 +10390,7 @@
           <p:cNvPr id="24" name="model-call-1">
             <a:extLst xmlns:a="http://schemas.openxmlformats.org/drawingml/2006/main">
               <a:ext uri="{FF2B5EF4-FFF2-40B4-BE49-F238E27FC236}">
-                <a16:creationId xmlns:a16="http://schemas.microsoft.com/office/drawing/2014/main" id="{9FEF6C16-BB56-417B-80B5-D7164BD93416}"/>
+                <a16:creationId xmlns:a16="http://schemas.microsoft.com/office/drawing/2014/main" id="{877979B7-47F7-4234-A756-EABAD75F35CA}"/>
               </a:ext>
             </a:extLst>
           </p:cNvPr>
@@ -10004,7 +10418,7 @@
           <p:cNvPr id="25" name="model-call-2">
             <a:extLst xmlns:a="http://schemas.openxmlformats.org/drawingml/2006/main">
               <a:ext uri="{FF2B5EF4-FFF2-40B4-BE49-F238E27FC236}">
-                <a16:creationId xmlns:a16="http://schemas.microsoft.com/office/drawing/2014/main" id="{2A5CB260-E35E-48B1-A471-EDF4682F43CA}"/>
+                <a16:creationId xmlns:a16="http://schemas.microsoft.com/office/drawing/2014/main" id="{3B70F274-F552-4892-8CBA-F8BCB0E0DC58}"/>
               </a:ext>
             </a:extLst>
           </p:cNvPr>
@@ -10032,7 +10446,7 @@
           <p:cNvPr id="26" name="model-call-3">
             <a:extLst xmlns:a="http://schemas.openxmlformats.org/drawingml/2006/main">
               <a:ext uri="{FF2B5EF4-FFF2-40B4-BE49-F238E27FC236}">
-                <a16:creationId xmlns:a16="http://schemas.microsoft.com/office/drawing/2014/main" id="{56D2208E-D6B6-49C4-B449-7352D659D568}"/>
+                <a16:creationId xmlns:a16="http://schemas.microsoft.com/office/drawing/2014/main" id="{CB8D5564-A6BC-4122-BDDE-BA08A3A470FE}"/>
               </a:ext>
             </a:extLst>
           </p:cNvPr>
@@ -10061,7 +10475,7 @@
           <p:cNvPr id="27" name="artifact-call-1">
             <a:extLst xmlns:a="http://schemas.openxmlformats.org/drawingml/2006/main">
               <a:ext uri="{FF2B5EF4-FFF2-40B4-BE49-F238E27FC236}">
-                <a16:creationId xmlns:a16="http://schemas.microsoft.com/office/drawing/2014/main" id="{887DA42D-FF9A-46F5-BB1B-D441D8791F06}"/>
+                <a16:creationId xmlns:a16="http://schemas.microsoft.com/office/drawing/2014/main" id="{5DE0FC56-F161-41CE-9AED-574C5D2CF96C}"/>
               </a:ext>
             </a:extLst>
           </p:cNvPr>
@@ -10089,7 +10503,7 @@
           <p:cNvPr id="28" name="artifact-call-2">
             <a:extLst xmlns:a="http://schemas.openxmlformats.org/drawingml/2006/main">
               <a:ext uri="{FF2B5EF4-FFF2-40B4-BE49-F238E27FC236}">
-                <a16:creationId xmlns:a16="http://schemas.microsoft.com/office/drawing/2014/main" id="{82E382FE-19FA-4BC7-BA20-B99675614945}"/>
+                <a16:creationId xmlns:a16="http://schemas.microsoft.com/office/drawing/2014/main" id="{A03EC112-97FA-4CEF-821F-88247A107421}"/>
               </a:ext>
             </a:extLst>
           </p:cNvPr>
@@ -10117,7 +10531,7 @@
           <p:cNvPr id="29" name="artifact-call-3">
             <a:extLst xmlns:a="http://schemas.openxmlformats.org/drawingml/2006/main">
               <a:ext uri="{FF2B5EF4-FFF2-40B4-BE49-F238E27FC236}">
-                <a16:creationId xmlns:a16="http://schemas.microsoft.com/office/drawing/2014/main" id="{328FDBF3-43FD-45EF-8103-05FFA61424CA}"/>
+                <a16:creationId xmlns:a16="http://schemas.microsoft.com/office/drawing/2014/main" id="{040C57D6-B5F4-4749-BFCC-DF91317EE3A2}"/>
               </a:ext>
             </a:extLst>
           </p:cNvPr>
@@ -10146,7 +10560,7 @@
           <p:cNvPr id="31" name="jdbc">
             <a:extLst xmlns:a="http://schemas.openxmlformats.org/drawingml/2006/main">
               <a:ext uri="{FF2B5EF4-FFF2-40B4-BE49-F238E27FC236}">
-                <a16:creationId xmlns:a16="http://schemas.microsoft.com/office/drawing/2014/main" id="{B39F1001-4C16-48E1-942F-B753CF1BA7E7}"/>
+                <a16:creationId xmlns:a16="http://schemas.microsoft.com/office/drawing/2014/main" id="{D648908A-0674-4675-B1AC-1733C83FE85A}"/>
               </a:ext>
             </a:extLst>
           </p:cNvPr>
@@ -10214,7 +10628,7 @@
           <p:cNvPr id="32" name="telemetry-1">
             <a:extLst xmlns:a="http://schemas.openxmlformats.org/drawingml/2006/main">
               <a:ext uri="{FF2B5EF4-FFF2-40B4-BE49-F238E27FC236}">
-                <a16:creationId xmlns:a16="http://schemas.microsoft.com/office/drawing/2014/main" id="{66B39B2D-6B4F-40FD-88B3-9668CA157838}"/>
+                <a16:creationId xmlns:a16="http://schemas.microsoft.com/office/drawing/2014/main" id="{D58AF676-03FD-4E44-90DC-6ADD46A19B69}"/>
               </a:ext>
             </a:extLst>
           </p:cNvPr>
@@ -10242,7 +10656,7 @@
           <p:cNvPr id="33" name="telemetry-2">
             <a:extLst xmlns:a="http://schemas.openxmlformats.org/drawingml/2006/main">
               <a:ext uri="{FF2B5EF4-FFF2-40B4-BE49-F238E27FC236}">
-                <a16:creationId xmlns:a16="http://schemas.microsoft.com/office/drawing/2014/main" id="{236A25EA-18AE-4553-B8B8-8ED926D978AF}"/>
+                <a16:creationId xmlns:a16="http://schemas.microsoft.com/office/drawing/2014/main" id="{B7766E2C-D407-4698-840C-DCAEFA6D0566}"/>
               </a:ext>
             </a:extLst>
           </p:cNvPr>
@@ -10270,7 +10684,7 @@
           <p:cNvPr id="34" name="telemetry-3">
             <a:extLst xmlns:a="http://schemas.openxmlformats.org/drawingml/2006/main">
               <a:ext uri="{FF2B5EF4-FFF2-40B4-BE49-F238E27FC236}">
-                <a16:creationId xmlns:a16="http://schemas.microsoft.com/office/drawing/2014/main" id="{537B5810-A0B9-4BF7-A89F-C0E74C465E96}"/>
+                <a16:creationId xmlns:a16="http://schemas.microsoft.com/office/drawing/2014/main" id="{5E74973D-0D88-47CB-B342-67E912AEB64E}"/>
               </a:ext>
             </a:extLst>
           </p:cNvPr>
@@ -10299,7 +10713,7 @@
           <p:cNvPr id="35" name="health">
             <a:extLst xmlns:a="http://schemas.openxmlformats.org/drawingml/2006/main">
               <a:ext uri="{FF2B5EF4-FFF2-40B4-BE49-F238E27FC236}">
-                <a16:creationId xmlns:a16="http://schemas.microsoft.com/office/drawing/2014/main" id="{428C1A19-A5B9-496B-9436-AFD734E43612}"/>
+                <a16:creationId xmlns:a16="http://schemas.microsoft.com/office/drawing/2014/main" id="{08C5076E-DF00-4439-A9A1-5426A55104D1}"/>
               </a:ext>
             </a:extLst>
           </p:cNvPr>
@@ -10365,7 +10779,7 @@
     </p:spTree>
     <p:extLst>
       <p:ext uri="{BB962C8B-B14F-4D97-AF65-F5344CB8AC3E}">
-        <p14:creationId xmlns:p14="http://schemas.microsoft.com/office/powerpoint/2010/main" val="1897133884"/>
+        <p14:creationId xmlns:p14="http://schemas.microsoft.com/office/powerpoint/2010/main" val="133037022"/>
       </p:ext>
     </p:extLst>
   </p:cSld>
@@ -10396,7 +10810,7 @@
           <p:cNvPr id="10" name="title">
             <a:extLst xmlns:a="http://schemas.openxmlformats.org/drawingml/2006/main">
               <a:ext uri="{FF2B5EF4-FFF2-40B4-BE49-F238E27FC236}">
-                <a16:creationId xmlns:a16="http://schemas.microsoft.com/office/drawing/2014/main" id="{9DBB4CA5-28D5-4E1C-A310-912D36771FC0}"/>
+                <a16:creationId xmlns:a16="http://schemas.microsoft.com/office/drawing/2014/main" id="{F9CFA74C-B36D-4E3C-87C6-19635F98FEB7}"/>
               </a:ext>
             </a:extLst>
           </p:cNvPr>
@@ -10464,7 +10878,7 @@
           <p:cNvPr id="2" name="page">
             <a:extLst xmlns:a="http://schemas.openxmlformats.org/drawingml/2006/main">
               <a:ext uri="{FF2B5EF4-FFF2-40B4-BE49-F238E27FC236}">
-                <a16:creationId xmlns:a16="http://schemas.microsoft.com/office/drawing/2014/main" id="{A98B12B2-CEBC-48E6-A190-8A09B3409C77}"/>
+                <a16:creationId xmlns:a16="http://schemas.microsoft.com/office/drawing/2014/main" id="{C9FEFE5E-BEEC-4B69-BE5B-657E06E5DF03}"/>
               </a:ext>
             </a:extLst>
           </p:cNvPr>
@@ -10532,7 +10946,7 @@
           <p:cNvPr id="3" name="window">
             <a:extLst xmlns:a="http://schemas.openxmlformats.org/drawingml/2006/main">
               <a:ext uri="{FF2B5EF4-FFF2-40B4-BE49-F238E27FC236}">
-                <a16:creationId xmlns:a16="http://schemas.microsoft.com/office/drawing/2014/main" id="{DC80B469-1035-4577-802C-BDF8B546CAFF}"/>
+                <a16:creationId xmlns:a16="http://schemas.microsoft.com/office/drawing/2014/main" id="{74AAD78B-BA80-4B01-9C72-E6D59F5A3CD6}"/>
               </a:ext>
             </a:extLst>
           </p:cNvPr>
@@ -10600,7 +11014,7 @@
           <p:cNvPr id="4" name="">
             <a:extLst xmlns:a="http://schemas.openxmlformats.org/drawingml/2006/main">
               <a:ext uri="{FF2B5EF4-FFF2-40B4-BE49-F238E27FC236}">
-                <a16:creationId xmlns:a16="http://schemas.microsoft.com/office/drawing/2014/main" id="{C320D8B1-7716-47AF-AEAB-C9E4A6C00FBC}"/>
+                <a16:creationId xmlns:a16="http://schemas.microsoft.com/office/drawing/2014/main" id="{1C79FE83-C887-4C95-AAC8-FF5313620895}"/>
               </a:ext>
             </a:extLst>
           </p:cNvPr>
@@ -11680,7 +12094,7 @@
           <p:cNvPr id="5" name="total-cost">
             <a:extLst xmlns:a="http://schemas.openxmlformats.org/drawingml/2006/main">
               <a:ext uri="{FF2B5EF4-FFF2-40B4-BE49-F238E27FC236}">
-                <a16:creationId xmlns:a16="http://schemas.microsoft.com/office/drawing/2014/main" id="{966AE20E-5E43-4530-A3D9-96C9F2854E0E}"/>
+                <a16:creationId xmlns:a16="http://schemas.microsoft.com/office/drawing/2014/main" id="{6A2B41AD-B5B2-495B-96C1-62CE72AD723A}"/>
               </a:ext>
             </a:extLst>
           </p:cNvPr>
@@ -11748,7 +12162,7 @@
           <p:cNvPr id="6" name="basis">
             <a:extLst xmlns:a="http://schemas.openxmlformats.org/drawingml/2006/main">
               <a:ext uri="{FF2B5EF4-FFF2-40B4-BE49-F238E27FC236}">
-                <a16:creationId xmlns:a16="http://schemas.microsoft.com/office/drawing/2014/main" id="{E688315C-FF51-4771-AD4A-F3A4EFDE0964}"/>
+                <a16:creationId xmlns:a16="http://schemas.microsoft.com/office/drawing/2014/main" id="{E608CE35-48A6-417A-9486-A3E537EE0FC9}"/>
               </a:ext>
             </a:extLst>
           </p:cNvPr>
@@ -11816,7 +12230,7 @@
           <p:cNvPr id="7" name="">
             <a:extLst xmlns:a="http://schemas.openxmlformats.org/drawingml/2006/main">
               <a:ext uri="{FF2B5EF4-FFF2-40B4-BE49-F238E27FC236}">
-                <a16:creationId xmlns:a16="http://schemas.microsoft.com/office/drawing/2014/main" id="{CA0A4BBB-42DA-482B-987B-10A320EB071D}"/>
+                <a16:creationId xmlns:a16="http://schemas.microsoft.com/office/drawing/2014/main" id="{86B4C867-A682-402B-A1E0-84A88995B95E}"/>
               </a:ext>
             </a:extLst>
           </p:cNvPr>
@@ -12907,7 +13321,7 @@
           <p:cNvPr id="8" name="leave">
             <a:extLst xmlns:a="http://schemas.openxmlformats.org/drawingml/2006/main">
               <a:ext uri="{FF2B5EF4-FFF2-40B4-BE49-F238E27FC236}">
-                <a16:creationId xmlns:a16="http://schemas.microsoft.com/office/drawing/2014/main" id="{FE66F8C2-59E7-4C98-8EB8-3DDED8FD8BF5}"/>
+                <a16:creationId xmlns:a16="http://schemas.microsoft.com/office/drawing/2014/main" id="{F30D65FC-B0F9-401F-A34E-361AB90DD000}"/>
               </a:ext>
             </a:extLst>
           </p:cNvPr>
@@ -12975,7 +13389,7 @@
           <p:cNvPr id="9" name="cost-exclusion">
             <a:extLst xmlns:a="http://schemas.openxmlformats.org/drawingml/2006/main">
               <a:ext uri="{FF2B5EF4-FFF2-40B4-BE49-F238E27FC236}">
-                <a16:creationId xmlns:a16="http://schemas.microsoft.com/office/drawing/2014/main" id="{D1E7F042-CCA8-4103-AEF9-6D2A4AC87EFB}"/>
+                <a16:creationId xmlns:a16="http://schemas.microsoft.com/office/drawing/2014/main" id="{2219B9AE-24B3-46C3-844B-2CC6D4847D47}"/>
               </a:ext>
             </a:extLst>
           </p:cNvPr>
@@ -13041,7 +13455,7 @@
     </p:spTree>
     <p:extLst>
       <p:ext uri="{BB962C8B-B14F-4D97-AF65-F5344CB8AC3E}">
-        <p14:creationId xmlns:p14="http://schemas.microsoft.com/office/powerpoint/2010/main" val="614590616"/>
+        <p14:creationId xmlns:p14="http://schemas.microsoft.com/office/powerpoint/2010/main" val="2074191942"/>
       </p:ext>
     </p:extLst>
   </p:cSld>

</xml_diff>

<commit_message>
docs: update user UAT schedule and split PM and security budgets
</commit_message>
<xml_diff>
--- a/docs/presentations/aam-project-overview-mvp.pptx
+++ b/docs/presentations/aam-project-overview-mvp.pptx
@@ -2,17 +2,17 @@
 <file path=ppt/presentation.xml><?xml version="1.0" encoding="utf-8"?>
 <p:presentation xmlns:p="http://schemas.openxmlformats.org/presentationml/2006/main">
   <p:sldMasterIdLst>
-    <p:sldMasterId xmlns:r="http://schemas.openxmlformats.org/officeDocument/2006/relationships" id="2147483648" r:id="R9857ea8aca5c4aa6"/>
+    <p:sldMasterId xmlns:r="http://schemas.openxmlformats.org/officeDocument/2006/relationships" id="2147483648" r:id="Ra4ecc726ec0b43b3"/>
   </p:sldMasterIdLst>
   <p:notesMasterIdLst>
-    <p:notesMasterId xmlns:r="http://schemas.openxmlformats.org/officeDocument/2006/relationships" r:id="R507de0c321374af1"/>
+    <p:notesMasterId xmlns:r="http://schemas.openxmlformats.org/officeDocument/2006/relationships" r:id="R302ef0c27beb4116"/>
   </p:notesMasterIdLst>
   <p:sldIdLst>
-    <p:sldId xmlns:r="http://schemas.openxmlformats.org/officeDocument/2006/relationships" id="256" r:id="R71f7e099b0884fac"/>
-    <p:sldId xmlns:r="http://schemas.openxmlformats.org/officeDocument/2006/relationships" id="257" r:id="R8a4508d8bccf4540"/>
-    <p:sldId xmlns:r="http://schemas.openxmlformats.org/officeDocument/2006/relationships" id="258" r:id="Rbdfd9f4fcbfa4ecc"/>
-    <p:sldId xmlns:r="http://schemas.openxmlformats.org/officeDocument/2006/relationships" id="259" r:id="Rec95dd2403824d02"/>
-    <p:sldId xmlns:r="http://schemas.openxmlformats.org/officeDocument/2006/relationships" id="260" r:id="R47e1fc36585c48b4"/>
+    <p:sldId xmlns:r="http://schemas.openxmlformats.org/officeDocument/2006/relationships" id="256" r:id="R3cd6e4c664c041e7"/>
+    <p:sldId xmlns:r="http://schemas.openxmlformats.org/officeDocument/2006/relationships" id="257" r:id="R45aaed328a7d4b7b"/>
+    <p:sldId xmlns:r="http://schemas.openxmlformats.org/officeDocument/2006/relationships" id="258" r:id="R2643e5278efa48b7"/>
+    <p:sldId xmlns:r="http://schemas.openxmlformats.org/officeDocument/2006/relationships" id="259" r:id="R31907abc348345c0"/>
+    <p:sldId xmlns:r="http://schemas.openxmlformats.org/officeDocument/2006/relationships" id="260" r:id="Re883fd7849a94715"/>
   </p:sldIdLst>
   <p:sldSz cx="15240000" cy="8572500"/>
   <p:notesSz cx="6858000" cy="9144000"/>
@@ -756,7 +756,7 @@
           <a:lstStyle xmlns:a="http://schemas.openxmlformats.org/drawingml/2006/main"/>
           <a:p xmlns:a="http://schemas.openxmlformats.org/drawingml/2006/main">
             <a:r>
-              <a:t>Source: https://github.com/realAaronWu/aam/blob/4266cc34b7c7639256ebb993810caeea34608a82/docs/planning/AAM_Delivery_Plan_FSD_SIT_UAT_to_2027-03-05_EN.xlsx . SHA-256 a918de308e653598253a3d1cd3428d509e4f69928cdc919a5fcc515c2b5f5ea8. Team and Gates A7:D13/A15:D15 supplies role effort and cost, D68:D79 supplies milestones. Cost equals scheduled person-days from the Gantt multiplied by editable default USD360 daily rates. Scheduled labor is not full payroll availability. Two developers, DS, two testers, BA and UI/UX are seven assumed resources, with planned part-time usage where the workbook allocates fewer days. Tester 1 covers technical QA. Tester 2 covers business and AI scenario QA after DS tuning. FSD/UX two weeks; Java build three weeks; CI/CD parallel; SIT/tuning eight weeks; UAT Feb15-24. Feb3-12 leave excluded. Budget and milestones are planned estimates, not approvals or actual expenditure.</a:t>
+              <a:t>Source: updated AAM_Delivery_Plan_UAT_PM_Budget_EN.xlsx, SHA-256 4f753f4e8f27124e0dc6d1a3ef25341f4f5fa4cc54e23b5adb8b96bfb0b8db09. Eight resources include PM at 0.5 person-day for each of 82 working days, totaling41 PM days and USD14760. Labor420.4 days x USD360 = USD151344. Pen test is a separate USD15000 fixed fee, assigned before Jan31 per user instruction, for total USD166344. Through Jan31 total USD138300; from Feb1 through Mar5 USD28044. Potential users participate Jan18-Feb24, 20 effective workdays excluding Feb3-12 leave. PM/BA book users Jan4-8 and train/access-check Jan11-15. SIT signoff and UAT readiness Jan15, initial candidate freeze Jan8 and independent evaluation Jan11-15; engineering QA continues during UAT. Pen test report Jan29 and retest Feb19, with retest assumed included in fee and execution in an isolated approved environment. User participation time is required but unestimated/unpriced. UAT signoff Feb24, Go/No-GoFeb25, productionFeb26, handoverMar5. Friday rollout needs staffed rollback/on-call. Budget/milestones remain planned estimates and pending approvals.</a:t>
             </a:r>
           </a:p>
         </p:txBody>
@@ -803,7 +803,7 @@
           <p:cNvPr id="3" name="Title">
             <a:extLst xmlns:a="http://schemas.openxmlformats.org/drawingml/2006/main">
               <a:ext uri="{FF2B5EF4-FFF2-40B4-BE49-F238E27FC236}">
-                <a16:creationId xmlns:a16="http://schemas.microsoft.com/office/drawing/2014/main" id="{2EAB71E2-4C69-4827-99D6-042C1459F7CA}"/>
+                <a16:creationId xmlns:a16="http://schemas.microsoft.com/office/drawing/2014/main" id="{942A0E33-88EC-4931-B865-7AB0A188E6D6}"/>
               </a:ext>
             </a:extLst>
           </p:cNvPr>
@@ -960,7 +960,7 @@
           <p:cNvPr id="2" name="Subtitle">
             <a:extLst xmlns:a="http://schemas.openxmlformats.org/drawingml/2006/main">
               <a:ext uri="{FF2B5EF4-FFF2-40B4-BE49-F238E27FC236}">
-                <a16:creationId xmlns:a16="http://schemas.microsoft.com/office/drawing/2014/main" id="{9C4929A0-C555-445F-9AC1-65C9BB53908D}"/>
+                <a16:creationId xmlns:a16="http://schemas.microsoft.com/office/drawing/2014/main" id="{421E137D-AC8B-4243-95AF-C4163E2C24D8}"/>
               </a:ext>
             </a:extLst>
           </p:cNvPr>
@@ -1134,7 +1134,7 @@
           <p:cNvPr id="2" name="Section title">
             <a:extLst xmlns:a="http://schemas.openxmlformats.org/drawingml/2006/main">
               <a:ext uri="{FF2B5EF4-FFF2-40B4-BE49-F238E27FC236}">
-                <a16:creationId xmlns:a16="http://schemas.microsoft.com/office/drawing/2014/main" id="{9B29D607-E2E0-4724-A90C-3AD18BAEBF35}"/>
+                <a16:creationId xmlns:a16="http://schemas.microsoft.com/office/drawing/2014/main" id="{610DEDD5-7B05-4B16-BD09-3D04C42CE113}"/>
               </a:ext>
             </a:extLst>
           </p:cNvPr>
@@ -1308,7 +1308,7 @@
           <p:cNvPr id="3" name="Title">
             <a:extLst xmlns:a="http://schemas.openxmlformats.org/drawingml/2006/main">
               <a:ext uri="{FF2B5EF4-FFF2-40B4-BE49-F238E27FC236}">
-                <a16:creationId xmlns:a16="http://schemas.microsoft.com/office/drawing/2014/main" id="{D8BDD192-9C9F-4D2A-B051-3DAA955FD199}"/>
+                <a16:creationId xmlns:a16="http://schemas.microsoft.com/office/drawing/2014/main" id="{6FC6AB72-A31D-48E8-86BF-5289082E9BE9}"/>
               </a:ext>
             </a:extLst>
           </p:cNvPr>
@@ -1465,7 +1465,7 @@
           <p:cNvPr id="2" name="Body">
             <a:extLst xmlns:a="http://schemas.openxmlformats.org/drawingml/2006/main">
               <a:ext uri="{FF2B5EF4-FFF2-40B4-BE49-F238E27FC236}">
-                <a16:creationId xmlns:a16="http://schemas.microsoft.com/office/drawing/2014/main" id="{3A4F6BDE-1E9B-4F62-8CB0-1C0029FA07DD}"/>
+                <a16:creationId xmlns:a16="http://schemas.microsoft.com/office/drawing/2014/main" id="{A514B793-1840-4CBF-9AEA-3278DC32F0F6}"/>
               </a:ext>
             </a:extLst>
           </p:cNvPr>
@@ -1639,7 +1639,7 @@
           <p:cNvPr id="4" name="Title">
             <a:extLst xmlns:a="http://schemas.openxmlformats.org/drawingml/2006/main">
               <a:ext uri="{FF2B5EF4-FFF2-40B4-BE49-F238E27FC236}">
-                <a16:creationId xmlns:a16="http://schemas.microsoft.com/office/drawing/2014/main" id="{9833ABE0-5CBA-4C52-AD71-F9D1C78DCEC8}"/>
+                <a16:creationId xmlns:a16="http://schemas.microsoft.com/office/drawing/2014/main" id="{BCE05BBB-FC23-4C0C-9956-BF8B558791F4}"/>
               </a:ext>
             </a:extLst>
           </p:cNvPr>
@@ -1796,7 +1796,7 @@
           <p:cNvPr id="2" name="Left column">
             <a:extLst xmlns:a="http://schemas.openxmlformats.org/drawingml/2006/main">
               <a:ext uri="{FF2B5EF4-FFF2-40B4-BE49-F238E27FC236}">
-                <a16:creationId xmlns:a16="http://schemas.microsoft.com/office/drawing/2014/main" id="{3FEFD53C-08CD-4EE5-8863-502CF2B4AA84}"/>
+                <a16:creationId xmlns:a16="http://schemas.microsoft.com/office/drawing/2014/main" id="{576E49AF-E532-4E7A-A16D-B9A77CDA43E1}"/>
               </a:ext>
             </a:extLst>
           </p:cNvPr>
@@ -1953,7 +1953,7 @@
           <p:cNvPr id="3" name="Right column">
             <a:extLst xmlns:a="http://schemas.openxmlformats.org/drawingml/2006/main">
               <a:ext uri="{FF2B5EF4-FFF2-40B4-BE49-F238E27FC236}">
-                <a16:creationId xmlns:a16="http://schemas.microsoft.com/office/drawing/2014/main" id="{025BDB1A-78BB-4073-BB40-B2FD65A595BF}"/>
+                <a16:creationId xmlns:a16="http://schemas.microsoft.com/office/drawing/2014/main" id="{2CBDEB7D-7F07-448A-825C-D0FBA1DE6B5D}"/>
               </a:ext>
             </a:extLst>
           </p:cNvPr>
@@ -2127,7 +2127,7 @@
           <p:cNvPr id="3" name="Title">
             <a:extLst xmlns:a="http://schemas.openxmlformats.org/drawingml/2006/main">
               <a:ext uri="{FF2B5EF4-FFF2-40B4-BE49-F238E27FC236}">
-                <a16:creationId xmlns:a16="http://schemas.microsoft.com/office/drawing/2014/main" id="{901E7AF1-EF37-4C17-A5E6-B79D080B6C2E}"/>
+                <a16:creationId xmlns:a16="http://schemas.microsoft.com/office/drawing/2014/main" id="{DFE3246C-CACB-4C35-8A51-7E8E6C151E45}"/>
               </a:ext>
             </a:extLst>
           </p:cNvPr>
@@ -2284,7 +2284,7 @@
           <p:cNvPr id="2" name="Left column">
             <a:extLst xmlns:a="http://schemas.openxmlformats.org/drawingml/2006/main">
               <a:ext uri="{FF2B5EF4-FFF2-40B4-BE49-F238E27FC236}">
-                <a16:creationId xmlns:a16="http://schemas.microsoft.com/office/drawing/2014/main" id="{177E0118-B374-4793-81DF-E31906C3C9AC}"/>
+                <a16:creationId xmlns:a16="http://schemas.microsoft.com/office/drawing/2014/main" id="{F08C163B-0F93-4E3F-87BC-3C72474A5405}"/>
               </a:ext>
             </a:extLst>
           </p:cNvPr>
@@ -2479,12 +2479,12 @@
   </p:cSld>
   <p:clrMap bg1="lt1" tx1="dk1" bg2="lt2" tx2="dk2" accent1="accent1" accent2="accent2" accent3="accent3" accent4="accent4" accent5="accent5" accent6="accent6" hlink="hlink" folHlink="folHlink"/>
   <p:sldLayoutIdLst>
-    <p:sldLayoutId xmlns:r="http://schemas.openxmlformats.org/officeDocument/2006/relationships" id="2147483649" r:id="Rdd8b7957e3274f08"/>
-    <p:sldLayoutId xmlns:r="http://schemas.openxmlformats.org/officeDocument/2006/relationships" id="2147483650" r:id="R9d99442d94b543d6"/>
-    <p:sldLayoutId xmlns:r="http://schemas.openxmlformats.org/officeDocument/2006/relationships" id="2147483651" r:id="Rd98a3f8f1fac4b83"/>
-    <p:sldLayoutId xmlns:r="http://schemas.openxmlformats.org/officeDocument/2006/relationships" id="2147483652" r:id="Rdf73bb4515b74e2c"/>
-    <p:sldLayoutId xmlns:r="http://schemas.openxmlformats.org/officeDocument/2006/relationships" id="2147483653" r:id="R912fdbb3dd3e4542"/>
-    <p:sldLayoutId xmlns:r="http://schemas.openxmlformats.org/officeDocument/2006/relationships" id="2147483654" r:id="R0a654deb9e554b19"/>
+    <p:sldLayoutId xmlns:r="http://schemas.openxmlformats.org/officeDocument/2006/relationships" id="2147483649" r:id="R22a8934d43e64177"/>
+    <p:sldLayoutId xmlns:r="http://schemas.openxmlformats.org/officeDocument/2006/relationships" id="2147483650" r:id="R1f82b8719d9d40c2"/>
+    <p:sldLayoutId xmlns:r="http://schemas.openxmlformats.org/officeDocument/2006/relationships" id="2147483651" r:id="Rfb09f9968a8b48f7"/>
+    <p:sldLayoutId xmlns:r="http://schemas.openxmlformats.org/officeDocument/2006/relationships" id="2147483652" r:id="Ra61a374418bc4590"/>
+    <p:sldLayoutId xmlns:r="http://schemas.openxmlformats.org/officeDocument/2006/relationships" id="2147483653" r:id="R3b19e4e34aa24297"/>
+    <p:sldLayoutId xmlns:r="http://schemas.openxmlformats.org/officeDocument/2006/relationships" id="2147483654" r:id="Rbcbf36a851454f60"/>
   </p:sldLayoutIdLst>
   <p:txStyles>
     <p:titleStyle>
@@ -3035,7 +3035,7 @@
           <p:cNvPr id="23" name="title">
             <a:extLst xmlns:a="http://schemas.openxmlformats.org/drawingml/2006/main">
               <a:ext uri="{FF2B5EF4-FFF2-40B4-BE49-F238E27FC236}">
-                <a16:creationId xmlns:a16="http://schemas.microsoft.com/office/drawing/2014/main" id="{3D28BB3D-A09B-499A-8836-5C94615C8825}"/>
+                <a16:creationId xmlns:a16="http://schemas.microsoft.com/office/drawing/2014/main" id="{FCAA758C-E9F7-4ACE-B19B-EF216F0FA6D1}"/>
               </a:ext>
             </a:extLst>
           </p:cNvPr>
@@ -3103,7 +3103,7 @@
           <p:cNvPr id="2" name="page">
             <a:extLst xmlns:a="http://schemas.openxmlformats.org/drawingml/2006/main">
               <a:ext uri="{FF2B5EF4-FFF2-40B4-BE49-F238E27FC236}">
-                <a16:creationId xmlns:a16="http://schemas.microsoft.com/office/drawing/2014/main" id="{42507972-CE38-48AB-A7BF-48ED0C9B598F}"/>
+                <a16:creationId xmlns:a16="http://schemas.microsoft.com/office/drawing/2014/main" id="{49CE9954-7A0C-45E9-B528-FE7306F4360F}"/>
               </a:ext>
             </a:extLst>
           </p:cNvPr>
@@ -3171,7 +3171,7 @@
           <p:cNvPr id="3" name="intro">
             <a:extLst xmlns:a="http://schemas.openxmlformats.org/drawingml/2006/main">
               <a:ext uri="{FF2B5EF4-FFF2-40B4-BE49-F238E27FC236}">
-                <a16:creationId xmlns:a16="http://schemas.microsoft.com/office/drawing/2014/main" id="{44668E74-C113-436D-BFC3-27D6BE8DE3CB}"/>
+                <a16:creationId xmlns:a16="http://schemas.microsoft.com/office/drawing/2014/main" id="{A31135E6-6ACC-466E-A8B0-75E1EB2D2FFE}"/>
               </a:ext>
             </a:extLst>
           </p:cNvPr>
@@ -3239,7 +3239,7 @@
           <p:cNvPr id="4" name="today">
             <a:extLst xmlns:a="http://schemas.openxmlformats.org/drawingml/2006/main">
               <a:ext uri="{FF2B5EF4-FFF2-40B4-BE49-F238E27FC236}">
-                <a16:creationId xmlns:a16="http://schemas.microsoft.com/office/drawing/2014/main" id="{948FA2DE-0570-4895-813C-6D92E6801CA5}"/>
+                <a16:creationId xmlns:a16="http://schemas.microsoft.com/office/drawing/2014/main" id="{B7AD7E18-EC8E-444A-9C7A-2D325F35D57F}"/>
               </a:ext>
             </a:extLst>
           </p:cNvPr>
@@ -3307,7 +3307,7 @@
           <p:cNvPr id="5" name="pain-title-0">
             <a:extLst xmlns:a="http://schemas.openxmlformats.org/drawingml/2006/main">
               <a:ext uri="{FF2B5EF4-FFF2-40B4-BE49-F238E27FC236}">
-                <a16:creationId xmlns:a16="http://schemas.microsoft.com/office/drawing/2014/main" id="{D7D4CCAC-0DE5-4696-813C-49F7D21BE539}"/>
+                <a16:creationId xmlns:a16="http://schemas.microsoft.com/office/drawing/2014/main" id="{25BBE2BF-6695-4202-928A-CA89677851A7}"/>
               </a:ext>
             </a:extLst>
           </p:cNvPr>
@@ -3375,7 +3375,7 @@
           <p:cNvPr id="6" name="pain-body-0">
             <a:extLst xmlns:a="http://schemas.openxmlformats.org/drawingml/2006/main">
               <a:ext uri="{FF2B5EF4-FFF2-40B4-BE49-F238E27FC236}">
-                <a16:creationId xmlns:a16="http://schemas.microsoft.com/office/drawing/2014/main" id="{8B6010B2-B6D2-4783-908E-5C0D2FD22491}"/>
+                <a16:creationId xmlns:a16="http://schemas.microsoft.com/office/drawing/2014/main" id="{69248EFE-B59E-4126-A1BB-8EFF5E7361DB}"/>
               </a:ext>
             </a:extLst>
           </p:cNvPr>
@@ -3443,7 +3443,7 @@
           <p:cNvPr id="7" name="pain-title-1">
             <a:extLst xmlns:a="http://schemas.openxmlformats.org/drawingml/2006/main">
               <a:ext uri="{FF2B5EF4-FFF2-40B4-BE49-F238E27FC236}">
-                <a16:creationId xmlns:a16="http://schemas.microsoft.com/office/drawing/2014/main" id="{BBF92CDF-ED51-44F3-9DBD-D54F363B8834}"/>
+                <a16:creationId xmlns:a16="http://schemas.microsoft.com/office/drawing/2014/main" id="{D33AF044-AB37-4A9C-B520-2546B3022C58}"/>
               </a:ext>
             </a:extLst>
           </p:cNvPr>
@@ -3511,7 +3511,7 @@
           <p:cNvPr id="8" name="pain-body-1">
             <a:extLst xmlns:a="http://schemas.openxmlformats.org/drawingml/2006/main">
               <a:ext uri="{FF2B5EF4-FFF2-40B4-BE49-F238E27FC236}">
-                <a16:creationId xmlns:a16="http://schemas.microsoft.com/office/drawing/2014/main" id="{7FB8FF10-577C-45D5-9D30-FCAFE3A2FCD7}"/>
+                <a16:creationId xmlns:a16="http://schemas.microsoft.com/office/drawing/2014/main" id="{AB428486-1379-44BD-B872-8C7C2CA2745B}"/>
               </a:ext>
             </a:extLst>
           </p:cNvPr>
@@ -3579,7 +3579,7 @@
           <p:cNvPr id="9" name="pain-title-2">
             <a:extLst xmlns:a="http://schemas.openxmlformats.org/drawingml/2006/main">
               <a:ext uri="{FF2B5EF4-FFF2-40B4-BE49-F238E27FC236}">
-                <a16:creationId xmlns:a16="http://schemas.microsoft.com/office/drawing/2014/main" id="{0D9327EC-7011-43AF-948E-4B24FAC59271}"/>
+                <a16:creationId xmlns:a16="http://schemas.microsoft.com/office/drawing/2014/main" id="{6EAD29C0-40B0-45F8-B97F-BD620787EA28}"/>
               </a:ext>
             </a:extLst>
           </p:cNvPr>
@@ -3647,7 +3647,7 @@
           <p:cNvPr id="10" name="pain-body-2">
             <a:extLst xmlns:a="http://schemas.openxmlformats.org/drawingml/2006/main">
               <a:ext uri="{FF2B5EF4-FFF2-40B4-BE49-F238E27FC236}">
-                <a16:creationId xmlns:a16="http://schemas.microsoft.com/office/drawing/2014/main" id="{2C0EC7DE-19E0-467F-8753-52C331AA1DA3}"/>
+                <a16:creationId xmlns:a16="http://schemas.microsoft.com/office/drawing/2014/main" id="{18F28727-6F60-4727-B4EA-68E763CC8103}"/>
               </a:ext>
             </a:extLst>
           </p:cNvPr>
@@ -3715,7 +3715,7 @@
           <p:cNvPr id="11" name="mvp">
             <a:extLst xmlns:a="http://schemas.openxmlformats.org/drawingml/2006/main">
               <a:ext uri="{FF2B5EF4-FFF2-40B4-BE49-F238E27FC236}">
-                <a16:creationId xmlns:a16="http://schemas.microsoft.com/office/drawing/2014/main" id="{44A2B8DA-BF24-4D27-8B82-7C73A78034E7}"/>
+                <a16:creationId xmlns:a16="http://schemas.microsoft.com/office/drawing/2014/main" id="{D160CEA7-AEFA-438E-8BEE-71207E86E23C}"/>
               </a:ext>
             </a:extLst>
           </p:cNvPr>
@@ -3783,7 +3783,7 @@
           <p:cNvPr id="12" name="scope-title-0">
             <a:extLst xmlns:a="http://schemas.openxmlformats.org/drawingml/2006/main">
               <a:ext uri="{FF2B5EF4-FFF2-40B4-BE49-F238E27FC236}">
-                <a16:creationId xmlns:a16="http://schemas.microsoft.com/office/drawing/2014/main" id="{7997E77F-6021-49CF-9831-92FCD5926A9B}"/>
+                <a16:creationId xmlns:a16="http://schemas.microsoft.com/office/drawing/2014/main" id="{2FF348A5-C042-46E7-8830-1B14AFCB3408}"/>
               </a:ext>
             </a:extLst>
           </p:cNvPr>
@@ -3851,7 +3851,7 @@
           <p:cNvPr id="13" name="scope-body-0">
             <a:extLst xmlns:a="http://schemas.openxmlformats.org/drawingml/2006/main">
               <a:ext uri="{FF2B5EF4-FFF2-40B4-BE49-F238E27FC236}">
-                <a16:creationId xmlns:a16="http://schemas.microsoft.com/office/drawing/2014/main" id="{B910B43C-6BF3-4E36-821B-A1F146D8D561}"/>
+                <a16:creationId xmlns:a16="http://schemas.microsoft.com/office/drawing/2014/main" id="{2E401280-011E-4E31-A0DB-D6BB65A3351D}"/>
               </a:ext>
             </a:extLst>
           </p:cNvPr>
@@ -3919,7 +3919,7 @@
           <p:cNvPr id="14" name="scope-title-1">
             <a:extLst xmlns:a="http://schemas.openxmlformats.org/drawingml/2006/main">
               <a:ext uri="{FF2B5EF4-FFF2-40B4-BE49-F238E27FC236}">
-                <a16:creationId xmlns:a16="http://schemas.microsoft.com/office/drawing/2014/main" id="{5255682A-E107-4150-8277-DC2D2BCE333E}"/>
+                <a16:creationId xmlns:a16="http://schemas.microsoft.com/office/drawing/2014/main" id="{ADA7F98B-B691-4F87-B929-EEB87F8C6AC7}"/>
               </a:ext>
             </a:extLst>
           </p:cNvPr>
@@ -3987,7 +3987,7 @@
           <p:cNvPr id="15" name="scope-body-1">
             <a:extLst xmlns:a="http://schemas.openxmlformats.org/drawingml/2006/main">
               <a:ext uri="{FF2B5EF4-FFF2-40B4-BE49-F238E27FC236}">
-                <a16:creationId xmlns:a16="http://schemas.microsoft.com/office/drawing/2014/main" id="{72AF4866-9AA8-4BE5-BFF6-87EAD9D41591}"/>
+                <a16:creationId xmlns:a16="http://schemas.microsoft.com/office/drawing/2014/main" id="{DD3650DA-03CF-48EB-B375-7479A73A538C}"/>
               </a:ext>
             </a:extLst>
           </p:cNvPr>
@@ -4055,7 +4055,7 @@
           <p:cNvPr id="16" name="scope-title-2">
             <a:extLst xmlns:a="http://schemas.openxmlformats.org/drawingml/2006/main">
               <a:ext uri="{FF2B5EF4-FFF2-40B4-BE49-F238E27FC236}">
-                <a16:creationId xmlns:a16="http://schemas.microsoft.com/office/drawing/2014/main" id="{FF97E5A9-1994-406E-81B2-CD614891B1A4}"/>
+                <a16:creationId xmlns:a16="http://schemas.microsoft.com/office/drawing/2014/main" id="{FC9FB5A0-3EBD-4A0D-8805-DA3443DCBD1B}"/>
               </a:ext>
             </a:extLst>
           </p:cNvPr>
@@ -4123,7 +4123,7 @@
           <p:cNvPr id="17" name="scope-body-2">
             <a:extLst xmlns:a="http://schemas.openxmlformats.org/drawingml/2006/main">
               <a:ext uri="{FF2B5EF4-FFF2-40B4-BE49-F238E27FC236}">
-                <a16:creationId xmlns:a16="http://schemas.microsoft.com/office/drawing/2014/main" id="{1F0E3425-647F-46A7-8AB9-EEF7AB1E7175}"/>
+                <a16:creationId xmlns:a16="http://schemas.microsoft.com/office/drawing/2014/main" id="{C58F3DCA-D7D2-4E6A-872C-CC17783F7A12}"/>
               </a:ext>
             </a:extLst>
           </p:cNvPr>
@@ -4191,7 +4191,7 @@
           <p:cNvPr id="18" name="scope-title-3">
             <a:extLst xmlns:a="http://schemas.openxmlformats.org/drawingml/2006/main">
               <a:ext uri="{FF2B5EF4-FFF2-40B4-BE49-F238E27FC236}">
-                <a16:creationId xmlns:a16="http://schemas.microsoft.com/office/drawing/2014/main" id="{6E4387D4-B2DF-4783-9615-39D91FC1B0F6}"/>
+                <a16:creationId xmlns:a16="http://schemas.microsoft.com/office/drawing/2014/main" id="{B079D31B-2AF9-4896-B530-EEEDE3A3144A}"/>
               </a:ext>
             </a:extLst>
           </p:cNvPr>
@@ -4259,7 +4259,7 @@
           <p:cNvPr id="19" name="scope-body-3">
             <a:extLst xmlns:a="http://schemas.openxmlformats.org/drawingml/2006/main">
               <a:ext uri="{FF2B5EF4-FFF2-40B4-BE49-F238E27FC236}">
-                <a16:creationId xmlns:a16="http://schemas.microsoft.com/office/drawing/2014/main" id="{2E9690F9-70FA-4785-990B-E4D6699AFDC1}"/>
+                <a16:creationId xmlns:a16="http://schemas.microsoft.com/office/drawing/2014/main" id="{8EDD52CA-8408-4F86-B3CB-626472A1510A}"/>
               </a:ext>
             </a:extLst>
           </p:cNvPr>
@@ -4327,7 +4327,7 @@
           <p:cNvPr id="20" name="scope-title-4">
             <a:extLst xmlns:a="http://schemas.openxmlformats.org/drawingml/2006/main">
               <a:ext uri="{FF2B5EF4-FFF2-40B4-BE49-F238E27FC236}">
-                <a16:creationId xmlns:a16="http://schemas.microsoft.com/office/drawing/2014/main" id="{4F14A718-46C6-4D44-B340-A23712236ECD}"/>
+                <a16:creationId xmlns:a16="http://schemas.microsoft.com/office/drawing/2014/main" id="{3ABF33BD-87D5-45F7-AFD9-BFB605B7D0C5}"/>
               </a:ext>
             </a:extLst>
           </p:cNvPr>
@@ -4395,7 +4395,7 @@
           <p:cNvPr id="21" name="scope-body-4">
             <a:extLst xmlns:a="http://schemas.openxmlformats.org/drawingml/2006/main">
               <a:ext uri="{FF2B5EF4-FFF2-40B4-BE49-F238E27FC236}">
-                <a16:creationId xmlns:a16="http://schemas.microsoft.com/office/drawing/2014/main" id="{0E8DAB4D-BECB-4A50-90DD-E796E17F1A57}"/>
+                <a16:creationId xmlns:a16="http://schemas.microsoft.com/office/drawing/2014/main" id="{FA33FDC1-167E-49E5-879F-95319C4A6D3A}"/>
               </a:ext>
             </a:extLst>
           </p:cNvPr>
@@ -4463,7 +4463,7 @@
           <p:cNvPr id="22" name="benefit">
             <a:extLst xmlns:a="http://schemas.openxmlformats.org/drawingml/2006/main">
               <a:ext uri="{FF2B5EF4-FFF2-40B4-BE49-F238E27FC236}">
-                <a16:creationId xmlns:a16="http://schemas.microsoft.com/office/drawing/2014/main" id="{267EAA46-5065-46DA-B3D8-582D1B3C7D69}"/>
+                <a16:creationId xmlns:a16="http://schemas.microsoft.com/office/drawing/2014/main" id="{1E799F70-8FFA-40EE-98AA-3B8E9A2E9B14}"/>
               </a:ext>
             </a:extLst>
           </p:cNvPr>
@@ -4529,7 +4529,7 @@
     </p:spTree>
     <p:extLst>
       <p:ext uri="{BB962C8B-B14F-4D97-AF65-F5344CB8AC3E}">
-        <p14:creationId xmlns:p14="http://schemas.microsoft.com/office/powerpoint/2010/main" val="1513220039"/>
+        <p14:creationId xmlns:p14="http://schemas.microsoft.com/office/powerpoint/2010/main" val="1953172748"/>
       </p:ext>
     </p:extLst>
   </p:cSld>
@@ -4560,7 +4560,7 @@
           <p:cNvPr id="24" name="title">
             <a:extLst xmlns:a="http://schemas.openxmlformats.org/drawingml/2006/main">
               <a:ext uri="{FF2B5EF4-FFF2-40B4-BE49-F238E27FC236}">
-                <a16:creationId xmlns:a16="http://schemas.microsoft.com/office/drawing/2014/main" id="{7E89AAAA-8E48-4258-B472-56F3E77628C3}"/>
+                <a16:creationId xmlns:a16="http://schemas.microsoft.com/office/drawing/2014/main" id="{DE6494F9-A702-4236-98AC-481717847362}"/>
               </a:ext>
             </a:extLst>
           </p:cNvPr>
@@ -4628,7 +4628,7 @@
           <p:cNvPr id="2" name="page">
             <a:extLst xmlns:a="http://schemas.openxmlformats.org/drawingml/2006/main">
               <a:ext uri="{FF2B5EF4-FFF2-40B4-BE49-F238E27FC236}">
-                <a16:creationId xmlns:a16="http://schemas.microsoft.com/office/drawing/2014/main" id="{4CD79712-76E9-4556-B792-D8D03CB33687}"/>
+                <a16:creationId xmlns:a16="http://schemas.microsoft.com/office/drawing/2014/main" id="{D38D4D16-D2C0-4521-989D-22BA5CD9BD02}"/>
               </a:ext>
             </a:extLst>
           </p:cNvPr>
@@ -4696,7 +4696,7 @@
           <p:cNvPr id="3" name="lead">
             <a:extLst xmlns:a="http://schemas.openxmlformats.org/drawingml/2006/main">
               <a:ext uri="{FF2B5EF4-FFF2-40B4-BE49-F238E27FC236}">
-                <a16:creationId xmlns:a16="http://schemas.microsoft.com/office/drawing/2014/main" id="{140FF9A0-F365-4F7B-9F4C-F9A0E61ED358}"/>
+                <a16:creationId xmlns:a16="http://schemas.microsoft.com/office/drawing/2014/main" id="{5ACF9CEB-9C90-480D-B346-F8C68A110826}"/>
               </a:ext>
             </a:extLst>
           </p:cNvPr>
@@ -4764,7 +4764,7 @@
           <p:cNvPr id="4" name="lead-body">
             <a:extLst xmlns:a="http://schemas.openxmlformats.org/drawingml/2006/main">
               <a:ext uri="{FF2B5EF4-FFF2-40B4-BE49-F238E27FC236}">
-                <a16:creationId xmlns:a16="http://schemas.microsoft.com/office/drawing/2014/main" id="{DFFC9C69-7D05-4ACF-BEFA-D6676F57D909}"/>
+                <a16:creationId xmlns:a16="http://schemas.microsoft.com/office/drawing/2014/main" id="{376267E4-3AEA-498F-BDBD-D6880F59C31B}"/>
               </a:ext>
             </a:extLst>
           </p:cNvPr>
@@ -4832,7 +4832,7 @@
           <p:cNvPr id="5" name="n-0">
             <a:extLst xmlns:a="http://schemas.openxmlformats.org/drawingml/2006/main">
               <a:ext uri="{FF2B5EF4-FFF2-40B4-BE49-F238E27FC236}">
-                <a16:creationId xmlns:a16="http://schemas.microsoft.com/office/drawing/2014/main" id="{451D4BBF-1FE4-41D6-99E0-8618E87E6D89}"/>
+                <a16:creationId xmlns:a16="http://schemas.microsoft.com/office/drawing/2014/main" id="{A6037F7B-C1DD-43CD-926A-D4DCE5F7BA0D}"/>
               </a:ext>
             </a:extLst>
           </p:cNvPr>
@@ -4900,7 +4900,7 @@
           <p:cNvPr id="6" name="h-0">
             <a:extLst xmlns:a="http://schemas.openxmlformats.org/drawingml/2006/main">
               <a:ext uri="{FF2B5EF4-FFF2-40B4-BE49-F238E27FC236}">
-                <a16:creationId xmlns:a16="http://schemas.microsoft.com/office/drawing/2014/main" id="{DF47C398-8CE0-46C3-90C3-3379A695464E}"/>
+                <a16:creationId xmlns:a16="http://schemas.microsoft.com/office/drawing/2014/main" id="{6EFA8B6D-948C-4175-AA8F-52B64272E286}"/>
               </a:ext>
             </a:extLst>
           </p:cNvPr>
@@ -4968,7 +4968,7 @@
           <p:cNvPr id="7" name="b-0">
             <a:extLst xmlns:a="http://schemas.openxmlformats.org/drawingml/2006/main">
               <a:ext uri="{FF2B5EF4-FFF2-40B4-BE49-F238E27FC236}">
-                <a16:creationId xmlns:a16="http://schemas.microsoft.com/office/drawing/2014/main" id="{19CD6113-8B16-42BD-99C9-2B48C5276B29}"/>
+                <a16:creationId xmlns:a16="http://schemas.microsoft.com/office/drawing/2014/main" id="{52B88257-C77D-47D0-8383-BD7278526050}"/>
               </a:ext>
             </a:extLst>
           </p:cNvPr>
@@ -5036,7 +5036,7 @@
           <p:cNvPr id="8" name="n-1">
             <a:extLst xmlns:a="http://schemas.openxmlformats.org/drawingml/2006/main">
               <a:ext uri="{FF2B5EF4-FFF2-40B4-BE49-F238E27FC236}">
-                <a16:creationId xmlns:a16="http://schemas.microsoft.com/office/drawing/2014/main" id="{80C2E769-5951-4620-95E2-61563B797845}"/>
+                <a16:creationId xmlns:a16="http://schemas.microsoft.com/office/drawing/2014/main" id="{8676713D-7325-44E0-BC19-972462CA4AAD}"/>
               </a:ext>
             </a:extLst>
           </p:cNvPr>
@@ -5104,7 +5104,7 @@
           <p:cNvPr id="9" name="h-1">
             <a:extLst xmlns:a="http://schemas.openxmlformats.org/drawingml/2006/main">
               <a:ext uri="{FF2B5EF4-FFF2-40B4-BE49-F238E27FC236}">
-                <a16:creationId xmlns:a16="http://schemas.microsoft.com/office/drawing/2014/main" id="{DF11F892-8723-406F-9215-94118822F299}"/>
+                <a16:creationId xmlns:a16="http://schemas.microsoft.com/office/drawing/2014/main" id="{3A9F25F9-E05C-4D76-BA35-4C9C8123D9CF}"/>
               </a:ext>
             </a:extLst>
           </p:cNvPr>
@@ -5172,7 +5172,7 @@
           <p:cNvPr id="10" name="b-1">
             <a:extLst xmlns:a="http://schemas.openxmlformats.org/drawingml/2006/main">
               <a:ext uri="{FF2B5EF4-FFF2-40B4-BE49-F238E27FC236}">
-                <a16:creationId xmlns:a16="http://schemas.microsoft.com/office/drawing/2014/main" id="{8C173AC2-18D7-45F0-852A-966BC93EAAD6}"/>
+                <a16:creationId xmlns:a16="http://schemas.microsoft.com/office/drawing/2014/main" id="{F1FDF15A-68D2-424C-805B-0B411D8E32BA}"/>
               </a:ext>
             </a:extLst>
           </p:cNvPr>
@@ -5240,7 +5240,7 @@
           <p:cNvPr id="11" name="n-2">
             <a:extLst xmlns:a="http://schemas.openxmlformats.org/drawingml/2006/main">
               <a:ext uri="{FF2B5EF4-FFF2-40B4-BE49-F238E27FC236}">
-                <a16:creationId xmlns:a16="http://schemas.microsoft.com/office/drawing/2014/main" id="{3D56A0CE-55C2-4A6B-895E-AFCBA5A49267}"/>
+                <a16:creationId xmlns:a16="http://schemas.microsoft.com/office/drawing/2014/main" id="{9727E3C5-0C43-4FE8-A90C-2BC1A8F6ACE3}"/>
               </a:ext>
             </a:extLst>
           </p:cNvPr>
@@ -5308,7 +5308,7 @@
           <p:cNvPr id="12" name="h-2">
             <a:extLst xmlns:a="http://schemas.openxmlformats.org/drawingml/2006/main">
               <a:ext uri="{FF2B5EF4-FFF2-40B4-BE49-F238E27FC236}">
-                <a16:creationId xmlns:a16="http://schemas.microsoft.com/office/drawing/2014/main" id="{45E8C0AA-82CD-4897-A785-85E8D7A4388F}"/>
+                <a16:creationId xmlns:a16="http://schemas.microsoft.com/office/drawing/2014/main" id="{5D59926A-A6AB-4401-8276-7C301E167CA3}"/>
               </a:ext>
             </a:extLst>
           </p:cNvPr>
@@ -5376,7 +5376,7 @@
           <p:cNvPr id="13" name="b-2">
             <a:extLst xmlns:a="http://schemas.openxmlformats.org/drawingml/2006/main">
               <a:ext uri="{FF2B5EF4-FFF2-40B4-BE49-F238E27FC236}">
-                <a16:creationId xmlns:a16="http://schemas.microsoft.com/office/drawing/2014/main" id="{21F64295-D470-4A67-B5C1-A955101E81B8}"/>
+                <a16:creationId xmlns:a16="http://schemas.microsoft.com/office/drawing/2014/main" id="{E051F096-6BD2-4921-B873-6345ED359280}"/>
               </a:ext>
             </a:extLst>
           </p:cNvPr>
@@ -5444,7 +5444,7 @@
           <p:cNvPr id="14" name="n-3">
             <a:extLst xmlns:a="http://schemas.openxmlformats.org/drawingml/2006/main">
               <a:ext uri="{FF2B5EF4-FFF2-40B4-BE49-F238E27FC236}">
-                <a16:creationId xmlns:a16="http://schemas.microsoft.com/office/drawing/2014/main" id="{27298665-FD9D-4153-BFF3-279B99132D7E}"/>
+                <a16:creationId xmlns:a16="http://schemas.microsoft.com/office/drawing/2014/main" id="{A766DB21-090D-4B4E-A335-BDA7F3D67BA1}"/>
               </a:ext>
             </a:extLst>
           </p:cNvPr>
@@ -5512,7 +5512,7 @@
           <p:cNvPr id="15" name="h-3">
             <a:extLst xmlns:a="http://schemas.openxmlformats.org/drawingml/2006/main">
               <a:ext uri="{FF2B5EF4-FFF2-40B4-BE49-F238E27FC236}">
-                <a16:creationId xmlns:a16="http://schemas.microsoft.com/office/drawing/2014/main" id="{91EB7F62-F172-44C1-8E75-8027743C892C}"/>
+                <a16:creationId xmlns:a16="http://schemas.microsoft.com/office/drawing/2014/main" id="{3D1FE022-9821-46E8-8316-019DBD6DB51E}"/>
               </a:ext>
             </a:extLst>
           </p:cNvPr>
@@ -5580,7 +5580,7 @@
           <p:cNvPr id="16" name="b-3">
             <a:extLst xmlns:a="http://schemas.openxmlformats.org/drawingml/2006/main">
               <a:ext uri="{FF2B5EF4-FFF2-40B4-BE49-F238E27FC236}">
-                <a16:creationId xmlns:a16="http://schemas.microsoft.com/office/drawing/2014/main" id="{2084CE53-BFC2-4796-A886-6128A2DCCBAD}"/>
+                <a16:creationId xmlns:a16="http://schemas.microsoft.com/office/drawing/2014/main" id="{F5377BED-B798-4B99-AA16-867ADD9350ED}"/>
               </a:ext>
             </a:extLst>
           </p:cNvPr>
@@ -5648,7 +5648,7 @@
           <p:cNvPr id="17" name="n-4">
             <a:extLst xmlns:a="http://schemas.openxmlformats.org/drawingml/2006/main">
               <a:ext uri="{FF2B5EF4-FFF2-40B4-BE49-F238E27FC236}">
-                <a16:creationId xmlns:a16="http://schemas.microsoft.com/office/drawing/2014/main" id="{1A1571AF-A8DD-4111-84BC-15825B4AC7F3}"/>
+                <a16:creationId xmlns:a16="http://schemas.microsoft.com/office/drawing/2014/main" id="{C8273024-612C-4C60-BCC5-1B643A073CFA}"/>
               </a:ext>
             </a:extLst>
           </p:cNvPr>
@@ -5716,7 +5716,7 @@
           <p:cNvPr id="18" name="h-4">
             <a:extLst xmlns:a="http://schemas.openxmlformats.org/drawingml/2006/main">
               <a:ext uri="{FF2B5EF4-FFF2-40B4-BE49-F238E27FC236}">
-                <a16:creationId xmlns:a16="http://schemas.microsoft.com/office/drawing/2014/main" id="{863D4E4B-E0D0-4D98-8A31-95D1A716E287}"/>
+                <a16:creationId xmlns:a16="http://schemas.microsoft.com/office/drawing/2014/main" id="{549B47A9-BA55-47EA-9C24-EB6357FFE6CC}"/>
               </a:ext>
             </a:extLst>
           </p:cNvPr>
@@ -5784,7 +5784,7 @@
           <p:cNvPr id="19" name="b-4">
             <a:extLst xmlns:a="http://schemas.openxmlformats.org/drawingml/2006/main">
               <a:ext uri="{FF2B5EF4-FFF2-40B4-BE49-F238E27FC236}">
-                <a16:creationId xmlns:a16="http://schemas.microsoft.com/office/drawing/2014/main" id="{85DDC0BB-9FE7-4742-84A9-C004F6DF60CF}"/>
+                <a16:creationId xmlns:a16="http://schemas.microsoft.com/office/drawing/2014/main" id="{A451F01D-C804-4A41-A23B-EB3E5FCDBA5D}"/>
               </a:ext>
             </a:extLst>
           </p:cNvPr>
@@ -5852,7 +5852,7 @@
           <p:cNvPr id="20" name="platform">
             <a:extLst xmlns:a="http://schemas.openxmlformats.org/drawingml/2006/main">
               <a:ext uri="{FF2B5EF4-FFF2-40B4-BE49-F238E27FC236}">
-                <a16:creationId xmlns:a16="http://schemas.microsoft.com/office/drawing/2014/main" id="{2AB2E0E6-A6B0-4479-B4B1-6EFB992A5A05}"/>
+                <a16:creationId xmlns:a16="http://schemas.microsoft.com/office/drawing/2014/main" id="{D7EAF6B4-4117-46C7-8365-41B43373EC30}"/>
               </a:ext>
             </a:extLst>
           </p:cNvPr>
@@ -5920,7 +5920,7 @@
           <p:cNvPr id="21" name="platform-list">
             <a:extLst xmlns:a="http://schemas.openxmlformats.org/drawingml/2006/main">
               <a:ext uri="{FF2B5EF4-FFF2-40B4-BE49-F238E27FC236}">
-                <a16:creationId xmlns:a16="http://schemas.microsoft.com/office/drawing/2014/main" id="{2505D828-8A29-46E3-ADC7-18D95A022B2F}"/>
+                <a16:creationId xmlns:a16="http://schemas.microsoft.com/office/drawing/2014/main" id="{35DCF3BA-EB01-45C5-BDC2-E4D8F207CC47}"/>
               </a:ext>
             </a:extLst>
           </p:cNvPr>
@@ -6080,7 +6080,7 @@
           <p:cNvPr id="22" name="delivery">
             <a:extLst xmlns:a="http://schemas.openxmlformats.org/drawingml/2006/main">
               <a:ext uri="{FF2B5EF4-FFF2-40B4-BE49-F238E27FC236}">
-                <a16:creationId xmlns:a16="http://schemas.microsoft.com/office/drawing/2014/main" id="{08586E99-EC42-46F7-B8D9-E645BAE16697}"/>
+                <a16:creationId xmlns:a16="http://schemas.microsoft.com/office/drawing/2014/main" id="{40683582-5CBE-48B0-9E61-866BEBC2B7DE}"/>
               </a:ext>
             </a:extLst>
           </p:cNvPr>
@@ -6148,7 +6148,7 @@
           <p:cNvPr id="23" name="delivery-body">
             <a:extLst xmlns:a="http://schemas.openxmlformats.org/drawingml/2006/main">
               <a:ext uri="{FF2B5EF4-FFF2-40B4-BE49-F238E27FC236}">
-                <a16:creationId xmlns:a16="http://schemas.microsoft.com/office/drawing/2014/main" id="{F3660663-FF02-4003-B962-F37D23201866}"/>
+                <a16:creationId xmlns:a16="http://schemas.microsoft.com/office/drawing/2014/main" id="{9DAFE8BB-D641-4350-8D6E-F30AC5EFD0C2}"/>
               </a:ext>
             </a:extLst>
           </p:cNvPr>
@@ -6260,7 +6260,7 @@
     </p:spTree>
     <p:extLst>
       <p:ext uri="{BB962C8B-B14F-4D97-AF65-F5344CB8AC3E}">
-        <p14:creationId xmlns:p14="http://schemas.microsoft.com/office/powerpoint/2010/main" val="925423096"/>
+        <p14:creationId xmlns:p14="http://schemas.microsoft.com/office/powerpoint/2010/main" val="447223021"/>
       </p:ext>
     </p:extLst>
   </p:cSld>
@@ -6291,7 +6291,7 @@
           <p:cNvPr id="27" name="">
             <a:extLst xmlns:a="http://schemas.openxmlformats.org/drawingml/2006/main">
               <a:ext uri="{FF2B5EF4-FFF2-40B4-BE49-F238E27FC236}">
-                <a16:creationId xmlns:a16="http://schemas.microsoft.com/office/drawing/2014/main" id="{82C929B2-D1FE-44DF-8E81-51582E900175}"/>
+                <a16:creationId xmlns:a16="http://schemas.microsoft.com/office/drawing/2014/main" id="{0C5BC5D3-7850-4B06-8C60-BAFF88445BAF}"/>
               </a:ext>
             </a:extLst>
           </p:cNvPr>
@@ -6323,7 +6323,7 @@
           <p:cNvPr id="26" name="">
             <a:extLst xmlns:a="http://schemas.openxmlformats.org/drawingml/2006/main">
               <a:ext uri="{FF2B5EF4-FFF2-40B4-BE49-F238E27FC236}">
-                <a16:creationId xmlns:a16="http://schemas.microsoft.com/office/drawing/2014/main" id="{21361021-02A2-440D-A7AE-B2E9CBEC313F}"/>
+                <a16:creationId xmlns:a16="http://schemas.microsoft.com/office/drawing/2014/main" id="{A66AC79F-3874-44C6-86FA-9244104BBFCA}"/>
               </a:ext>
             </a:extLst>
           </p:cNvPr>
@@ -6355,7 +6355,7 @@
           <p:cNvPr id="25" name="">
             <a:extLst xmlns:a="http://schemas.openxmlformats.org/drawingml/2006/main">
               <a:ext uri="{FF2B5EF4-FFF2-40B4-BE49-F238E27FC236}">
-                <a16:creationId xmlns:a16="http://schemas.microsoft.com/office/drawing/2014/main" id="{E7B71F08-10C2-4359-9ED6-F46409573EE9}"/>
+                <a16:creationId xmlns:a16="http://schemas.microsoft.com/office/drawing/2014/main" id="{E3AACD5C-AB43-45A3-82C3-DF0D9517F259}"/>
               </a:ext>
             </a:extLst>
           </p:cNvPr>
@@ -6390,7 +6390,7 @@
           <p:cNvPr id="20" name="">
             <a:extLst xmlns:a="http://schemas.openxmlformats.org/drawingml/2006/main">
               <a:ext uri="{FF2B5EF4-FFF2-40B4-BE49-F238E27FC236}">
-                <a16:creationId xmlns:a16="http://schemas.microsoft.com/office/drawing/2014/main" id="{998F8435-C60C-438A-AE31-84F9141F0BFC}"/>
+                <a16:creationId xmlns:a16="http://schemas.microsoft.com/office/drawing/2014/main" id="{FDEF69D1-26A3-489A-B5B1-BD626AA1B375}"/>
               </a:ext>
             </a:extLst>
           </p:cNvPr>
@@ -6425,7 +6425,7 @@
           <p:cNvPr id="19" name="">
             <a:extLst xmlns:a="http://schemas.openxmlformats.org/drawingml/2006/main">
               <a:ext uri="{FF2B5EF4-FFF2-40B4-BE49-F238E27FC236}">
-                <a16:creationId xmlns:a16="http://schemas.microsoft.com/office/drawing/2014/main" id="{746ECCAA-E093-4002-9B6F-18857C1F7FD1}"/>
+                <a16:creationId xmlns:a16="http://schemas.microsoft.com/office/drawing/2014/main" id="{4B70EBD5-2AFE-4A5E-9BDD-55C0127F165C}"/>
               </a:ext>
             </a:extLst>
           </p:cNvPr>
@@ -6457,7 +6457,7 @@
           <p:cNvPr id="14" name="">
             <a:extLst xmlns:a="http://schemas.openxmlformats.org/drawingml/2006/main">
               <a:ext uri="{FF2B5EF4-FFF2-40B4-BE49-F238E27FC236}">
-                <a16:creationId xmlns:a16="http://schemas.microsoft.com/office/drawing/2014/main" id="{9CDF2364-8485-49F7-91DE-D0259AE30D5E}"/>
+                <a16:creationId xmlns:a16="http://schemas.microsoft.com/office/drawing/2014/main" id="{7D7D0F86-BAE6-4713-AFB7-7261365912F6}"/>
               </a:ext>
             </a:extLst>
           </p:cNvPr>
@@ -6489,7 +6489,7 @@
           <p:cNvPr id="13" name="">
             <a:extLst xmlns:a="http://schemas.openxmlformats.org/drawingml/2006/main">
               <a:ext uri="{FF2B5EF4-FFF2-40B4-BE49-F238E27FC236}">
-                <a16:creationId xmlns:a16="http://schemas.microsoft.com/office/drawing/2014/main" id="{C6ADF8CE-106B-485B-B0E5-2BE21322F2A3}"/>
+                <a16:creationId xmlns:a16="http://schemas.microsoft.com/office/drawing/2014/main" id="{3EB9E02A-74F4-48FB-99C9-42FDDD095584}"/>
               </a:ext>
             </a:extLst>
           </p:cNvPr>
@@ -6521,7 +6521,7 @@
           <p:cNvPr id="12" name="">
             <a:extLst xmlns:a="http://schemas.openxmlformats.org/drawingml/2006/main">
               <a:ext uri="{FF2B5EF4-FFF2-40B4-BE49-F238E27FC236}">
-                <a16:creationId xmlns:a16="http://schemas.microsoft.com/office/drawing/2014/main" id="{F81219B4-436A-450D-9DF7-EE0D7AB32775}"/>
+                <a16:creationId xmlns:a16="http://schemas.microsoft.com/office/drawing/2014/main" id="{D56ACAF5-9D11-4B29-859D-ADFF664E2A7A}"/>
               </a:ext>
             </a:extLst>
           </p:cNvPr>
@@ -6553,7 +6553,7 @@
           <p:cNvPr id="11" name="">
             <a:extLst xmlns:a="http://schemas.openxmlformats.org/drawingml/2006/main">
               <a:ext uri="{FF2B5EF4-FFF2-40B4-BE49-F238E27FC236}">
-                <a16:creationId xmlns:a16="http://schemas.microsoft.com/office/drawing/2014/main" id="{58B06EAD-96D4-480B-AEA8-CDB5CBCEB4C9}"/>
+                <a16:creationId xmlns:a16="http://schemas.microsoft.com/office/drawing/2014/main" id="{6996A4C5-CAA6-43FF-BB5E-9F84FEAA80D2}"/>
               </a:ext>
             </a:extLst>
           </p:cNvPr>
@@ -6585,7 +6585,7 @@
           <p:cNvPr id="10" name="">
             <a:extLst xmlns:a="http://schemas.openxmlformats.org/drawingml/2006/main">
               <a:ext uri="{FF2B5EF4-FFF2-40B4-BE49-F238E27FC236}">
-                <a16:creationId xmlns:a16="http://schemas.microsoft.com/office/drawing/2014/main" id="{AD2516A6-1DF1-4426-A794-600F87BA2C62}"/>
+                <a16:creationId xmlns:a16="http://schemas.microsoft.com/office/drawing/2014/main" id="{9FC53883-2AB1-47A4-ACE4-376791F374AA}"/>
               </a:ext>
             </a:extLst>
           </p:cNvPr>
@@ -6617,7 +6617,7 @@
           <p:cNvPr id="30" name="title">
             <a:extLst xmlns:a="http://schemas.openxmlformats.org/drawingml/2006/main">
               <a:ext uri="{FF2B5EF4-FFF2-40B4-BE49-F238E27FC236}">
-                <a16:creationId xmlns:a16="http://schemas.microsoft.com/office/drawing/2014/main" id="{21DE2603-A5C5-4D97-946C-CE9C1F7E805A}"/>
+                <a16:creationId xmlns:a16="http://schemas.microsoft.com/office/drawing/2014/main" id="{BF072DB6-4240-4E42-B853-C91FA47645BD}"/>
               </a:ext>
             </a:extLst>
           </p:cNvPr>
@@ -6685,7 +6685,7 @@
           <p:cNvPr id="2" name="page">
             <a:extLst xmlns:a="http://schemas.openxmlformats.org/drawingml/2006/main">
               <a:ext uri="{FF2B5EF4-FFF2-40B4-BE49-F238E27FC236}">
-                <a16:creationId xmlns:a16="http://schemas.microsoft.com/office/drawing/2014/main" id="{579A8990-A282-456F-9919-D4BFA4549661}"/>
+                <a16:creationId xmlns:a16="http://schemas.microsoft.com/office/drawing/2014/main" id="{5E544BE3-789F-4E9C-B274-BA2C8C7E4E8A}"/>
               </a:ext>
             </a:extLst>
           </p:cNvPr>
@@ -6753,7 +6753,7 @@
           <p:cNvPr id="3" name="caption">
             <a:extLst xmlns:a="http://schemas.openxmlformats.org/drawingml/2006/main">
               <a:ext uri="{FF2B5EF4-FFF2-40B4-BE49-F238E27FC236}">
-                <a16:creationId xmlns:a16="http://schemas.microsoft.com/office/drawing/2014/main" id="{D173EC6E-2AE5-4E83-B233-BE1650204E00}"/>
+                <a16:creationId xmlns:a16="http://schemas.microsoft.com/office/drawing/2014/main" id="{B1486197-05AE-46A7-9F90-E9D372A51096}"/>
               </a:ext>
             </a:extLst>
           </p:cNvPr>
@@ -6821,7 +6821,7 @@
           <p:cNvPr id="4" name="sync">
             <a:extLst xmlns:a="http://schemas.openxmlformats.org/drawingml/2006/main">
               <a:ext uri="{FF2B5EF4-FFF2-40B4-BE49-F238E27FC236}">
-                <a16:creationId xmlns:a16="http://schemas.microsoft.com/office/drawing/2014/main" id="{F494DDA8-FBAE-4632-9F92-74C8ADB8B1D2}"/>
+                <a16:creationId xmlns:a16="http://schemas.microsoft.com/office/drawing/2014/main" id="{4E8F45F1-E91C-459B-853E-E78C4AC0A509}"/>
               </a:ext>
             </a:extLst>
           </p:cNvPr>
@@ -6942,7 +6942,7 @@
           <p:cNvPr id="5" name="intent">
             <a:extLst xmlns:a="http://schemas.openxmlformats.org/drawingml/2006/main">
               <a:ext uri="{FF2B5EF4-FFF2-40B4-BE49-F238E27FC236}">
-                <a16:creationId xmlns:a16="http://schemas.microsoft.com/office/drawing/2014/main" id="{E5CA06D3-B2DA-42CA-8BB8-CA7EB6261D45}"/>
+                <a16:creationId xmlns:a16="http://schemas.microsoft.com/office/drawing/2014/main" id="{B9CDF980-DD94-425F-8968-147C56413CB8}"/>
               </a:ext>
             </a:extLst>
           </p:cNvPr>
@@ -7063,7 +7063,7 @@
           <p:cNvPr id="6" name="triage">
             <a:extLst xmlns:a="http://schemas.openxmlformats.org/drawingml/2006/main">
               <a:ext uri="{FF2B5EF4-FFF2-40B4-BE49-F238E27FC236}">
-                <a16:creationId xmlns:a16="http://schemas.microsoft.com/office/drawing/2014/main" id="{697F1A60-B08E-4D27-BF93-FE0BB905D563}"/>
+                <a16:creationId xmlns:a16="http://schemas.microsoft.com/office/drawing/2014/main" id="{39ACAD79-1300-4514-A8A0-E2DCA60D91D8}"/>
               </a:ext>
             </a:extLst>
           </p:cNvPr>
@@ -7184,7 +7184,7 @@
           <p:cNvPr id="7" name="case">
             <a:extLst xmlns:a="http://schemas.openxmlformats.org/drawingml/2006/main">
               <a:ext uri="{FF2B5EF4-FFF2-40B4-BE49-F238E27FC236}">
-                <a16:creationId xmlns:a16="http://schemas.microsoft.com/office/drawing/2014/main" id="{B7D233FD-FAC8-4C74-865C-F8319C3A336A}"/>
+                <a16:creationId xmlns:a16="http://schemas.microsoft.com/office/drawing/2014/main" id="{C28174AC-F63C-48A1-8320-E58AD907F3C1}"/>
               </a:ext>
             </a:extLst>
           </p:cNvPr>
@@ -7305,7 +7305,7 @@
           <p:cNvPr id="8" name="overview">
             <a:extLst xmlns:a="http://schemas.openxmlformats.org/drawingml/2006/main">
               <a:ext uri="{FF2B5EF4-FFF2-40B4-BE49-F238E27FC236}">
-                <a16:creationId xmlns:a16="http://schemas.microsoft.com/office/drawing/2014/main" id="{3EC45513-F6FB-4AE9-929D-6B424A87EBE4}"/>
+                <a16:creationId xmlns:a16="http://schemas.microsoft.com/office/drawing/2014/main" id="{3445FADA-500F-4F34-8318-493A35D0DDF0}"/>
               </a:ext>
             </a:extLst>
           </p:cNvPr>
@@ -7426,7 +7426,7 @@
           <p:cNvPr id="9" name="progress">
             <a:extLst xmlns:a="http://schemas.openxmlformats.org/drawingml/2006/main">
               <a:ext uri="{FF2B5EF4-FFF2-40B4-BE49-F238E27FC236}">
-                <a16:creationId xmlns:a16="http://schemas.microsoft.com/office/drawing/2014/main" id="{9D51B2B9-3EE8-4FCF-9A58-A55A47535D18}"/>
+                <a16:creationId xmlns:a16="http://schemas.microsoft.com/office/drawing/2014/main" id="{210C8DE7-CECB-435B-B562-43F80D7E5ED1}"/>
               </a:ext>
             </a:extLst>
           </p:cNvPr>
@@ -7547,7 +7547,7 @@
           <p:cNvPr id="15" name="mail-input">
             <a:extLst xmlns:a="http://schemas.openxmlformats.org/drawingml/2006/main">
               <a:ext uri="{FF2B5EF4-FFF2-40B4-BE49-F238E27FC236}">
-                <a16:creationId xmlns:a16="http://schemas.microsoft.com/office/drawing/2014/main" id="{898B1138-931A-47D0-80FE-9524B4C79F35}"/>
+                <a16:creationId xmlns:a16="http://schemas.microsoft.com/office/drawing/2014/main" id="{F1ABBD1B-67CB-49C7-9304-1193A983EB9A}"/>
               </a:ext>
             </a:extLst>
           </p:cNvPr>
@@ -7615,7 +7615,7 @@
           <p:cNvPr id="16" name="playbook-label">
             <a:extLst xmlns:a="http://schemas.openxmlformats.org/drawingml/2006/main">
               <a:ext uri="{FF2B5EF4-FFF2-40B4-BE49-F238E27FC236}">
-                <a16:creationId xmlns:a16="http://schemas.microsoft.com/office/drawing/2014/main" id="{0533B342-AA5F-42D6-ABE6-0EFAC993F6B4}"/>
+                <a16:creationId xmlns:a16="http://schemas.microsoft.com/office/drawing/2014/main" id="{C3BF6626-CF9C-44D3-BF86-002A78979C05}"/>
               </a:ext>
             </a:extLst>
           </p:cNvPr>
@@ -7683,7 +7683,7 @@
           <p:cNvPr id="17" name="author">
             <a:extLst xmlns:a="http://schemas.openxmlformats.org/drawingml/2006/main">
               <a:ext uri="{FF2B5EF4-FFF2-40B4-BE49-F238E27FC236}">
-                <a16:creationId xmlns:a16="http://schemas.microsoft.com/office/drawing/2014/main" id="{0837309D-D50F-40E8-B7C0-EDE28117D6C9}"/>
+                <a16:creationId xmlns:a16="http://schemas.microsoft.com/office/drawing/2014/main" id="{EF84A0C1-F839-4F97-B10B-C9C00EACDAA8}"/>
               </a:ext>
             </a:extLst>
           </p:cNvPr>
@@ -7804,7 +7804,7 @@
           <p:cNvPr id="18" name="rules">
             <a:extLst xmlns:a="http://schemas.openxmlformats.org/drawingml/2006/main">
               <a:ext uri="{FF2B5EF4-FFF2-40B4-BE49-F238E27FC236}">
-                <a16:creationId xmlns:a16="http://schemas.microsoft.com/office/drawing/2014/main" id="{3D8D6C8D-11CD-4030-817B-4DC2A6FBFEC0}"/>
+                <a16:creationId xmlns:a16="http://schemas.microsoft.com/office/drawing/2014/main" id="{BAF43D20-B05D-4EC1-A106-871DCCDD3B35}"/>
               </a:ext>
             </a:extLst>
           </p:cNvPr>
@@ -7925,7 +7925,7 @@
           <p:cNvPr id="21" name="reply-label">
             <a:extLst xmlns:a="http://schemas.openxmlformats.org/drawingml/2006/main">
               <a:ext uri="{FF2B5EF4-FFF2-40B4-BE49-F238E27FC236}">
-                <a16:creationId xmlns:a16="http://schemas.microsoft.com/office/drawing/2014/main" id="{CA473A08-88A7-449D-9588-ECC13F0F63BD}"/>
+                <a16:creationId xmlns:a16="http://schemas.microsoft.com/office/drawing/2014/main" id="{79A9B09B-C025-48C7-A899-536B1749F314}"/>
               </a:ext>
             </a:extLst>
           </p:cNvPr>
@@ -7993,7 +7993,7 @@
           <p:cNvPr id="22" name="generate">
             <a:extLst xmlns:a="http://schemas.openxmlformats.org/drawingml/2006/main">
               <a:ext uri="{FF2B5EF4-FFF2-40B4-BE49-F238E27FC236}">
-                <a16:creationId xmlns:a16="http://schemas.microsoft.com/office/drawing/2014/main" id="{1947AC8A-5258-498D-9E2D-C01FBE9DF112}"/>
+                <a16:creationId xmlns:a16="http://schemas.microsoft.com/office/drawing/2014/main" id="{EBFF3DB7-2052-4735-BD4A-12A90698427E}"/>
               </a:ext>
             </a:extLst>
           </p:cNvPr>
@@ -8114,7 +8114,7 @@
           <p:cNvPr id="23" name="review">
             <a:extLst xmlns:a="http://schemas.openxmlformats.org/drawingml/2006/main">
               <a:ext uri="{FF2B5EF4-FFF2-40B4-BE49-F238E27FC236}">
-                <a16:creationId xmlns:a16="http://schemas.microsoft.com/office/drawing/2014/main" id="{B7C30FEC-29C3-4C58-A4BD-FD3AF6E56E84}"/>
+                <a16:creationId xmlns:a16="http://schemas.microsoft.com/office/drawing/2014/main" id="{047BCA43-5A2E-4018-AEEA-9BF16943CB52}"/>
               </a:ext>
             </a:extLst>
           </p:cNvPr>
@@ -8235,7 +8235,7 @@
           <p:cNvPr id="24" name="send">
             <a:extLst xmlns:a="http://schemas.openxmlformats.org/drawingml/2006/main">
               <a:ext uri="{FF2B5EF4-FFF2-40B4-BE49-F238E27FC236}">
-                <a16:creationId xmlns:a16="http://schemas.microsoft.com/office/drawing/2014/main" id="{D04FAEF2-C86E-4EA5-A6C1-48E911AF7866}"/>
+                <a16:creationId xmlns:a16="http://schemas.microsoft.com/office/drawing/2014/main" id="{F129FB71-9C64-4291-9722-8A6428C5DAD6}"/>
               </a:ext>
             </a:extLst>
           </p:cNvPr>
@@ -8356,7 +8356,7 @@
           <p:cNvPr id="28" name="legend">
             <a:extLst xmlns:a="http://schemas.openxmlformats.org/drawingml/2006/main">
               <a:ext uri="{FF2B5EF4-FFF2-40B4-BE49-F238E27FC236}">
-                <a16:creationId xmlns:a16="http://schemas.microsoft.com/office/drawing/2014/main" id="{FFE18842-1224-46A9-8974-1AC4AECBA2F8}"/>
+                <a16:creationId xmlns:a16="http://schemas.microsoft.com/office/drawing/2014/main" id="{2B1A7852-B24C-4816-893F-FF50D53C5DD0}"/>
               </a:ext>
             </a:extLst>
           </p:cNvPr>
@@ -8424,7 +8424,7 @@
           <p:cNvPr id="29" name="boundary">
             <a:extLst xmlns:a="http://schemas.openxmlformats.org/drawingml/2006/main">
               <a:ext uri="{FF2B5EF4-FFF2-40B4-BE49-F238E27FC236}">
-                <a16:creationId xmlns:a16="http://schemas.microsoft.com/office/drawing/2014/main" id="{176B82A5-C5D9-42DA-AE65-A41B2F185744}"/>
+                <a16:creationId xmlns:a16="http://schemas.microsoft.com/office/drawing/2014/main" id="{F3E4199B-9319-482F-B8E6-FF251595D7B0}"/>
               </a:ext>
             </a:extLst>
           </p:cNvPr>
@@ -8513,7 +8513,7 @@
     </p:spTree>
     <p:extLst>
       <p:ext uri="{BB962C8B-B14F-4D97-AF65-F5344CB8AC3E}">
-        <p14:creationId xmlns:p14="http://schemas.microsoft.com/office/powerpoint/2010/main" val="1609199717"/>
+        <p14:creationId xmlns:p14="http://schemas.microsoft.com/office/powerpoint/2010/main" val="1508020845"/>
       </p:ext>
     </p:extLst>
   </p:cSld>
@@ -8544,7 +8544,7 @@
           <p:cNvPr id="30" name="">
             <a:extLst xmlns:a="http://schemas.openxmlformats.org/drawingml/2006/main">
               <a:ext uri="{FF2B5EF4-FFF2-40B4-BE49-F238E27FC236}">
-                <a16:creationId xmlns:a16="http://schemas.microsoft.com/office/drawing/2014/main" id="{D594FB77-2A1A-4275-BC1D-F36859F5FF3B}"/>
+                <a16:creationId xmlns:a16="http://schemas.microsoft.com/office/drawing/2014/main" id="{22BEED7F-2872-4FF9-A755-4D298A43ED6A}"/>
               </a:ext>
             </a:extLst>
           </p:cNvPr>
@@ -8576,7 +8576,7 @@
           <p:cNvPr id="20" name="">
             <a:extLst xmlns:a="http://schemas.openxmlformats.org/drawingml/2006/main">
               <a:ext uri="{FF2B5EF4-FFF2-40B4-BE49-F238E27FC236}">
-                <a16:creationId xmlns:a16="http://schemas.microsoft.com/office/drawing/2014/main" id="{82054B62-C5B8-4E44-A1C2-EFFA42DE95E0}"/>
+                <a16:creationId xmlns:a16="http://schemas.microsoft.com/office/drawing/2014/main" id="{976C453E-3F92-44A5-848B-C37FAB4A7A15}"/>
               </a:ext>
             </a:extLst>
           </p:cNvPr>
@@ -8610,7 +8610,7 @@
           <p:cNvPr id="18" name="">
             <a:extLst xmlns:a="http://schemas.openxmlformats.org/drawingml/2006/main">
               <a:ext uri="{FF2B5EF4-FFF2-40B4-BE49-F238E27FC236}">
-                <a16:creationId xmlns:a16="http://schemas.microsoft.com/office/drawing/2014/main" id="{390A424C-6C72-4B66-8ACE-0B28A2FCEFFA}"/>
+                <a16:creationId xmlns:a16="http://schemas.microsoft.com/office/drawing/2014/main" id="{DB8F6C5A-563F-4B22-85C6-DD1B493857D3}"/>
               </a:ext>
             </a:extLst>
           </p:cNvPr>
@@ -8644,7 +8644,7 @@
           <p:cNvPr id="16" name="">
             <a:extLst xmlns:a="http://schemas.openxmlformats.org/drawingml/2006/main">
               <a:ext uri="{FF2B5EF4-FFF2-40B4-BE49-F238E27FC236}">
-                <a16:creationId xmlns:a16="http://schemas.microsoft.com/office/drawing/2014/main" id="{BF21341A-3FDE-49F7-9254-A0DA3ACA0313}"/>
+                <a16:creationId xmlns:a16="http://schemas.microsoft.com/office/drawing/2014/main" id="{46AD97E8-FAA0-4DCD-A17A-296A1959F679}"/>
               </a:ext>
             </a:extLst>
           </p:cNvPr>
@@ -8676,7 +8676,7 @@
           <p:cNvPr id="14" name="">
             <a:extLst xmlns:a="http://schemas.openxmlformats.org/drawingml/2006/main">
               <a:ext uri="{FF2B5EF4-FFF2-40B4-BE49-F238E27FC236}">
-                <a16:creationId xmlns:a16="http://schemas.microsoft.com/office/drawing/2014/main" id="{12514041-DAF5-4F35-A746-8A04F7A8EBA4}"/>
+                <a16:creationId xmlns:a16="http://schemas.microsoft.com/office/drawing/2014/main" id="{C8AA00F1-3398-4339-BFD6-858FA7FFE5ED}"/>
               </a:ext>
             </a:extLst>
           </p:cNvPr>
@@ -8708,7 +8708,7 @@
           <p:cNvPr id="36" name="title">
             <a:extLst xmlns:a="http://schemas.openxmlformats.org/drawingml/2006/main">
               <a:ext uri="{FF2B5EF4-FFF2-40B4-BE49-F238E27FC236}">
-                <a16:creationId xmlns:a16="http://schemas.microsoft.com/office/drawing/2014/main" id="{A2A63750-A305-4ACF-8D90-28424FFBA51A}"/>
+                <a16:creationId xmlns:a16="http://schemas.microsoft.com/office/drawing/2014/main" id="{1D06904D-4B8F-45C3-A5CC-F2DE9FEE77ED}"/>
               </a:ext>
             </a:extLst>
           </p:cNvPr>
@@ -8776,7 +8776,7 @@
           <p:cNvPr id="2" name="page">
             <a:extLst xmlns:a="http://schemas.openxmlformats.org/drawingml/2006/main">
               <a:ext uri="{FF2B5EF4-FFF2-40B4-BE49-F238E27FC236}">
-                <a16:creationId xmlns:a16="http://schemas.microsoft.com/office/drawing/2014/main" id="{36AA7C6D-62E1-4579-8836-99A62000DD45}"/>
+                <a16:creationId xmlns:a16="http://schemas.microsoft.com/office/drawing/2014/main" id="{7B3B9635-7B54-4AE4-BCD0-E56F88DF8936}"/>
               </a:ext>
             </a:extLst>
           </p:cNvPr>
@@ -8844,7 +8844,7 @@
           <p:cNvPr id="3" name="caption">
             <a:extLst xmlns:a="http://schemas.openxmlformats.org/drawingml/2006/main">
               <a:ext uri="{FF2B5EF4-FFF2-40B4-BE49-F238E27FC236}">
-                <a16:creationId xmlns:a16="http://schemas.microsoft.com/office/drawing/2014/main" id="{7DE27461-4E1C-4EBD-9663-B97630E38248}"/>
+                <a16:creationId xmlns:a16="http://schemas.microsoft.com/office/drawing/2014/main" id="{F133DF95-1104-4310-BDE8-AEC2F5A9C279}"/>
               </a:ext>
             </a:extLst>
           </p:cNvPr>
@@ -8912,7 +8912,7 @@
           <p:cNvPr id="4" name="am">
             <a:extLst xmlns:a="http://schemas.openxmlformats.org/drawingml/2006/main">
               <a:ext uri="{FF2B5EF4-FFF2-40B4-BE49-F238E27FC236}">
-                <a16:creationId xmlns:a16="http://schemas.microsoft.com/office/drawing/2014/main" id="{5FBDBADA-E048-414F-A9B4-7982ABA84105}"/>
+                <a16:creationId xmlns:a16="http://schemas.microsoft.com/office/drawing/2014/main" id="{779FA8F9-923D-422E-A40B-BBC098932498}"/>
               </a:ext>
             </a:extLst>
           </p:cNvPr>
@@ -9012,7 +9012,7 @@
           <p:cNvPr id="5" name="portal">
             <a:extLst xmlns:a="http://schemas.openxmlformats.org/drawingml/2006/main">
               <a:ext uri="{FF2B5EF4-FFF2-40B4-BE49-F238E27FC236}">
-                <a16:creationId xmlns:a16="http://schemas.microsoft.com/office/drawing/2014/main" id="{76BDBA33-5473-4C74-82B0-B20B355F64C7}"/>
+                <a16:creationId xmlns:a16="http://schemas.microsoft.com/office/drawing/2014/main" id="{07F8295C-CECC-445F-AA32-2A8C8AA6517F}"/>
               </a:ext>
             </a:extLst>
           </p:cNvPr>
@@ -9112,7 +9112,7 @@
           <p:cNvPr id="6" name="java">
             <a:extLst xmlns:a="http://schemas.openxmlformats.org/drawingml/2006/main">
               <a:ext uri="{FF2B5EF4-FFF2-40B4-BE49-F238E27FC236}">
-                <a16:creationId xmlns:a16="http://schemas.microsoft.com/office/drawing/2014/main" id="{75F9C9A1-E413-4593-89E0-6F8504154C92}"/>
+                <a16:creationId xmlns:a16="http://schemas.microsoft.com/office/drawing/2014/main" id="{6CD28521-B790-4E99-8746-24C526359B7D}"/>
               </a:ext>
             </a:extLst>
           </p:cNvPr>
@@ -9275,7 +9275,7 @@
           <p:cNvPr id="7" name="okta">
             <a:extLst xmlns:a="http://schemas.openxmlformats.org/drawingml/2006/main">
               <a:ext uri="{FF2B5EF4-FFF2-40B4-BE49-F238E27FC236}">
-                <a16:creationId xmlns:a16="http://schemas.microsoft.com/office/drawing/2014/main" id="{85FD9B7E-7AFE-4AE5-9210-51F3579FF210}"/>
+                <a16:creationId xmlns:a16="http://schemas.microsoft.com/office/drawing/2014/main" id="{AB63FE94-6961-44EC-93A6-963DF45AD2EC}"/>
               </a:ext>
             </a:extLst>
           </p:cNvPr>
@@ -9396,7 +9396,7 @@
           <p:cNvPr id="8" name="entra">
             <a:extLst xmlns:a="http://schemas.openxmlformats.org/drawingml/2006/main">
               <a:ext uri="{FF2B5EF4-FFF2-40B4-BE49-F238E27FC236}">
-                <a16:creationId xmlns:a16="http://schemas.microsoft.com/office/drawing/2014/main" id="{4AABA699-1D61-43A7-95B8-DB8D7C171811}"/>
+                <a16:creationId xmlns:a16="http://schemas.microsoft.com/office/drawing/2014/main" id="{7BB9F9DC-D2E5-42DF-951C-35934FE2106C}"/>
               </a:ext>
             </a:extLst>
           </p:cNvPr>
@@ -9517,7 +9517,7 @@
           <p:cNvPr id="9" name="graph">
             <a:extLst xmlns:a="http://schemas.openxmlformats.org/drawingml/2006/main">
               <a:ext uri="{FF2B5EF4-FFF2-40B4-BE49-F238E27FC236}">
-                <a16:creationId xmlns:a16="http://schemas.microsoft.com/office/drawing/2014/main" id="{C2A7EF92-2088-4E03-BDFE-2F8E6B4D465A}"/>
+                <a16:creationId xmlns:a16="http://schemas.microsoft.com/office/drawing/2014/main" id="{3CDE0E2A-B5A2-4ADC-B508-7AC38D82F652}"/>
               </a:ext>
             </a:extLst>
           </p:cNvPr>
@@ -9617,7 +9617,7 @@
           <p:cNvPr id="10" name="foundry">
             <a:extLst xmlns:a="http://schemas.openxmlformats.org/drawingml/2006/main">
               <a:ext uri="{FF2B5EF4-FFF2-40B4-BE49-F238E27FC236}">
-                <a16:creationId xmlns:a16="http://schemas.microsoft.com/office/drawing/2014/main" id="{8384C5C3-09FC-4EC3-9E63-8FC85C7996AF}"/>
+                <a16:creationId xmlns:a16="http://schemas.microsoft.com/office/drawing/2014/main" id="{7F35B7EB-21B4-4EA6-99E8-A687CCB5338A}"/>
               </a:ext>
             </a:extLst>
           </p:cNvPr>
@@ -9738,7 +9738,7 @@
           <p:cNvPr id="11" name="blob">
             <a:extLst xmlns:a="http://schemas.openxmlformats.org/drawingml/2006/main">
               <a:ext uri="{FF2B5EF4-FFF2-40B4-BE49-F238E27FC236}">
-                <a16:creationId xmlns:a16="http://schemas.microsoft.com/office/drawing/2014/main" id="{E006D3C6-510C-4928-8C81-EB354D9EF974}"/>
+                <a16:creationId xmlns:a16="http://schemas.microsoft.com/office/drawing/2014/main" id="{F772A77F-55A8-492B-909A-6B0A9C47978D}"/>
               </a:ext>
             </a:extLst>
           </p:cNvPr>
@@ -9859,7 +9859,7 @@
           <p:cNvPr id="12" name="postgres">
             <a:extLst xmlns:a="http://schemas.openxmlformats.org/drawingml/2006/main">
               <a:ext uri="{FF2B5EF4-FFF2-40B4-BE49-F238E27FC236}">
-                <a16:creationId xmlns:a16="http://schemas.microsoft.com/office/drawing/2014/main" id="{2DFFAC62-EDB1-4C8B-B2B9-EC90073BEB99}"/>
+                <a16:creationId xmlns:a16="http://schemas.microsoft.com/office/drawing/2014/main" id="{76254B85-DDE4-4F7B-A58C-05C935CCD88A}"/>
               </a:ext>
             </a:extLst>
           </p:cNvPr>
@@ -9980,7 +9980,7 @@
           <p:cNvPr id="13" name="monitor">
             <a:extLst xmlns:a="http://schemas.openxmlformats.org/drawingml/2006/main">
               <a:ext uri="{FF2B5EF4-FFF2-40B4-BE49-F238E27FC236}">
-                <a16:creationId xmlns:a16="http://schemas.microsoft.com/office/drawing/2014/main" id="{8EAE3103-25A3-461E-8D35-8110757C556D}"/>
+                <a16:creationId xmlns:a16="http://schemas.microsoft.com/office/drawing/2014/main" id="{ABF25B27-B8A4-49DD-904D-F97015FF0D39}"/>
               </a:ext>
             </a:extLst>
           </p:cNvPr>
@@ -10101,7 +10101,7 @@
           <p:cNvPr id="15" name="https">
             <a:extLst xmlns:a="http://schemas.openxmlformats.org/drawingml/2006/main">
               <a:ext uri="{FF2B5EF4-FFF2-40B4-BE49-F238E27FC236}">
-                <a16:creationId xmlns:a16="http://schemas.microsoft.com/office/drawing/2014/main" id="{EBB8B441-40DA-49F2-BCE1-C0C55EC1385F}"/>
+                <a16:creationId xmlns:a16="http://schemas.microsoft.com/office/drawing/2014/main" id="{7D45B7D9-9502-483A-AC70-DFA9031FF7B3}"/>
               </a:ext>
             </a:extLst>
           </p:cNvPr>
@@ -10169,7 +10169,7 @@
           <p:cNvPr id="17" name="http">
             <a:extLst xmlns:a="http://schemas.openxmlformats.org/drawingml/2006/main">
               <a:ext uri="{FF2B5EF4-FFF2-40B4-BE49-F238E27FC236}">
-                <a16:creationId xmlns:a16="http://schemas.microsoft.com/office/drawing/2014/main" id="{476A17B0-7A7E-402A-9FC9-F7333914CED9}"/>
+                <a16:creationId xmlns:a16="http://schemas.microsoft.com/office/drawing/2014/main" id="{0B55DE8A-8574-4BEB-AECB-302E83EC6195}"/>
               </a:ext>
             </a:extLst>
           </p:cNvPr>
@@ -10237,7 +10237,7 @@
           <p:cNvPr id="19" name="sso">
             <a:extLst xmlns:a="http://schemas.openxmlformats.org/drawingml/2006/main">
               <a:ext uri="{FF2B5EF4-FFF2-40B4-BE49-F238E27FC236}">
-                <a16:creationId xmlns:a16="http://schemas.microsoft.com/office/drawing/2014/main" id="{7F6EDADB-B0FB-40FD-90D2-4E60DB017EEF}"/>
+                <a16:creationId xmlns:a16="http://schemas.microsoft.com/office/drawing/2014/main" id="{3CDE01A7-49BC-4644-97D8-78050DCD8C56}"/>
               </a:ext>
             </a:extLst>
           </p:cNvPr>
@@ -10305,7 +10305,7 @@
           <p:cNvPr id="21" name="graph-call-1">
             <a:extLst xmlns:a="http://schemas.openxmlformats.org/drawingml/2006/main">
               <a:ext uri="{FF2B5EF4-FFF2-40B4-BE49-F238E27FC236}">
-                <a16:creationId xmlns:a16="http://schemas.microsoft.com/office/drawing/2014/main" id="{C3F9AF3B-DAC4-49A3-9CA1-2262CE961D72}"/>
+                <a16:creationId xmlns:a16="http://schemas.microsoft.com/office/drawing/2014/main" id="{5BE18B49-5222-4195-9A27-15E67A537C1C}"/>
               </a:ext>
             </a:extLst>
           </p:cNvPr>
@@ -10333,7 +10333,7 @@
           <p:cNvPr id="22" name="graph-call-2">
             <a:extLst xmlns:a="http://schemas.openxmlformats.org/drawingml/2006/main">
               <a:ext uri="{FF2B5EF4-FFF2-40B4-BE49-F238E27FC236}">
-                <a16:creationId xmlns:a16="http://schemas.microsoft.com/office/drawing/2014/main" id="{4B2D5952-016D-49F2-9935-6E8F5ED1A8F3}"/>
+                <a16:creationId xmlns:a16="http://schemas.microsoft.com/office/drawing/2014/main" id="{6CD87005-3E1E-48AD-9D6F-C792B561CA37}"/>
               </a:ext>
             </a:extLst>
           </p:cNvPr>
@@ -10361,7 +10361,7 @@
           <p:cNvPr id="23" name="graph-call-3">
             <a:extLst xmlns:a="http://schemas.openxmlformats.org/drawingml/2006/main">
               <a:ext uri="{FF2B5EF4-FFF2-40B4-BE49-F238E27FC236}">
-                <a16:creationId xmlns:a16="http://schemas.microsoft.com/office/drawing/2014/main" id="{BD9E9D83-0C60-44D6-A03B-FE8B9E440916}"/>
+                <a16:creationId xmlns:a16="http://schemas.microsoft.com/office/drawing/2014/main" id="{AFE6DCFF-921F-475F-9F89-EEC436737259}"/>
               </a:ext>
             </a:extLst>
           </p:cNvPr>
@@ -10390,7 +10390,7 @@
           <p:cNvPr id="24" name="model-call-1">
             <a:extLst xmlns:a="http://schemas.openxmlformats.org/drawingml/2006/main">
               <a:ext uri="{FF2B5EF4-FFF2-40B4-BE49-F238E27FC236}">
-                <a16:creationId xmlns:a16="http://schemas.microsoft.com/office/drawing/2014/main" id="{877979B7-47F7-4234-A756-EABAD75F35CA}"/>
+                <a16:creationId xmlns:a16="http://schemas.microsoft.com/office/drawing/2014/main" id="{AEF44207-4AFC-4CE9-BB28-3932A66ACD95}"/>
               </a:ext>
             </a:extLst>
           </p:cNvPr>
@@ -10418,7 +10418,7 @@
           <p:cNvPr id="25" name="model-call-2">
             <a:extLst xmlns:a="http://schemas.openxmlformats.org/drawingml/2006/main">
               <a:ext uri="{FF2B5EF4-FFF2-40B4-BE49-F238E27FC236}">
-                <a16:creationId xmlns:a16="http://schemas.microsoft.com/office/drawing/2014/main" id="{3B70F274-F552-4892-8CBA-F8BCB0E0DC58}"/>
+                <a16:creationId xmlns:a16="http://schemas.microsoft.com/office/drawing/2014/main" id="{772FFCD0-B766-4B3F-ABC6-90B8348625A7}"/>
               </a:ext>
             </a:extLst>
           </p:cNvPr>
@@ -10446,7 +10446,7 @@
           <p:cNvPr id="26" name="model-call-3">
             <a:extLst xmlns:a="http://schemas.openxmlformats.org/drawingml/2006/main">
               <a:ext uri="{FF2B5EF4-FFF2-40B4-BE49-F238E27FC236}">
-                <a16:creationId xmlns:a16="http://schemas.microsoft.com/office/drawing/2014/main" id="{CB8D5564-A6BC-4122-BDDE-BA08A3A470FE}"/>
+                <a16:creationId xmlns:a16="http://schemas.microsoft.com/office/drawing/2014/main" id="{548A98EB-1CD0-4E3C-A02A-4063AE8B59E8}"/>
               </a:ext>
             </a:extLst>
           </p:cNvPr>
@@ -10475,7 +10475,7 @@
           <p:cNvPr id="27" name="artifact-call-1">
             <a:extLst xmlns:a="http://schemas.openxmlformats.org/drawingml/2006/main">
               <a:ext uri="{FF2B5EF4-FFF2-40B4-BE49-F238E27FC236}">
-                <a16:creationId xmlns:a16="http://schemas.microsoft.com/office/drawing/2014/main" id="{5DE0FC56-F161-41CE-9AED-574C5D2CF96C}"/>
+                <a16:creationId xmlns:a16="http://schemas.microsoft.com/office/drawing/2014/main" id="{55953912-F800-4503-ABDC-2D46C6B7858B}"/>
               </a:ext>
             </a:extLst>
           </p:cNvPr>
@@ -10503,7 +10503,7 @@
           <p:cNvPr id="28" name="artifact-call-2">
             <a:extLst xmlns:a="http://schemas.openxmlformats.org/drawingml/2006/main">
               <a:ext uri="{FF2B5EF4-FFF2-40B4-BE49-F238E27FC236}">
-                <a16:creationId xmlns:a16="http://schemas.microsoft.com/office/drawing/2014/main" id="{A03EC112-97FA-4CEF-821F-88247A107421}"/>
+                <a16:creationId xmlns:a16="http://schemas.microsoft.com/office/drawing/2014/main" id="{34D0BD0F-5283-4365-AAEC-DBE84F6F6D0E}"/>
               </a:ext>
             </a:extLst>
           </p:cNvPr>
@@ -10531,7 +10531,7 @@
           <p:cNvPr id="29" name="artifact-call-3">
             <a:extLst xmlns:a="http://schemas.openxmlformats.org/drawingml/2006/main">
               <a:ext uri="{FF2B5EF4-FFF2-40B4-BE49-F238E27FC236}">
-                <a16:creationId xmlns:a16="http://schemas.microsoft.com/office/drawing/2014/main" id="{040C57D6-B5F4-4749-BFCC-DF91317EE3A2}"/>
+                <a16:creationId xmlns:a16="http://schemas.microsoft.com/office/drawing/2014/main" id="{94936629-EB89-470C-8F5A-C32B5F98DBCF}"/>
               </a:ext>
             </a:extLst>
           </p:cNvPr>
@@ -10560,7 +10560,7 @@
           <p:cNvPr id="31" name="jdbc">
             <a:extLst xmlns:a="http://schemas.openxmlformats.org/drawingml/2006/main">
               <a:ext uri="{FF2B5EF4-FFF2-40B4-BE49-F238E27FC236}">
-                <a16:creationId xmlns:a16="http://schemas.microsoft.com/office/drawing/2014/main" id="{D648908A-0674-4675-B1AC-1733C83FE85A}"/>
+                <a16:creationId xmlns:a16="http://schemas.microsoft.com/office/drawing/2014/main" id="{E9897988-2994-4635-84B1-5EA9E14402EC}"/>
               </a:ext>
             </a:extLst>
           </p:cNvPr>
@@ -10628,7 +10628,7 @@
           <p:cNvPr id="32" name="telemetry-1">
             <a:extLst xmlns:a="http://schemas.openxmlformats.org/drawingml/2006/main">
               <a:ext uri="{FF2B5EF4-FFF2-40B4-BE49-F238E27FC236}">
-                <a16:creationId xmlns:a16="http://schemas.microsoft.com/office/drawing/2014/main" id="{D58AF676-03FD-4E44-90DC-6ADD46A19B69}"/>
+                <a16:creationId xmlns:a16="http://schemas.microsoft.com/office/drawing/2014/main" id="{582AF159-AFE1-45FB-92DD-CB3CD130C08C}"/>
               </a:ext>
             </a:extLst>
           </p:cNvPr>
@@ -10656,7 +10656,7 @@
           <p:cNvPr id="33" name="telemetry-2">
             <a:extLst xmlns:a="http://schemas.openxmlformats.org/drawingml/2006/main">
               <a:ext uri="{FF2B5EF4-FFF2-40B4-BE49-F238E27FC236}">
-                <a16:creationId xmlns:a16="http://schemas.microsoft.com/office/drawing/2014/main" id="{B7766E2C-D407-4698-840C-DCAEFA6D0566}"/>
+                <a16:creationId xmlns:a16="http://schemas.microsoft.com/office/drawing/2014/main" id="{D06FB53A-18F7-4E7E-B16B-DCBDF268AF8C}"/>
               </a:ext>
             </a:extLst>
           </p:cNvPr>
@@ -10684,7 +10684,7 @@
           <p:cNvPr id="34" name="telemetry-3">
             <a:extLst xmlns:a="http://schemas.openxmlformats.org/drawingml/2006/main">
               <a:ext uri="{FF2B5EF4-FFF2-40B4-BE49-F238E27FC236}">
-                <a16:creationId xmlns:a16="http://schemas.microsoft.com/office/drawing/2014/main" id="{5E74973D-0D88-47CB-B342-67E912AEB64E}"/>
+                <a16:creationId xmlns:a16="http://schemas.microsoft.com/office/drawing/2014/main" id="{F048A1B5-14B2-43DF-8D1F-E6C4913ADE4A}"/>
               </a:ext>
             </a:extLst>
           </p:cNvPr>
@@ -10713,7 +10713,7 @@
           <p:cNvPr id="35" name="health">
             <a:extLst xmlns:a="http://schemas.openxmlformats.org/drawingml/2006/main">
               <a:ext uri="{FF2B5EF4-FFF2-40B4-BE49-F238E27FC236}">
-                <a16:creationId xmlns:a16="http://schemas.microsoft.com/office/drawing/2014/main" id="{08C5076E-DF00-4439-A9A1-5426A55104D1}"/>
+                <a16:creationId xmlns:a16="http://schemas.microsoft.com/office/drawing/2014/main" id="{8EF40E56-3C49-4F4C-A61C-8DCFE1D32CD6}"/>
               </a:ext>
             </a:extLst>
           </p:cNvPr>
@@ -10779,7 +10779,7 @@
     </p:spTree>
     <p:extLst>
       <p:ext uri="{BB962C8B-B14F-4D97-AF65-F5344CB8AC3E}">
-        <p14:creationId xmlns:p14="http://schemas.microsoft.com/office/powerpoint/2010/main" val="133037022"/>
+        <p14:creationId xmlns:p14="http://schemas.microsoft.com/office/powerpoint/2010/main" val="545182662"/>
       </p:ext>
     </p:extLst>
   </p:cSld>
@@ -10807,10 +10807,10 @@
       </p:grpSpPr>
       <p:sp>
         <p:nvSpPr>
-          <p:cNvPr id="10" name="title">
+          <p:cNvPr id="12" name="title">
             <a:extLst xmlns:a="http://schemas.openxmlformats.org/drawingml/2006/main">
               <a:ext uri="{FF2B5EF4-FFF2-40B4-BE49-F238E27FC236}">
-                <a16:creationId xmlns:a16="http://schemas.microsoft.com/office/drawing/2014/main" id="{F9CFA74C-B36D-4E3C-87C6-19635F98FEB7}"/>
+                <a16:creationId xmlns:a16="http://schemas.microsoft.com/office/drawing/2014/main" id="{0CA62B14-EC1A-4529-AC32-9C783CB24F25}"/>
               </a:ext>
             </a:extLst>
           </p:cNvPr>
@@ -10868,7 +10868,7 @@
                 <a:ea typeface="Arial"/>
                 <a:cs typeface="Arial"/>
               </a:rPr>
-              <a:t>Delivery Milestones and Estimated Labor Cost</a:t>
+              <a:t>Delivery Milestones and Estimated Project Cost</a:t>
             </a:r>
           </a:p>
         </p:txBody>
@@ -10878,7 +10878,7 @@
           <p:cNvPr id="2" name="page">
             <a:extLst xmlns:a="http://schemas.openxmlformats.org/drawingml/2006/main">
               <a:ext uri="{FF2B5EF4-FFF2-40B4-BE49-F238E27FC236}">
-                <a16:creationId xmlns:a16="http://schemas.microsoft.com/office/drawing/2014/main" id="{C9FEFE5E-BEEC-4B69-BE5B-657E06E5DF03}"/>
+                <a16:creationId xmlns:a16="http://schemas.microsoft.com/office/drawing/2014/main" id="{0D604979-64B4-4AC5-97E5-3BDF699DD900}"/>
               </a:ext>
             </a:extLst>
           </p:cNvPr>
@@ -10946,7 +10946,7 @@
           <p:cNvPr id="3" name="window">
             <a:extLst xmlns:a="http://schemas.openxmlformats.org/drawingml/2006/main">
               <a:ext uri="{FF2B5EF4-FFF2-40B4-BE49-F238E27FC236}">
-                <a16:creationId xmlns:a16="http://schemas.microsoft.com/office/drawing/2014/main" id="{74AAD78B-BA80-4B01-9C72-E6D59F5A3CD6}"/>
+                <a16:creationId xmlns:a16="http://schemas.microsoft.com/office/drawing/2014/main" id="{ABA1556D-5C93-4AA1-8BB0-EBE429C05599}"/>
               </a:ext>
             </a:extLst>
           </p:cNvPr>
@@ -11014,7 +11014,7 @@
           <p:cNvPr id="4" name="">
             <a:extLst xmlns:a="http://schemas.openxmlformats.org/drawingml/2006/main">
               <a:ext uri="{FF2B5EF4-FFF2-40B4-BE49-F238E27FC236}">
-                <a16:creationId xmlns:a16="http://schemas.microsoft.com/office/drawing/2014/main" id="{1C79FE83-C887-4C95-AAC8-FF5313620895}"/>
+                <a16:creationId xmlns:a16="http://schemas.microsoft.com/office/drawing/2014/main" id="{06B7C8A0-521E-4798-BF3D-BF23ECD38CD2}"/>
               </a:ext>
             </a:extLst>
           </p:cNvPr>
@@ -11033,7 +11033,7 @@
                 <a:gridCol w="5524500"/>
                 <a:gridCol w="2762250"/>
               </a:tblGrid>
-              <a:tr h="419100">
+              <a:tr h="389164">
                 <a:tc>
                   <a:txBody>
                     <a:bodyPr/>
@@ -11125,7 +11125,7 @@
                   </a:tcPr>
                 </a:tc>
               </a:tr>
-              <a:tr h="419100">
+              <a:tr h="389164">
                 <a:tc>
                   <a:txBody>
                     <a:bodyPr/>
@@ -11205,7 +11205,7 @@
                   </a:tcPr>
                 </a:tc>
               </a:tr>
-              <a:tr h="419100">
+              <a:tr h="389164">
                 <a:tc>
                   <a:txBody>
                     <a:bodyPr/>
@@ -11285,7 +11285,7 @@
                   </a:tcPr>
                 </a:tc>
               </a:tr>
-              <a:tr h="419100">
+              <a:tr h="389164">
                 <a:tc>
                   <a:txBody>
                     <a:bodyPr/>
@@ -11365,7 +11365,7 @@
                   </a:tcPr>
                 </a:tc>
               </a:tr>
-              <a:tr h="419100">
+              <a:tr h="389164">
                 <a:tc>
                   <a:txBody>
                     <a:bodyPr/>
@@ -11445,7 +11445,7 @@
                   </a:tcPr>
                 </a:tc>
               </a:tr>
-              <a:tr h="419100">
+              <a:tr h="389164">
                 <a:tc>
                   <a:txBody>
                     <a:bodyPr/>
@@ -11525,7 +11525,7 @@
                   </a:tcPr>
                 </a:tc>
               </a:tr>
-              <a:tr h="419100">
+              <a:tr h="389164">
                 <a:tc>
                   <a:txBody>
                     <a:bodyPr/>
@@ -11540,7 +11540,167 @@
                           <a:ea typeface="Arial"/>
                           <a:cs typeface="Arial"/>
                         </a:rPr>
-                        <a:t>SIT signoff</a:t>
+                        <a:t>SIT signoff and UAT environment ready</a:t>
+                      </a:r>
+                    </a:p>
+                  </a:txBody>
+                  <a:tcPr marL="114300" marR="114300" marT="28575" marB="28575" anchor="ctr">
+                    <a:lnL w="6668">
+                      <a:solidFill>
+                        <a:srgbClr val="DFE5EC"/>
+                      </a:solidFill>
+                      <a:prstDash val="solid"/>
+                    </a:lnL>
+                    <a:lnR w="6668">
+                      <a:solidFill>
+                        <a:srgbClr val="DFE5EC"/>
+                      </a:solidFill>
+                      <a:prstDash val="solid"/>
+                    </a:lnR>
+                    <a:lnB w="6668">
+                      <a:solidFill>
+                        <a:srgbClr val="DFE5EC"/>
+                      </a:solidFill>
+                      <a:prstDash val="solid"/>
+                    </a:lnB>
+                    <a:solidFill>
+                      <a:srgbClr val="FFFFFF"/>
+                    </a:solidFill>
+                  </a:tcPr>
+                </a:tc>
+                <a:tc>
+                  <a:txBody>
+                    <a:bodyPr/>
+                    <a:lstStyle/>
+                    <a:p>
+                      <a:r>
+                        <a:rPr sz="1725">
+                          <a:solidFill>
+                            <a:srgbClr val="132B45"/>
+                          </a:solidFill>
+                          <a:latin typeface="Arial"/>
+                          <a:ea typeface="Arial"/>
+                          <a:cs typeface="Arial"/>
+                        </a:rPr>
+                        <a:t>15 Jan 2027</a:t>
+                      </a:r>
+                    </a:p>
+                  </a:txBody>
+                  <a:tcPr marL="114300" marR="114300" marT="28575" marB="28575" anchor="ctr">
+                    <a:lnR w="6668">
+                      <a:solidFill>
+                        <a:srgbClr val="DFE5EC"/>
+                      </a:solidFill>
+                      <a:prstDash val="solid"/>
+                    </a:lnR>
+                    <a:lnB w="6668">
+                      <a:solidFill>
+                        <a:srgbClr val="DFE5EC"/>
+                      </a:solidFill>
+                      <a:prstDash val="solid"/>
+                    </a:lnB>
+                    <a:solidFill>
+                      <a:srgbClr val="FFFFFF"/>
+                    </a:solidFill>
+                  </a:tcPr>
+                </a:tc>
+              </a:tr>
+              <a:tr h="389164">
+                <a:tc>
+                  <a:txBody>
+                    <a:bodyPr/>
+                    <a:lstStyle/>
+                    <a:p>
+                      <a:r>
+                        <a:rPr sz="1725">
+                          <a:solidFill>
+                            <a:srgbClr val="132B45"/>
+                          </a:solidFill>
+                          <a:latin typeface="Arial"/>
+                          <a:ea typeface="Arial"/>
+                          <a:cs typeface="Arial"/>
+                        </a:rPr>
+                        <a:t>Potential-user UAT start</a:t>
+                      </a:r>
+                    </a:p>
+                  </a:txBody>
+                  <a:tcPr marL="114300" marR="114300" marT="28575" marB="28575" anchor="ctr">
+                    <a:lnL w="6668">
+                      <a:solidFill>
+                        <a:srgbClr val="DFE5EC"/>
+                      </a:solidFill>
+                      <a:prstDash val="solid"/>
+                    </a:lnL>
+                    <a:lnR w="6668">
+                      <a:solidFill>
+                        <a:srgbClr val="DFE5EC"/>
+                      </a:solidFill>
+                      <a:prstDash val="solid"/>
+                    </a:lnR>
+                    <a:lnB w="6668">
+                      <a:solidFill>
+                        <a:srgbClr val="DFE5EC"/>
+                      </a:solidFill>
+                      <a:prstDash val="solid"/>
+                    </a:lnB>
+                    <a:solidFill>
+                      <a:srgbClr val="FFFFFF"/>
+                    </a:solidFill>
+                  </a:tcPr>
+                </a:tc>
+                <a:tc>
+                  <a:txBody>
+                    <a:bodyPr/>
+                    <a:lstStyle/>
+                    <a:p>
+                      <a:r>
+                        <a:rPr sz="1725">
+                          <a:solidFill>
+                            <a:srgbClr val="132B45"/>
+                          </a:solidFill>
+                          <a:latin typeface="Arial"/>
+                          <a:ea typeface="Arial"/>
+                          <a:cs typeface="Arial"/>
+                        </a:rPr>
+                        <a:t>18 Jan 2027</a:t>
+                      </a:r>
+                    </a:p>
+                  </a:txBody>
+                  <a:tcPr marL="114300" marR="114300" marT="28575" marB="28575" anchor="ctr">
+                    <a:lnR w="6668">
+                      <a:solidFill>
+                        <a:srgbClr val="DFE5EC"/>
+                      </a:solidFill>
+                      <a:prstDash val="solid"/>
+                    </a:lnR>
+                    <a:lnB w="6668">
+                      <a:solidFill>
+                        <a:srgbClr val="DFE5EC"/>
+                      </a:solidFill>
+                      <a:prstDash val="solid"/>
+                    </a:lnB>
+                    <a:solidFill>
+                      <a:srgbClr val="FFFFFF"/>
+                    </a:solidFill>
+                  </a:tcPr>
+                </a:tc>
+              </a:tr>
+              <a:tr h="389164">
+                <a:tc>
+                  <a:txBody>
+                    <a:bodyPr/>
+                    <a:lstStyle/>
+                    <a:p>
+                      <a:r>
+                        <a:rPr sz="1725">
+                          <a:solidFill>
+                            <a:srgbClr val="132B45"/>
+                          </a:solidFill>
+                          <a:latin typeface="Arial"/>
+                          <a:ea typeface="Arial"/>
+                          <a:cs typeface="Arial"/>
+                        </a:rPr>
+                        <a:t>Penetration-test report</a:t>
                       </a:r>
                     </a:p>
                   </a:txBody>
@@ -11605,7 +11765,7 @@
                   </a:tcPr>
                 </a:tc>
               </a:tr>
-              <a:tr h="419100">
+              <a:tr h="389164">
                 <a:tc>
                   <a:txBody>
                     <a:bodyPr/>
@@ -11620,7 +11780,7 @@
                           <a:ea typeface="Arial"/>
                           <a:cs typeface="Arial"/>
                         </a:rPr>
-                        <a:t>UAT environment and smoke complete</a:t>
+                        <a:t>Security retest complete</a:t>
                       </a:r>
                     </a:p>
                   </a:txBody>
@@ -11662,7 +11822,7 @@
                           <a:ea typeface="Arial"/>
                           <a:cs typeface="Arial"/>
                         </a:rPr>
-                        <a:t>02 Feb 2027</a:t>
+                        <a:t>19 Feb 2027</a:t>
                       </a:r>
                     </a:p>
                   </a:txBody>
@@ -11685,87 +11845,7 @@
                   </a:tcPr>
                 </a:tc>
               </a:tr>
-              <a:tr h="419100">
-                <a:tc>
-                  <a:txBody>
-                    <a:bodyPr/>
-                    <a:lstStyle/>
-                    <a:p>
-                      <a:r>
-                        <a:rPr sz="1725">
-                          <a:solidFill>
-                            <a:srgbClr val="132B45"/>
-                          </a:solidFill>
-                          <a:latin typeface="Arial"/>
-                          <a:ea typeface="Arial"/>
-                          <a:cs typeface="Arial"/>
-                        </a:rPr>
-                        <a:t>AM UAT start</a:t>
-                      </a:r>
-                    </a:p>
-                  </a:txBody>
-                  <a:tcPr marL="114300" marR="114300" marT="28575" marB="28575" anchor="ctr">
-                    <a:lnL w="6668">
-                      <a:solidFill>
-                        <a:srgbClr val="DFE5EC"/>
-                      </a:solidFill>
-                      <a:prstDash val="solid"/>
-                    </a:lnL>
-                    <a:lnR w="6668">
-                      <a:solidFill>
-                        <a:srgbClr val="DFE5EC"/>
-                      </a:solidFill>
-                      <a:prstDash val="solid"/>
-                    </a:lnR>
-                    <a:lnB w="6668">
-                      <a:solidFill>
-                        <a:srgbClr val="DFE5EC"/>
-                      </a:solidFill>
-                      <a:prstDash val="solid"/>
-                    </a:lnB>
-                    <a:solidFill>
-                      <a:srgbClr val="FFFFFF"/>
-                    </a:solidFill>
-                  </a:tcPr>
-                </a:tc>
-                <a:tc>
-                  <a:txBody>
-                    <a:bodyPr/>
-                    <a:lstStyle/>
-                    <a:p>
-                      <a:r>
-                        <a:rPr sz="1725">
-                          <a:solidFill>
-                            <a:srgbClr val="132B45"/>
-                          </a:solidFill>
-                          <a:latin typeface="Arial"/>
-                          <a:ea typeface="Arial"/>
-                          <a:cs typeface="Arial"/>
-                        </a:rPr>
-                        <a:t>15 Feb 2027</a:t>
-                      </a:r>
-                    </a:p>
-                  </a:txBody>
-                  <a:tcPr marL="114300" marR="114300" marT="28575" marB="28575" anchor="ctr">
-                    <a:lnR w="6668">
-                      <a:solidFill>
-                        <a:srgbClr val="DFE5EC"/>
-                      </a:solidFill>
-                      <a:prstDash val="solid"/>
-                    </a:lnR>
-                    <a:lnB w="6668">
-                      <a:solidFill>
-                        <a:srgbClr val="DFE5EC"/>
-                      </a:solidFill>
-                      <a:prstDash val="solid"/>
-                    </a:lnB>
-                    <a:solidFill>
-                      <a:srgbClr val="FFFFFF"/>
-                    </a:solidFill>
-                  </a:tcPr>
-                </a:tc>
-              </a:tr>
-              <a:tr h="419100">
+              <a:tr h="389164">
                 <a:tc>
                   <a:txBody>
                     <a:bodyPr/>
@@ -11845,7 +11925,7 @@
                   </a:tcPr>
                 </a:tc>
               </a:tr>
-              <a:tr h="419100">
+              <a:tr h="389164">
                 <a:tc>
                   <a:txBody>
                     <a:bodyPr/>
@@ -11925,7 +12005,7 @@
                   </a:tcPr>
                 </a:tc>
               </a:tr>
-              <a:tr h="419100">
+              <a:tr h="389164">
                 <a:tc>
                   <a:txBody>
                     <a:bodyPr/>
@@ -12005,7 +12085,7 @@
                   </a:tcPr>
                 </a:tc>
               </a:tr>
-              <a:tr h="419100">
+              <a:tr h="389164">
                 <a:tc>
                   <a:txBody>
                     <a:bodyPr/>
@@ -12094,7 +12174,7 @@
           <p:cNvPr id="5" name="total-cost">
             <a:extLst xmlns:a="http://schemas.openxmlformats.org/drawingml/2006/main">
               <a:ext uri="{FF2B5EF4-FFF2-40B4-BE49-F238E27FC236}">
-                <a16:creationId xmlns:a16="http://schemas.microsoft.com/office/drawing/2014/main" id="{6A2B41AD-B5B2-495B-96C1-62CE72AD723A}"/>
+                <a16:creationId xmlns:a16="http://schemas.microsoft.com/office/drawing/2014/main" id="{E81A3D11-DDA0-452E-9ECA-762B319B569A}"/>
               </a:ext>
             </a:extLst>
           </p:cNvPr>
@@ -12152,7 +12232,7 @@
                 <a:ea typeface="Arial"/>
                 <a:cs typeface="Arial"/>
               </a:rPr>
-              <a:t>$136,584</a:t>
+              <a:t>$166,344</a:t>
             </a:r>
           </a:p>
         </p:txBody>
@@ -12162,7 +12242,7 @@
           <p:cNvPr id="6" name="basis">
             <a:extLst xmlns:a="http://schemas.openxmlformats.org/drawingml/2006/main">
               <a:ext uri="{FF2B5EF4-FFF2-40B4-BE49-F238E27FC236}">
-                <a16:creationId xmlns:a16="http://schemas.microsoft.com/office/drawing/2014/main" id="{E608CE35-48A6-417A-9486-A3E537EE0FC9}"/>
+                <a16:creationId xmlns:a16="http://schemas.microsoft.com/office/drawing/2014/main" id="{07C83BE7-E7B5-47B9-92A1-95AEC9ED2A72}"/>
               </a:ext>
             </a:extLst>
           </p:cNvPr>
@@ -12174,7 +12254,7 @@
         <p:spPr>
           <a:xfrm xmlns:a="http://schemas.openxmlformats.org/drawingml/2006/main">
             <a:off x="9620250" y="2819400"/>
-            <a:ext cx="4953000" cy="666750"/>
+            <a:ext cx="5000625" cy="381000"/>
           </a:xfrm>
           <a:prstGeom xmlns:a="http://schemas.openxmlformats.org/drawingml/2006/main" prst="rect">
             <a:avLst/>
@@ -12190,7 +12270,7 @@
           </a:bodyPr>
           <a:lstStyle xmlns:a="http://schemas.openxmlformats.org/drawingml/2006/main">
             <a:defPPr algn="l">
-              <a:defRPr sz="1875" b="0">
+              <a:defRPr sz="1800" b="0">
                 <a:solidFill>
                   <a:srgbClr val="56677A"/>
                 </a:solidFill>
@@ -12202,7 +12282,7 @@
           </a:lstStyle>
           <a:p xmlns:a="http://schemas.openxmlformats.org/drawingml/2006/main">
             <a:pPr algn="l">
-              <a:defRPr sz="1875" b="0">
+              <a:defRPr sz="1800" b="0">
                 <a:solidFill>
                   <a:srgbClr val="56677A"/>
                 </a:solidFill>
@@ -12212,7 +12292,7 @@
               </a:defRPr>
             </a:pPr>
             <a:r>
-              <a:rPr sz="1875" b="0">
+              <a:rPr sz="1800" b="0">
                 <a:solidFill>
                   <a:srgbClr val="56677A"/>
                 </a:solidFill>
@@ -12220,17 +12300,85 @@
                 <a:ea typeface="Arial"/>
                 <a:cs typeface="Arial"/>
               </a:rPr>
-              <a:t>379.4 scheduled person-days at USD 360/day</a:t>
+              <a:t>Labor: 420.4 person-days at $360/day</a:t>
+            </a:r>
+          </a:p>
+        </p:txBody>
+      </p:sp>
+      <p:sp>
+        <p:nvSpPr>
+          <p:cNvPr id="7" name="fixed-fee">
+            <a:extLst xmlns:a="http://schemas.openxmlformats.org/drawingml/2006/main">
+              <a:ext uri="{FF2B5EF4-FFF2-40B4-BE49-F238E27FC236}">
+                <a16:creationId xmlns:a16="http://schemas.microsoft.com/office/drawing/2014/main" id="{1B306ACF-22B2-4CDB-BC7B-96B65B6F9E15}"/>
+              </a:ext>
+            </a:extLst>
+          </p:cNvPr>
+          <p:cNvSpPr>
+            <a:spLocks xmlns:a="http://schemas.openxmlformats.org/drawingml/2006/main" noGrp="1"/>
+          </p:cNvSpPr>
+          <p:nvPr/>
+        </p:nvSpPr>
+        <p:spPr>
+          <a:xfrm xmlns:a="http://schemas.openxmlformats.org/drawingml/2006/main">
+            <a:off x="9620250" y="3238500"/>
+            <a:ext cx="5000625" cy="304800"/>
+          </a:xfrm>
+          <a:prstGeom xmlns:a="http://schemas.openxmlformats.org/drawingml/2006/main" prst="rect">
+            <a:avLst/>
+          </a:prstGeom>
+          <a:noFill xmlns:a="http://schemas.openxmlformats.org/drawingml/2006/main"/>
+          <a:ln xmlns:a="http://schemas.openxmlformats.org/drawingml/2006/main" w="0">
+            <a:noFill/>
+          </a:ln>
+        </p:spPr>
+        <p:txBody>
+          <a:bodyPr xmlns:a="http://schemas.openxmlformats.org/drawingml/2006/main" wrap="square" lIns="0" tIns="0" rIns="0" bIns="0" anchor="t">
+            <a:noAutofit/>
+          </a:bodyPr>
+          <a:lstStyle xmlns:a="http://schemas.openxmlformats.org/drawingml/2006/main">
+            <a:defPPr algn="l">
+              <a:defRPr sz="1800" b="0">
+                <a:solidFill>
+                  <a:srgbClr val="132B45"/>
+                </a:solidFill>
+                <a:latin typeface="Arial"/>
+                <a:ea typeface="Arial"/>
+                <a:cs typeface="Arial"/>
+              </a:defRPr>
+            </a:defPPr>
+          </a:lstStyle>
+          <a:p xmlns:a="http://schemas.openxmlformats.org/drawingml/2006/main">
+            <a:pPr algn="l">
+              <a:defRPr sz="1800" b="0">
+                <a:solidFill>
+                  <a:srgbClr val="132B45"/>
+                </a:solidFill>
+                <a:latin typeface="Arial"/>
+                <a:ea typeface="Arial"/>
+                <a:cs typeface="Arial"/>
+              </a:defRPr>
+            </a:pPr>
+            <a:r>
+              <a:rPr sz="1800" b="0">
+                <a:solidFill>
+                  <a:srgbClr val="132B45"/>
+                </a:solidFill>
+                <a:latin typeface="Arial"/>
+                <a:ea typeface="Arial"/>
+                <a:cs typeface="Arial"/>
+              </a:rPr>
+              <a:t>$15,000 fixed penetration-test fee</a:t>
             </a:r>
           </a:p>
         </p:txBody>
       </p:sp>
       <p:graphicFrame>
         <p:nvGraphicFramePr>
-          <p:cNvPr id="7" name="">
+          <p:cNvPr id="8" name="">
             <a:extLst xmlns:a="http://schemas.openxmlformats.org/drawingml/2006/main">
               <a:ext uri="{FF2B5EF4-FFF2-40B4-BE49-F238E27FC236}">
-                <a16:creationId xmlns:a16="http://schemas.microsoft.com/office/drawing/2014/main" id="{86B4C867-A682-402B-A1E0-84A88995B95E}"/>
+                <a16:creationId xmlns:a16="http://schemas.microsoft.com/office/drawing/2014/main" id="{7E56484A-E92C-4CF1-BD56-BFA6C186E5AC}"/>
               </a:ext>
             </a:extLst>
           </p:cNvPr>
@@ -12250,7 +12398,7 @@
                 <a:gridCol w="1000125"/>
                 <a:gridCol w="1952625"/>
               </a:tblGrid>
-              <a:tr h="400050">
+              <a:tr h="360045">
                 <a:tc>
                   <a:txBody>
                     <a:bodyPr/>
@@ -12269,7 +12417,7 @@
                       </a:r>
                     </a:p>
                   </a:txBody>
-                  <a:tcPr marL="114300" marR="114300" marT="28575" marB="28575" anchor="ctr">
+                  <a:tcPr marL="114300" marR="114300" marT="9525" marB="9525" anchor="ctr">
                     <a:lnL w="6668">
                       <a:solidFill>
                         <a:srgbClr val="DFE5EC"/>
@@ -12317,7 +12465,7 @@
                       </a:r>
                     </a:p>
                   </a:txBody>
-                  <a:tcPr marL="114300" marR="114300" marT="28575" marB="28575" anchor="ctr">
+                  <a:tcPr marL="114300" marR="114300" marT="9525" marB="9525" anchor="ctr">
                     <a:lnR w="6668">
                       <a:solidFill>
                         <a:srgbClr val="DFE5EC"/>
@@ -12359,7 +12507,7 @@
                       </a:r>
                     </a:p>
                   </a:txBody>
-                  <a:tcPr marL="114300" marR="114300" marT="28575" marB="28575" anchor="ctr">
+                  <a:tcPr marL="114300" marR="114300" marT="9525" marB="9525" anchor="ctr">
                     <a:lnR w="6668">
                       <a:solidFill>
                         <a:srgbClr val="DFE5EC"/>
@@ -12384,7 +12532,7 @@
                   </a:tcPr>
                 </a:tc>
               </a:tr>
-              <a:tr h="400050">
+              <a:tr h="360045">
                 <a:tc>
                   <a:txBody>
                     <a:bodyPr/>
@@ -12403,7 +12551,7 @@
                       </a:r>
                     </a:p>
                   </a:txBody>
-                  <a:tcPr marL="114300" marR="114300" marT="28575" marB="28575" anchor="ctr">
+                  <a:tcPr marL="114300" marR="114300" marT="9525" marB="9525" anchor="ctr">
                     <a:lnL w="6668">
                       <a:solidFill>
                         <a:srgbClr val="DFE5EC"/>
@@ -12445,7 +12593,7 @@
                       </a:r>
                     </a:p>
                   </a:txBody>
-                  <a:tcPr marL="114300" marR="114300" marT="28575" marB="28575" anchor="ctr">
+                  <a:tcPr marL="114300" marR="114300" marT="9525" marB="9525" anchor="ctr">
                     <a:lnR w="6668">
                       <a:solidFill>
                         <a:srgbClr val="DFE5EC"/>
@@ -12481,7 +12629,7 @@
                       </a:r>
                     </a:p>
                   </a:txBody>
-                  <a:tcPr marL="114300" marR="114300" marT="28575" marB="28575" anchor="ctr">
+                  <a:tcPr marL="114300" marR="114300" marT="9525" marB="9525" anchor="ctr">
                     <a:lnR w="6668">
                       <a:solidFill>
                         <a:srgbClr val="DFE5EC"/>
@@ -12500,7 +12648,7 @@
                   </a:tcPr>
                 </a:tc>
               </a:tr>
-              <a:tr h="400050">
+              <a:tr h="360045">
                 <a:tc>
                   <a:txBody>
                     <a:bodyPr/>
@@ -12519,7 +12667,7 @@
                       </a:r>
                     </a:p>
                   </a:txBody>
-                  <a:tcPr marL="114300" marR="114300" marT="28575" marB="28575" anchor="ctr">
+                  <a:tcPr marL="114300" marR="114300" marT="9525" marB="9525" anchor="ctr">
                     <a:lnL w="6668">
                       <a:solidFill>
                         <a:srgbClr val="DFE5EC"/>
@@ -12561,7 +12709,7 @@
                       </a:r>
                     </a:p>
                   </a:txBody>
-                  <a:tcPr marL="114300" marR="114300" marT="28575" marB="28575" anchor="ctr">
+                  <a:tcPr marL="114300" marR="114300" marT="9525" marB="9525" anchor="ctr">
                     <a:lnR w="6668">
                       <a:solidFill>
                         <a:srgbClr val="DFE5EC"/>
@@ -12597,7 +12745,7 @@
                       </a:r>
                     </a:p>
                   </a:txBody>
-                  <a:tcPr marL="114300" marR="114300" marT="28575" marB="28575" anchor="ctr">
+                  <a:tcPr marL="114300" marR="114300" marT="9525" marB="9525" anchor="ctr">
                     <a:lnR w="6668">
                       <a:solidFill>
                         <a:srgbClr val="DFE5EC"/>
@@ -12616,7 +12764,7 @@
                   </a:tcPr>
                 </a:tc>
               </a:tr>
-              <a:tr h="400050">
+              <a:tr h="360045">
                 <a:tc>
                   <a:txBody>
                     <a:bodyPr/>
@@ -12635,7 +12783,7 @@
                       </a:r>
                     </a:p>
                   </a:txBody>
-                  <a:tcPr marL="114300" marR="114300" marT="28575" marB="28575" anchor="ctr">
+                  <a:tcPr marL="114300" marR="114300" marT="9525" marB="9525" anchor="ctr">
                     <a:lnL w="6668">
                       <a:solidFill>
                         <a:srgbClr val="DFE5EC"/>
@@ -12677,7 +12825,7 @@
                       </a:r>
                     </a:p>
                   </a:txBody>
-                  <a:tcPr marL="114300" marR="114300" marT="28575" marB="28575" anchor="ctr">
+                  <a:tcPr marL="114300" marR="114300" marT="9525" marB="9525" anchor="ctr">
                     <a:lnR w="6668">
                       <a:solidFill>
                         <a:srgbClr val="DFE5EC"/>
@@ -12713,7 +12861,7 @@
                       </a:r>
                     </a:p>
                   </a:txBody>
-                  <a:tcPr marL="114300" marR="114300" marT="28575" marB="28575" anchor="ctr">
+                  <a:tcPr marL="114300" marR="114300" marT="9525" marB="9525" anchor="ctr">
                     <a:lnR w="6668">
                       <a:solidFill>
                         <a:srgbClr val="DFE5EC"/>
@@ -12732,7 +12880,7 @@
                   </a:tcPr>
                 </a:tc>
               </a:tr>
-              <a:tr h="400050">
+              <a:tr h="360045">
                 <a:tc>
                   <a:txBody>
                     <a:bodyPr/>
@@ -12751,7 +12899,7 @@
                       </a:r>
                     </a:p>
                   </a:txBody>
-                  <a:tcPr marL="114300" marR="114300" marT="28575" marB="28575" anchor="ctr">
+                  <a:tcPr marL="114300" marR="114300" marT="9525" marB="9525" anchor="ctr">
                     <a:lnL w="6668">
                       <a:solidFill>
                         <a:srgbClr val="DFE5EC"/>
@@ -12793,7 +12941,7 @@
                       </a:r>
                     </a:p>
                   </a:txBody>
-                  <a:tcPr marL="114300" marR="114300" marT="28575" marB="28575" anchor="ctr">
+                  <a:tcPr marL="114300" marR="114300" marT="9525" marB="9525" anchor="ctr">
                     <a:lnR w="6668">
                       <a:solidFill>
                         <a:srgbClr val="DFE5EC"/>
@@ -12829,7 +12977,7 @@
                       </a:r>
                     </a:p>
                   </a:txBody>
-                  <a:tcPr marL="114300" marR="114300" marT="28575" marB="28575" anchor="ctr">
+                  <a:tcPr marL="114300" marR="114300" marT="9525" marB="9525" anchor="ctr">
                     <a:lnR w="6668">
                       <a:solidFill>
                         <a:srgbClr val="DFE5EC"/>
@@ -12848,7 +12996,7 @@
                   </a:tcPr>
                 </a:tc>
               </a:tr>
-              <a:tr h="400050">
+              <a:tr h="360045">
                 <a:tc>
                   <a:txBody>
                     <a:bodyPr/>
@@ -12867,7 +13015,7 @@
                       </a:r>
                     </a:p>
                   </a:txBody>
-                  <a:tcPr marL="114300" marR="114300" marT="28575" marB="28575" anchor="ctr">
+                  <a:tcPr marL="114300" marR="114300" marT="9525" marB="9525" anchor="ctr">
                     <a:lnL w="6668">
                       <a:solidFill>
                         <a:srgbClr val="DFE5EC"/>
@@ -12909,7 +13057,7 @@
                       </a:r>
                     </a:p>
                   </a:txBody>
-                  <a:tcPr marL="114300" marR="114300" marT="28575" marB="28575" anchor="ctr">
+                  <a:tcPr marL="114300" marR="114300" marT="9525" marB="9525" anchor="ctr">
                     <a:lnR w="6668">
                       <a:solidFill>
                         <a:srgbClr val="DFE5EC"/>
@@ -12945,7 +13093,7 @@
                       </a:r>
                     </a:p>
                   </a:txBody>
-                  <a:tcPr marL="114300" marR="114300" marT="28575" marB="28575" anchor="ctr">
+                  <a:tcPr marL="114300" marR="114300" marT="9525" marB="9525" anchor="ctr">
                     <a:lnR w="6668">
                       <a:solidFill>
                         <a:srgbClr val="DFE5EC"/>
@@ -12964,7 +13112,7 @@
                   </a:tcPr>
                 </a:tc>
               </a:tr>
-              <a:tr h="400050">
+              <a:tr h="360045">
                 <a:tc>
                   <a:txBody>
                     <a:bodyPr/>
@@ -12983,7 +13131,7 @@
                       </a:r>
                     </a:p>
                   </a:txBody>
-                  <a:tcPr marL="114300" marR="114300" marT="28575" marB="28575" anchor="ctr">
+                  <a:tcPr marL="114300" marR="114300" marT="9525" marB="9525" anchor="ctr">
                     <a:lnL w="6668">
                       <a:solidFill>
                         <a:srgbClr val="DFE5EC"/>
@@ -13025,7 +13173,7 @@
                       </a:r>
                     </a:p>
                   </a:txBody>
-                  <a:tcPr marL="114300" marR="114300" marT="28575" marB="28575" anchor="ctr">
+                  <a:tcPr marL="114300" marR="114300" marT="9525" marB="9525" anchor="ctr">
                     <a:lnR w="6668">
                       <a:solidFill>
                         <a:srgbClr val="DFE5EC"/>
@@ -13061,7 +13209,7 @@
                       </a:r>
                     </a:p>
                   </a:txBody>
-                  <a:tcPr marL="114300" marR="114300" marT="28575" marB="28575" anchor="ctr">
+                  <a:tcPr marL="114300" marR="114300" marT="9525" marB="9525" anchor="ctr">
                     <a:lnR w="6668">
                       <a:solidFill>
                         <a:srgbClr val="DFE5EC"/>
@@ -13080,7 +13228,7 @@
                   </a:tcPr>
                 </a:tc>
               </a:tr>
-              <a:tr h="400050">
+              <a:tr h="360045">
                 <a:tc>
                   <a:txBody>
                     <a:bodyPr/>
@@ -13099,7 +13247,7 @@
                       </a:r>
                     </a:p>
                   </a:txBody>
-                  <a:tcPr marL="114300" marR="114300" marT="28575" marB="28575" anchor="ctr">
+                  <a:tcPr marL="114300" marR="114300" marT="9525" marB="9525" anchor="ctr">
                     <a:lnL w="6668">
                       <a:solidFill>
                         <a:srgbClr val="DFE5EC"/>
@@ -13141,7 +13289,7 @@
                       </a:r>
                     </a:p>
                   </a:txBody>
-                  <a:tcPr marL="114300" marR="114300" marT="28575" marB="28575" anchor="ctr">
+                  <a:tcPr marL="114300" marR="114300" marT="9525" marB="9525" anchor="ctr">
                     <a:lnR w="6668">
                       <a:solidFill>
                         <a:srgbClr val="DFE5EC"/>
@@ -13177,7 +13325,7 @@
                       </a:r>
                     </a:p>
                   </a:txBody>
-                  <a:tcPr marL="114300" marR="114300" marT="28575" marB="28575" anchor="ctr">
+                  <a:tcPr marL="114300" marR="114300" marT="9525" marB="9525" anchor="ctr">
                     <a:lnR w="6668">
                       <a:solidFill>
                         <a:srgbClr val="DFE5EC"/>
@@ -13196,7 +13344,123 @@
                   </a:tcPr>
                 </a:tc>
               </a:tr>
-              <a:tr h="400050">
+              <a:tr h="360045">
+                <a:tc>
+                  <a:txBody>
+                    <a:bodyPr/>
+                    <a:lstStyle/>
+                    <a:p>
+                      <a:r>
+                        <a:rPr sz="1725">
+                          <a:solidFill>
+                            <a:srgbClr val="132B45"/>
+                          </a:solidFill>
+                          <a:latin typeface="Arial"/>
+                          <a:ea typeface="Arial"/>
+                          <a:cs typeface="Arial"/>
+                        </a:rPr>
+                        <a:t>PM</a:t>
+                      </a:r>
+                    </a:p>
+                  </a:txBody>
+                  <a:tcPr marL="114300" marR="114300" marT="9525" marB="9525" anchor="ctr">
+                    <a:lnL w="6668">
+                      <a:solidFill>
+                        <a:srgbClr val="DFE5EC"/>
+                      </a:solidFill>
+                      <a:prstDash val="solid"/>
+                    </a:lnL>
+                    <a:lnR w="6668">
+                      <a:solidFill>
+                        <a:srgbClr val="DFE5EC"/>
+                      </a:solidFill>
+                      <a:prstDash val="solid"/>
+                    </a:lnR>
+                    <a:lnB w="6668">
+                      <a:solidFill>
+                        <a:srgbClr val="DFE5EC"/>
+                      </a:solidFill>
+                      <a:prstDash val="solid"/>
+                    </a:lnB>
+                    <a:solidFill>
+                      <a:srgbClr val="FFFFFF"/>
+                    </a:solidFill>
+                  </a:tcPr>
+                </a:tc>
+                <a:tc>
+                  <a:txBody>
+                    <a:bodyPr/>
+                    <a:lstStyle/>
+                    <a:p>
+                      <a:r>
+                        <a:rPr sz="1725">
+                          <a:solidFill>
+                            <a:srgbClr val="132B45"/>
+                          </a:solidFill>
+                          <a:latin typeface="Arial"/>
+                          <a:ea typeface="Arial"/>
+                          <a:cs typeface="Arial"/>
+                        </a:rPr>
+                        <a:t>41.0</a:t>
+                      </a:r>
+                    </a:p>
+                  </a:txBody>
+                  <a:tcPr marL="114300" marR="114300" marT="9525" marB="9525" anchor="ctr">
+                    <a:lnR w="6668">
+                      <a:solidFill>
+                        <a:srgbClr val="DFE5EC"/>
+                      </a:solidFill>
+                      <a:prstDash val="solid"/>
+                    </a:lnR>
+                    <a:lnB w="6668">
+                      <a:solidFill>
+                        <a:srgbClr val="DFE5EC"/>
+                      </a:solidFill>
+                      <a:prstDash val="solid"/>
+                    </a:lnB>
+                    <a:solidFill>
+                      <a:srgbClr val="FFFFFF"/>
+                    </a:solidFill>
+                  </a:tcPr>
+                </a:tc>
+                <a:tc>
+                  <a:txBody>
+                    <a:bodyPr/>
+                    <a:lstStyle/>
+                    <a:p>
+                      <a:r>
+                        <a:rPr sz="1725">
+                          <a:solidFill>
+                            <a:srgbClr val="132B45"/>
+                          </a:solidFill>
+                          <a:latin typeface="Arial"/>
+                          <a:ea typeface="Arial"/>
+                          <a:cs typeface="Arial"/>
+                        </a:rPr>
+                        <a:t>$14,760</a:t>
+                      </a:r>
+                    </a:p>
+                  </a:txBody>
+                  <a:tcPr marL="114300" marR="114300" marT="9525" marB="9525" anchor="ctr">
+                    <a:lnR w="6668">
+                      <a:solidFill>
+                        <a:srgbClr val="DFE5EC"/>
+                      </a:solidFill>
+                      <a:prstDash val="solid"/>
+                    </a:lnR>
+                    <a:lnB w="6668">
+                      <a:solidFill>
+                        <a:srgbClr val="DFE5EC"/>
+                      </a:solidFill>
+                      <a:prstDash val="solid"/>
+                    </a:lnB>
+                    <a:solidFill>
+                      <a:srgbClr val="FFFFFF"/>
+                    </a:solidFill>
+                  </a:tcPr>
+                </a:tc>
+              </a:tr>
+              <a:tr h="360045">
                 <a:tc>
                   <a:txBody>
                     <a:bodyPr/>
@@ -13211,11 +13475,11 @@
                           <a:ea typeface="Arial"/>
                           <a:cs typeface="Arial"/>
                         </a:rPr>
-                        <a:t>TOTAL</a:t>
+                        <a:t>LABOR TOTAL</a:t>
                       </a:r>
                     </a:p>
                   </a:txBody>
-                  <a:tcPr marL="114300" marR="114300" marT="28575" marB="28575" anchor="ctr">
+                  <a:tcPr marL="114300" marR="114300" marT="9525" marB="9525" anchor="ctr">
                     <a:lnL w="6668">
                       <a:solidFill>
                         <a:srgbClr val="DFE5EC"/>
@@ -13253,11 +13517,11 @@
                           <a:ea typeface="Arial"/>
                           <a:cs typeface="Arial"/>
                         </a:rPr>
-                        <a:t>379.4</a:t>
+                        <a:t>420.4</a:t>
                       </a:r>
                     </a:p>
                   </a:txBody>
-                  <a:tcPr marL="114300" marR="114300" marT="28575" marB="28575" anchor="ctr">
+                  <a:tcPr marL="114300" marR="114300" marT="9525" marB="9525" anchor="ctr">
                     <a:lnR w="6668">
                       <a:solidFill>
                         <a:srgbClr val="DFE5EC"/>
@@ -13289,11 +13553,11 @@
                           <a:ea typeface="Arial"/>
                           <a:cs typeface="Arial"/>
                         </a:rPr>
-                        <a:t>$136,584</a:t>
+                        <a:t>$151,344</a:t>
                       </a:r>
                     </a:p>
                   </a:txBody>
-                  <a:tcPr marL="114300" marR="114300" marT="28575" marB="28575" anchor="ctr">
+                  <a:tcPr marL="114300" marR="114300" marT="9525" marB="9525" anchor="ctr">
                     <a:lnR w="6668">
                       <a:solidFill>
                         <a:srgbClr val="DFE5EC"/>
@@ -13318,10 +13582,10 @@
       </p:graphicFrame>
       <p:sp>
         <p:nvSpPr>
-          <p:cNvPr id="8" name="leave">
+          <p:cNvPr id="9" name="budget-split">
             <a:extLst xmlns:a="http://schemas.openxmlformats.org/drawingml/2006/main">
               <a:ext uri="{FF2B5EF4-FFF2-40B4-BE49-F238E27FC236}">
-                <a16:creationId xmlns:a16="http://schemas.microsoft.com/office/drawing/2014/main" id="{F30D65FC-B0F9-401F-A34E-361AB90DD000}"/>
+                <a16:creationId xmlns:a16="http://schemas.microsoft.com/office/drawing/2014/main" id="{2759E70C-2D50-48B2-81D4-CC58A61BB816}"/>
               </a:ext>
             </a:extLst>
           </p:cNvPr>
@@ -13332,8 +13596,8 @@
         </p:nvSpPr>
         <p:spPr>
           <a:xfrm xmlns:a="http://schemas.openxmlformats.org/drawingml/2006/main">
-            <a:off x="609600" y="7629525"/>
-            <a:ext cx="14001750" cy="333375"/>
+            <a:off x="9620250" y="7362825"/>
+            <a:ext cx="5000625" cy="266700"/>
           </a:xfrm>
           <a:prstGeom xmlns:a="http://schemas.openxmlformats.org/drawingml/2006/main" prst="rect">
             <a:avLst/>
@@ -13349,9 +13613,9 @@
           </a:bodyPr>
           <a:lstStyle xmlns:a="http://schemas.openxmlformats.org/drawingml/2006/main">
             <a:defPPr algn="l">
-              <a:defRPr sz="1650" b="0">
-                <a:solidFill>
-                  <a:srgbClr val="132B45"/>
+              <a:defRPr sz="1575" b="1">
+                <a:solidFill>
+                  <a:srgbClr val="2563EB"/>
                 </a:solidFill>
                 <a:latin typeface="Arial"/>
                 <a:ea typeface="Arial"/>
@@ -13361,9 +13625,9 @@
           </a:lstStyle>
           <a:p xmlns:a="http://schemas.openxmlformats.org/drawingml/2006/main">
             <a:pPr algn="l">
-              <a:defRPr sz="1650" b="0">
-                <a:solidFill>
-                  <a:srgbClr val="132B45"/>
+              <a:defRPr sz="1575" b="1">
+                <a:solidFill>
+                  <a:srgbClr val="2563EB"/>
                 </a:solidFill>
                 <a:latin typeface="Arial"/>
                 <a:ea typeface="Arial"/>
@@ -13371,25 +13635,25 @@
               </a:defRPr>
             </a:pPr>
             <a:r>
-              <a:rPr sz="1650" b="0">
-                <a:solidFill>
-                  <a:srgbClr val="132B45"/>
-                </a:solidFill>
-                <a:latin typeface="Arial"/>
-                <a:ea typeface="Arial"/>
-                <a:cs typeface="Arial"/>
-              </a:rPr>
-              <a:t>Feb 3-12 leave excluded. UAT has 8 workdays. Production depends on Feb 24 signoff and Feb 25 Go decision.</a:t>
+              <a:rPr sz="1575" b="1">
+                <a:solidFill>
+                  <a:srgbClr val="2563EB"/>
+                </a:solidFill>
+                <a:latin typeface="Arial"/>
+                <a:ea typeface="Arial"/>
+                <a:cs typeface="Arial"/>
+              </a:rPr>
+              <a:t>To 31 Jan: $138,300    From Feb: $28,044</a:t>
             </a:r>
           </a:p>
         </p:txBody>
       </p:sp>
       <p:sp>
         <p:nvSpPr>
-          <p:cNvPr id="9" name="cost-exclusion">
+          <p:cNvPr id="10" name="leave">
             <a:extLst xmlns:a="http://schemas.openxmlformats.org/drawingml/2006/main">
               <a:ext uri="{FF2B5EF4-FFF2-40B4-BE49-F238E27FC236}">
-                <a16:creationId xmlns:a16="http://schemas.microsoft.com/office/drawing/2014/main" id="{2219B9AE-24B3-46C3-844B-2CC6D4847D47}"/>
+                <a16:creationId xmlns:a16="http://schemas.microsoft.com/office/drawing/2014/main" id="{629F54EA-A081-45E0-AA4D-45B3777DF926}"/>
               </a:ext>
             </a:extLst>
           </p:cNvPr>
@@ -13400,8 +13664,8 @@
         </p:nvSpPr>
         <p:spPr>
           <a:xfrm xmlns:a="http://schemas.openxmlformats.org/drawingml/2006/main">
-            <a:off x="609600" y="8010525"/>
-            <a:ext cx="12954000" cy="304800"/>
+            <a:off x="609600" y="7686675"/>
+            <a:ext cx="14001750" cy="285750"/>
           </a:xfrm>
           <a:prstGeom xmlns:a="http://schemas.openxmlformats.org/drawingml/2006/main" prst="rect">
             <a:avLst/>
@@ -13419,7 +13683,7 @@
             <a:defPPr algn="l">
               <a:defRPr sz="1575" b="0">
                 <a:solidFill>
-                  <a:srgbClr val="56677A"/>
+                  <a:srgbClr val="132B45"/>
                 </a:solidFill>
                 <a:latin typeface="Arial"/>
                 <a:ea typeface="Arial"/>
@@ -13431,12 +13695,80 @@
             <a:pPr algn="l">
               <a:defRPr sz="1575" b="0">
                 <a:solidFill>
+                  <a:srgbClr val="132B45"/>
+                </a:solidFill>
+                <a:latin typeface="Arial"/>
+                <a:ea typeface="Arial"/>
+                <a:cs typeface="Arial"/>
+              </a:defRPr>
+            </a:pPr>
+            <a:r>
+              <a:rPr sz="1575" b="0">
+                <a:solidFill>
+                  <a:srgbClr val="132B45"/>
+                </a:solidFill>
+                <a:latin typeface="Arial"/>
+                <a:ea typeface="Arial"/>
+                <a:cs typeface="Arial"/>
+              </a:rPr>
+              <a:t>Potential-user UAT Jan 18-Feb 24: 20 workdays, excluding Feb 3-12 leave. PM: 0.5 day/workday across 82 days.</a:t>
+            </a:r>
+          </a:p>
+        </p:txBody>
+      </p:sp>
+      <p:sp>
+        <p:nvSpPr>
+          <p:cNvPr id="11" name="cost-exclusion">
+            <a:extLst xmlns:a="http://schemas.openxmlformats.org/drawingml/2006/main">
+              <a:ext uri="{FF2B5EF4-FFF2-40B4-BE49-F238E27FC236}">
+                <a16:creationId xmlns:a16="http://schemas.microsoft.com/office/drawing/2014/main" id="{5CA47891-F5AE-4D0E-9BDE-67A3D9CB7183}"/>
+              </a:ext>
+            </a:extLst>
+          </p:cNvPr>
+          <p:cNvSpPr>
+            <a:spLocks xmlns:a="http://schemas.openxmlformats.org/drawingml/2006/main" noGrp="1"/>
+          </p:cNvSpPr>
+          <p:nvPr/>
+        </p:nvSpPr>
+        <p:spPr>
+          <a:xfrm xmlns:a="http://schemas.openxmlformats.org/drawingml/2006/main">
+            <a:off x="609600" y="8067675"/>
+            <a:ext cx="12954000" cy="266700"/>
+          </a:xfrm>
+          <a:prstGeom xmlns:a="http://schemas.openxmlformats.org/drawingml/2006/main" prst="rect">
+            <a:avLst/>
+          </a:prstGeom>
+          <a:noFill xmlns:a="http://schemas.openxmlformats.org/drawingml/2006/main"/>
+          <a:ln xmlns:a="http://schemas.openxmlformats.org/drawingml/2006/main" w="0">
+            <a:noFill/>
+          </a:ln>
+        </p:spPr>
+        <p:txBody>
+          <a:bodyPr xmlns:a="http://schemas.openxmlformats.org/drawingml/2006/main" wrap="square" lIns="0" tIns="0" rIns="0" bIns="0" anchor="t">
+            <a:noAutofit/>
+          </a:bodyPr>
+          <a:lstStyle xmlns:a="http://schemas.openxmlformats.org/drawingml/2006/main">
+            <a:defPPr algn="l">
+              <a:defRPr sz="1575" b="0">
+                <a:solidFill>
                   <a:srgbClr val="56677A"/>
                 </a:solidFill>
                 <a:latin typeface="Arial"/>
                 <a:ea typeface="Arial"/>
                 <a:cs typeface="Arial"/>
               </a:defRPr>
+            </a:defPPr>
+          </a:lstStyle>
+          <a:p xmlns:a="http://schemas.openxmlformats.org/drawingml/2006/main">
+            <a:pPr algn="l">
+              <a:defRPr sz="1575" b="0">
+                <a:solidFill>
+                  <a:srgbClr val="56677A"/>
+                </a:solidFill>
+                <a:latin typeface="Arial"/>
+                <a:ea typeface="Arial"/>
+                <a:cs typeface="Arial"/>
+              </a:defRPr>
             </a:pPr>
             <a:r>
               <a:rPr sz="1575" b="0">
@@ -13447,7 +13779,7 @@
                 <a:ea typeface="Arial"/>
                 <a:cs typeface="Arial"/>
               </a:rPr>
-              <a:t>Labor estimate excludes Azure, model consumption, external IT/AM time and overhead. Friday rollout requires staffed on-call coverage.</a:t>
+              <a:t>$15,000 pen test belongs to January budget. Excludes Azure/model usage, unpriced business-user time and overhead.</a:t>
             </a:r>
           </a:p>
         </p:txBody>
@@ -13455,7 +13787,7 @@
     </p:spTree>
     <p:extLst>
       <p:ext uri="{BB962C8B-B14F-4D97-AF65-F5344CB8AC3E}">
-        <p14:creationId xmlns:p14="http://schemas.microsoft.com/office/powerpoint/2010/main" val="2074191942"/>
+        <p14:creationId xmlns:p14="http://schemas.microsoft.com/office/powerpoint/2010/main" val="1022252170"/>
       </p:ext>
     </p:extLst>
   </p:cSld>

</xml_diff>